<commit_message>
deleted last hidden slide, changes font size on 1 slide
</commit_message>
<xml_diff>
--- a/Slides/Module 13 Security.pptx
+++ b/Slides/Module 13 Security.pptx
@@ -6,7 +6,7 @@
     <p:sldMasterId id="2147483675" r:id="rId2"/>
   </p:sldMasterIdLst>
   <p:notesMasterIdLst>
-    <p:notesMasterId r:id="rId48"/>
+    <p:notesMasterId r:id="rId47"/>
   </p:notesMasterIdLst>
   <p:sldIdLst>
     <p:sldId id="342" r:id="rId3"/>
@@ -52,8 +52,7 @@
     <p:sldId id="616" r:id="rId43"/>
     <p:sldId id="392" r:id="rId44"/>
     <p:sldId id="391" r:id="rId45"/>
-    <p:sldId id="341" r:id="rId46"/>
-    <p:sldId id="343" r:id="rId47"/>
+    <p:sldId id="343" r:id="rId46"/>
   </p:sldIdLst>
   <p:sldSz cx="12192000" cy="6858000"/>
   <p:notesSz cx="6858000" cy="9144000"/>
@@ -580,7 +579,7 @@
           <a:p>
             <a:fld id="{7C7E5181-6CF5-45F7-A87A-E0E0B1FD7549}" type="datetimeFigureOut">
               <a:rPr lang="en-US" smtClean="0"/>
-              <a:t>10/10/2026</a:t>
+              <a:t>10/20/2026</a:t>
             </a:fld>
             <a:endParaRPr lang="en-US" dirty="0"/>
           </a:p>
@@ -4355,106 +4354,6 @@
             <p:ph type="sldImg"/>
           </p:nvPr>
         </p:nvSpPr>
-        <p:spPr/>
-        <p:txBody>
-          <a:bodyPr/>
-          <a:lstStyle/>
-          <a:p>
-            <a:endParaRPr lang="en-US"/>
-          </a:p>
-        </p:txBody>
-      </p:sp>
-      <p:sp>
-        <p:nvSpPr>
-          <p:cNvPr id="3" name="Notes Placeholder 2"/>
-          <p:cNvSpPr>
-            <a:spLocks noGrp="1"/>
-          </p:cNvSpPr>
-          <p:nvPr>
-            <p:ph type="body" idx="1"/>
-          </p:nvPr>
-        </p:nvSpPr>
-        <p:spPr/>
-        <p:txBody>
-          <a:bodyPr/>
-          <a:lstStyle/>
-          <a:p>
-            <a:r>
-              <a:rPr lang="en-US" dirty="0"/>
-              <a:t>&lt;read slide&gt;</a:t>
-            </a:r>
-          </a:p>
-          <a:p>
-            <a:r>
-              <a:rPr lang="en-US" dirty="0"/>
-              <a:t>Your developers will be more conscious of security issues if they discuss them on a regular basis during their ordinary workflow.</a:t>
-            </a:r>
-          </a:p>
-        </p:txBody>
-      </p:sp>
-      <p:sp>
-        <p:nvSpPr>
-          <p:cNvPr id="4" name="Slide Number Placeholder 3"/>
-          <p:cNvSpPr>
-            <a:spLocks noGrp="1"/>
-          </p:cNvSpPr>
-          <p:nvPr>
-            <p:ph type="sldNum" sz="quarter" idx="5"/>
-          </p:nvPr>
-        </p:nvSpPr>
-        <p:spPr/>
-        <p:txBody>
-          <a:bodyPr/>
-          <a:lstStyle/>
-          <a:p>
-            <a:fld id="{07937F07-1250-4CCE-B198-1B2887014F41}" type="slidenum">
-              <a:rPr lang="en-US" smtClean="0"/>
-              <a:t>44</a:t>
-            </a:fld>
-            <a:endParaRPr lang="en-US"/>
-          </a:p>
-        </p:txBody>
-      </p:sp>
-    </p:spTree>
-    <p:extLst>
-      <p:ext uri="{BB962C8B-B14F-4D97-AF65-F5344CB8AC3E}">
-        <p14:creationId xmlns:p14="http://schemas.microsoft.com/office/powerpoint/2010/main" val="603226819"/>
-      </p:ext>
-    </p:extLst>
-  </p:cSld>
-  <p:clrMapOvr>
-    <a:masterClrMapping/>
-  </p:clrMapOvr>
-</p:notes>
-</file>
-
-<file path=ppt/notesSlides/notesSlide37.xml><?xml version="1.0" encoding="utf-8"?>
-<p:notes xmlns:a="http://schemas.openxmlformats.org/drawingml/2006/main" xmlns:r="http://schemas.openxmlformats.org/officeDocument/2006/relationships" xmlns:p="http://schemas.openxmlformats.org/presentationml/2006/main">
-  <p:cSld>
-    <p:spTree>
-      <p:nvGrpSpPr>
-        <p:cNvPr id="1" name=""/>
-        <p:cNvGrpSpPr/>
-        <p:nvPr/>
-      </p:nvGrpSpPr>
-      <p:grpSpPr>
-        <a:xfrm>
-          <a:off x="0" y="0"/>
-          <a:ext cx="0" cy="0"/>
-          <a:chOff x="0" y="0"/>
-          <a:chExt cx="0" cy="0"/>
-        </a:xfrm>
-      </p:grpSpPr>
-      <p:sp>
-        <p:nvSpPr>
-          <p:cNvPr id="2" name="Slide Image Placeholder 1"/>
-          <p:cNvSpPr>
-            <a:spLocks noGrp="1" noRot="1" noChangeAspect="1"/>
-          </p:cNvSpPr>
-          <p:nvPr>
-            <p:ph type="sldImg"/>
-          </p:nvPr>
-        </p:nvSpPr>
         <p:spPr>
           <a:xfrm>
             <a:off x="381000" y="685800"/>
@@ -5331,7 +5230,7 @@
           <a:p>
             <a:fld id="{5D2A64DE-480B-420F-9649-4F8E696E08E0}" type="datetime1">
               <a:rPr lang="en-US" smtClean="0"/>
-              <a:t>10/10/2026</a:t>
+              <a:t>10/20/2026</a:t>
             </a:fld>
             <a:endParaRPr lang="en-US" dirty="0"/>
           </a:p>
@@ -5453,7 +5352,7 @@
           </a:prstGeom>
           <a:extLst>
             <a:ext uri="{C572A759-6A51-4108-AA02-DFA0A04FC94B}">
-              <ma14:wrappingTextBoxFlag xmlns="" xmlns:m="http://schemas.openxmlformats.org/officeDocument/2006/math" xmlns:a14="http://schemas.microsoft.com/office/drawing/2010/main" xmlns:ma14="http://schemas.microsoft.com/office/mac/drawingml/2011/main" val="1"/>
+              <ma14:wrappingTextBoxFlag xmlns:ma14="http://schemas.microsoft.com/office/mac/drawingml/2011/main" xmlns:a14="http://schemas.microsoft.com/office/drawing/2010/main" xmlns:m="http://schemas.openxmlformats.org/officeDocument/2006/math" xmlns="" val="1"/>
             </a:ext>
           </a:extLst>
         </p:spPr>
@@ -5744,7 +5643,7 @@
           <a:p>
             <a:fld id="{EA476A42-A091-4468-A075-64A31BE59948}" type="datetime1">
               <a:rPr lang="en-US" smtClean="0"/>
-              <a:t>10/10/2026</a:t>
+              <a:t>10/20/2026</a:t>
             </a:fld>
             <a:endParaRPr lang="en-US" dirty="0"/>
           </a:p>
@@ -5942,7 +5841,7 @@
           <a:p>
             <a:fld id="{0D3616D0-8311-4107-9726-6B805E7D05BA}" type="datetime1">
               <a:rPr lang="en-US" smtClean="0"/>
-              <a:t>10/10/2026</a:t>
+              <a:t>10/20/2026</a:t>
             </a:fld>
             <a:endParaRPr lang="en-US" dirty="0"/>
           </a:p>
@@ -6150,7 +6049,7 @@
           <a:p>
             <a:fld id="{3BC2557A-5C88-417A-A763-5AC779462A5F}" type="datetime1">
               <a:rPr lang="en-US" smtClean="0"/>
-              <a:t>10/10/2026</a:t>
+              <a:t>10/20/2026</a:t>
             </a:fld>
             <a:endParaRPr lang="en-US" dirty="0"/>
           </a:p>
@@ -7109,7 +7008,7 @@
           <a:p>
             <a:fld id="{5D2A64DE-480B-420F-9649-4F8E696E08E0}" type="datetime1">
               <a:rPr lang="en-US" smtClean="0"/>
-              <a:t>10/10/2026</a:t>
+              <a:t>10/20/2026</a:t>
             </a:fld>
             <a:endParaRPr lang="en-US" dirty="0"/>
           </a:p>
@@ -7529,7 +7428,7 @@
           <a:p>
             <a:fld id="{07C7BFD4-467E-4EDE-93EA-052F5B39A4E5}" type="datetime1">
               <a:rPr lang="en-US" smtClean="0"/>
-              <a:t>10/10/2026</a:t>
+              <a:t>10/20/2026</a:t>
             </a:fld>
             <a:endParaRPr lang="en-US" dirty="0"/>
           </a:p>
@@ -7779,7 +7678,7 @@
           <a:p>
             <a:fld id="{07C7BFD4-467E-4EDE-93EA-052F5B39A4E5}" type="datetime1">
               <a:rPr lang="en-US" smtClean="0"/>
-              <a:t>10/10/2026</a:t>
+              <a:t>10/20/2026</a:t>
             </a:fld>
             <a:endParaRPr lang="en-US" dirty="0"/>
           </a:p>
@@ -7928,7 +7827,7 @@
           <a:p>
             <a:fld id="{109E55A0-C911-4F03-82FC-7E5926047D46}" type="datetime1">
               <a:rPr lang="en-US" smtClean="0"/>
-              <a:t>10/10/2026</a:t>
+              <a:t>10/20/2026</a:t>
             </a:fld>
             <a:endParaRPr lang="en-US" dirty="0"/>
           </a:p>
@@ -8116,7 +8015,7 @@
           <a:p>
             <a:fld id="{2B7B7EE0-7771-4CD5-9B2B-3550753A54A1}" type="datetime1">
               <a:rPr lang="en-US" smtClean="0"/>
-              <a:t>10/10/2026</a:t>
+              <a:t>10/20/2026</a:t>
             </a:fld>
             <a:endParaRPr lang="en-US" dirty="0"/>
           </a:p>
@@ -8330,7 +8229,7 @@
           <a:p>
             <a:fld id="{07C7BFD4-467E-4EDE-93EA-052F5B39A4E5}" type="datetime1">
               <a:rPr lang="en-US" smtClean="0"/>
-              <a:t>10/10/2026</a:t>
+              <a:t>10/20/2026</a:t>
             </a:fld>
             <a:endParaRPr lang="en-US" dirty="0"/>
           </a:p>
@@ -8518,7 +8417,7 @@
           <a:p>
             <a:fld id="{109E55A0-C911-4F03-82FC-7E5926047D46}" type="datetime1">
               <a:rPr lang="en-US" smtClean="0"/>
-              <a:t>10/10/2026</a:t>
+              <a:t>10/20/2026</a:t>
             </a:fld>
             <a:endParaRPr lang="en-US" dirty="0"/>
           </a:p>
@@ -8831,7 +8730,7 @@
           <a:p>
             <a:fld id="{A533CBE2-D5BE-47AC-ADC2-9CDFC1D0CF90}" type="datetime1">
               <a:rPr lang="en-US" smtClean="0"/>
-              <a:t>10/10/2026</a:t>
+              <a:t>10/20/2026</a:t>
             </a:fld>
             <a:endParaRPr lang="en-US" dirty="0"/>
           </a:p>
@@ -9132,7 +9031,7 @@
           <a:p>
             <a:fld id="{39B7EDB1-CE74-4951-85A2-0B01C2128E28}" type="datetime1">
               <a:rPr lang="en-US" smtClean="0"/>
-              <a:t>10/10/2026</a:t>
+              <a:t>10/20/2026</a:t>
             </a:fld>
             <a:endParaRPr lang="en-US" dirty="0"/>
           </a:p>
@@ -9580,7 +9479,7 @@
           <a:p>
             <a:fld id="{2BC7EB92-A5C2-4807-A9DC-9EDE6CBFB241}" type="datetime1">
               <a:rPr lang="en-US" smtClean="0"/>
-              <a:t>10/10/2026</a:t>
+              <a:t>10/20/2026</a:t>
             </a:fld>
             <a:endParaRPr lang="en-US" dirty="0"/>
           </a:p>
@@ -9693,7 +9592,7 @@
           <a:p>
             <a:fld id="{2B7B7EE0-7771-4CD5-9B2B-3550753A54A1}" type="datetime1">
               <a:rPr lang="en-US" smtClean="0"/>
-              <a:t>10/10/2026</a:t>
+              <a:t>10/20/2026</a:t>
             </a:fld>
             <a:endParaRPr lang="en-US" dirty="0"/>
           </a:p>
@@ -10004,7 +9903,7 @@
           <a:p>
             <a:fld id="{F8B318B3-0E87-4416-A9B8-D891968C2727}" type="datetime1">
               <a:rPr lang="en-US" smtClean="0"/>
-              <a:t>10/10/2026</a:t>
+              <a:t>10/20/2026</a:t>
             </a:fld>
             <a:endParaRPr lang="en-US" dirty="0"/>
           </a:p>
@@ -10245,7 +10144,7 @@
           <a:p>
             <a:fld id="{54D997E8-DDEE-43F1-8D9B-F8A1E11DE488}" type="datetime1">
               <a:rPr lang="en-US" smtClean="0"/>
-              <a:t>10/10/2026</a:t>
+              <a:t>10/20/2026</a:t>
             </a:fld>
             <a:endParaRPr lang="en-US" dirty="0"/>
           </a:p>
@@ -10820,7 +10719,7 @@
           <a:p>
             <a:fld id="{54D997E8-DDEE-43F1-8D9B-F8A1E11DE488}" type="datetime1">
               <a:rPr lang="en-US" smtClean="0"/>
-              <a:t>10/10/2026</a:t>
+              <a:t>10/20/2026</a:t>
             </a:fld>
             <a:endParaRPr lang="en-US" dirty="0"/>
           </a:p>
@@ -11387,7 +11286,7 @@
           </a:prstGeom>
           <a:extLst>
             <a:ext uri="{C572A759-6A51-4108-AA02-DFA0A04FC94B}">
-              <ma14:wrappingTextBoxFlag xmlns:ma14="http://schemas.microsoft.com/office/mac/drawingml/2011/main" xmlns:a14="http://schemas.microsoft.com/office/drawing/2010/main" xmlns:m="http://schemas.openxmlformats.org/officeDocument/2006/math" xmlns="" val="1"/>
+              <ma14:wrappingTextBoxFlag xmlns="" xmlns:m="http://schemas.openxmlformats.org/officeDocument/2006/math" xmlns:a14="http://schemas.microsoft.com/office/drawing/2010/main" xmlns:ma14="http://schemas.microsoft.com/office/mac/drawingml/2011/main" val="1"/>
             </a:ext>
           </a:extLst>
         </p:spPr>
@@ -12772,7 +12671,7 @@
           </a:ln>
           <a:extLst>
             <a:ext uri="{C572A759-6A51-4108-AA02-DFA0A04FC94B}">
-              <ma14:wrappingTextBoxFlag xmlns="" xmlns:m="http://schemas.openxmlformats.org/officeDocument/2006/math" xmlns:a14="http://schemas.microsoft.com/office/drawing/2010/main" xmlns:ma14="http://schemas.microsoft.com/office/mac/drawingml/2011/main" val="1"/>
+              <ma14:wrappingTextBoxFlag xmlns:ma14="http://schemas.microsoft.com/office/mac/drawingml/2011/main" xmlns:a14="http://schemas.microsoft.com/office/drawing/2010/main" xmlns:m="http://schemas.openxmlformats.org/officeDocument/2006/math" xmlns="" val="1"/>
             </a:ext>
           </a:extLst>
         </p:spPr>
@@ -13009,7 +12908,7 @@
           </a:ln>
           <a:extLst>
             <a:ext uri="{C572A759-6A51-4108-AA02-DFA0A04FC94B}">
-              <ma14:wrappingTextBoxFlag xmlns="" xmlns:m="http://schemas.openxmlformats.org/officeDocument/2006/math" xmlns:a14="http://schemas.microsoft.com/office/drawing/2010/main" xmlns:ma14="http://schemas.microsoft.com/office/mac/drawingml/2011/main" val="1"/>
+              <ma14:wrappingTextBoxFlag xmlns:ma14="http://schemas.microsoft.com/office/mac/drawingml/2011/main" xmlns:a14="http://schemas.microsoft.com/office/drawing/2010/main" xmlns:m="http://schemas.openxmlformats.org/officeDocument/2006/math" xmlns="" val="1"/>
             </a:ext>
           </a:extLst>
         </p:spPr>
@@ -13105,7 +13004,7 @@
           </a:ln>
           <a:extLst>
             <a:ext uri="{C572A759-6A51-4108-AA02-DFA0A04FC94B}">
-              <ma14:wrappingTextBoxFlag xmlns="" xmlns:m="http://schemas.openxmlformats.org/officeDocument/2006/math" xmlns:a14="http://schemas.microsoft.com/office/drawing/2010/main" xmlns:ma14="http://schemas.microsoft.com/office/mac/drawingml/2011/main" val="1"/>
+              <ma14:wrappingTextBoxFlag xmlns:ma14="http://schemas.microsoft.com/office/mac/drawingml/2011/main" xmlns:a14="http://schemas.microsoft.com/office/drawing/2010/main" xmlns:m="http://schemas.openxmlformats.org/officeDocument/2006/math" xmlns="" val="1"/>
             </a:ext>
           </a:extLst>
         </p:spPr>
@@ -13335,7 +13234,7 @@
           </a:ln>
           <a:extLst>
             <a:ext uri="{C572A759-6A51-4108-AA02-DFA0A04FC94B}">
-              <ma14:wrappingTextBoxFlag xmlns="" xmlns:m="http://schemas.openxmlformats.org/officeDocument/2006/math" xmlns:a14="http://schemas.microsoft.com/office/drawing/2010/main" xmlns:ma14="http://schemas.microsoft.com/office/mac/drawingml/2011/main" val="1"/>
+              <ma14:wrappingTextBoxFlag xmlns:ma14="http://schemas.microsoft.com/office/mac/drawingml/2011/main" xmlns:a14="http://schemas.microsoft.com/office/drawing/2010/main" xmlns:m="http://schemas.openxmlformats.org/officeDocument/2006/math" xmlns="" val="1"/>
             </a:ext>
           </a:extLst>
         </p:spPr>
@@ -13999,7 +13898,7 @@
           </a:prstGeom>
           <a:extLst>
             <a:ext uri="{C572A759-6A51-4108-AA02-DFA0A04FC94B}">
-              <ma14:wrappingTextBoxFlag xmlns="" xmlns:m="http://schemas.openxmlformats.org/officeDocument/2006/math" xmlns:a14="http://schemas.microsoft.com/office/drawing/2010/main" xmlns:ma14="http://schemas.microsoft.com/office/mac/drawingml/2011/main" val="1"/>
+              <ma14:wrappingTextBoxFlag xmlns:ma14="http://schemas.microsoft.com/office/mac/drawingml/2011/main" xmlns:a14="http://schemas.microsoft.com/office/drawing/2010/main" xmlns:m="http://schemas.openxmlformats.org/officeDocument/2006/math" xmlns="" val="1"/>
             </a:ext>
           </a:extLst>
         </p:spPr>
@@ -14055,7 +13954,7 @@
           </a:ln>
           <a:extLst>
             <a:ext uri="{C572A759-6A51-4108-AA02-DFA0A04FC94B}">
-              <ma14:wrappingTextBoxFlag xmlns="" xmlns:m="http://schemas.openxmlformats.org/officeDocument/2006/math" xmlns:a14="http://schemas.microsoft.com/office/drawing/2010/main" xmlns:ma14="http://schemas.microsoft.com/office/mac/drawingml/2011/main" val="1"/>
+              <ma14:wrappingTextBoxFlag xmlns:ma14="http://schemas.microsoft.com/office/mac/drawingml/2011/main" xmlns:a14="http://schemas.microsoft.com/office/drawing/2010/main" xmlns:m="http://schemas.openxmlformats.org/officeDocument/2006/math" xmlns="" val="1"/>
             </a:ext>
           </a:extLst>
         </p:spPr>
@@ -14917,7 +14816,7 @@
             <a:effectLst/>
             <a:extLst>
               <a:ext uri="{C572A759-6A51-4108-AA02-DFA0A04FC94B}">
-                <ma14:wrappingTextBoxFlag xmlns="" xmlns:m="http://schemas.openxmlformats.org/officeDocument/2006/math" xmlns:a14="http://schemas.microsoft.com/office/drawing/2010/main" xmlns:ma14="http://schemas.microsoft.com/office/mac/drawingml/2011/main" val="1"/>
+                <ma14:wrappingTextBoxFlag xmlns:ma14="http://schemas.microsoft.com/office/mac/drawingml/2011/main" xmlns:a14="http://schemas.microsoft.com/office/drawing/2010/main" xmlns:m="http://schemas.openxmlformats.org/officeDocument/2006/math" xmlns="" val="1"/>
               </a:ext>
             </a:extLst>
           </p:spPr>
@@ -15219,7 +15118,7 @@
           </a:ln>
           <a:extLst>
             <a:ext uri="{C572A759-6A51-4108-AA02-DFA0A04FC94B}">
-              <ma14:wrappingTextBoxFlag xmlns="" xmlns:m="http://schemas.openxmlformats.org/officeDocument/2006/math" xmlns:a14="http://schemas.microsoft.com/office/drawing/2010/main" xmlns:ma14="http://schemas.microsoft.com/office/mac/drawingml/2011/main" val="1"/>
+              <ma14:wrappingTextBoxFlag xmlns:ma14="http://schemas.microsoft.com/office/mac/drawingml/2011/main" xmlns:a14="http://schemas.microsoft.com/office/drawing/2010/main" xmlns:m="http://schemas.openxmlformats.org/officeDocument/2006/math" xmlns="" val="1"/>
             </a:ext>
           </a:extLst>
         </p:spPr>
@@ -15660,7 +15559,7 @@
           <a:effectLst/>
           <a:extLst>
             <a:ext uri="{C572A759-6A51-4108-AA02-DFA0A04FC94B}">
-              <ma14:wrappingTextBoxFlag xmlns="" xmlns:m="http://schemas.openxmlformats.org/officeDocument/2006/math" xmlns:a14="http://schemas.microsoft.com/office/drawing/2010/main" xmlns:ma14="http://schemas.microsoft.com/office/mac/drawingml/2011/main" val="1"/>
+              <ma14:wrappingTextBoxFlag xmlns:ma14="http://schemas.microsoft.com/office/mac/drawingml/2011/main" xmlns:a14="http://schemas.microsoft.com/office/drawing/2010/main" xmlns:m="http://schemas.openxmlformats.org/officeDocument/2006/math" xmlns="" val="1"/>
             </a:ext>
           </a:extLst>
         </p:spPr>
@@ -16978,7 +16877,7 @@
           <a:effectLst/>
           <a:extLst>
             <a:ext uri="{C572A759-6A51-4108-AA02-DFA0A04FC94B}">
-              <ma14:wrappingTextBoxFlag xmlns="" xmlns:m="http://schemas.openxmlformats.org/officeDocument/2006/math" xmlns:a14="http://schemas.microsoft.com/office/drawing/2010/main" xmlns:ma14="http://schemas.microsoft.com/office/mac/drawingml/2011/main" val="1"/>
+              <ma14:wrappingTextBoxFlag xmlns:ma14="http://schemas.microsoft.com/office/mac/drawingml/2011/main" xmlns:a14="http://schemas.microsoft.com/office/drawing/2010/main" xmlns:m="http://schemas.openxmlformats.org/officeDocument/2006/math" xmlns="" val="1"/>
             </a:ext>
           </a:extLst>
         </p:spPr>
@@ -18001,7 +17900,7 @@
           </a:ln>
           <a:extLst>
             <a:ext uri="{C572A759-6A51-4108-AA02-DFA0A04FC94B}">
-              <ma14:wrappingTextBoxFlag xmlns="" xmlns:m="http://schemas.openxmlformats.org/officeDocument/2006/math" xmlns:a14="http://schemas.microsoft.com/office/drawing/2010/main" xmlns:ma14="http://schemas.microsoft.com/office/mac/drawingml/2011/main" val="1"/>
+              <ma14:wrappingTextBoxFlag xmlns:ma14="http://schemas.microsoft.com/office/mac/drawingml/2011/main" xmlns:a14="http://schemas.microsoft.com/office/drawing/2010/main" xmlns:m="http://schemas.openxmlformats.org/officeDocument/2006/math" xmlns="" val="1"/>
             </a:ext>
           </a:extLst>
         </p:spPr>
@@ -18096,7 +17995,7 @@
           </a:ln>
           <a:extLst>
             <a:ext uri="{C572A759-6A51-4108-AA02-DFA0A04FC94B}">
-              <ma14:wrappingTextBoxFlag xmlns="" xmlns:m="http://schemas.openxmlformats.org/officeDocument/2006/math" xmlns:a14="http://schemas.microsoft.com/office/drawing/2010/main" xmlns:ma14="http://schemas.microsoft.com/office/mac/drawingml/2011/main" val="1"/>
+              <ma14:wrappingTextBoxFlag xmlns:ma14="http://schemas.microsoft.com/office/mac/drawingml/2011/main" xmlns:a14="http://schemas.microsoft.com/office/drawing/2010/main" xmlns:m="http://schemas.openxmlformats.org/officeDocument/2006/math" xmlns="" val="1"/>
             </a:ext>
           </a:extLst>
         </p:spPr>
@@ -18155,7 +18054,7 @@
           </a:ln>
           <a:extLst>
             <a:ext uri="{C572A759-6A51-4108-AA02-DFA0A04FC94B}">
-              <ma14:wrappingTextBoxFlag xmlns="" xmlns:m="http://schemas.openxmlformats.org/officeDocument/2006/math" xmlns:a14="http://schemas.microsoft.com/office/drawing/2010/main" xmlns:ma14="http://schemas.microsoft.com/office/mac/drawingml/2011/main" val="1"/>
+              <ma14:wrappingTextBoxFlag xmlns:ma14="http://schemas.microsoft.com/office/mac/drawingml/2011/main" xmlns:a14="http://schemas.microsoft.com/office/drawing/2010/main" xmlns:m="http://schemas.openxmlformats.org/officeDocument/2006/math" xmlns="" val="1"/>
             </a:ext>
           </a:extLst>
         </p:spPr>
@@ -18214,7 +18113,7 @@
           </a:ln>
           <a:extLst>
             <a:ext uri="{C572A759-6A51-4108-AA02-DFA0A04FC94B}">
-              <ma14:wrappingTextBoxFlag xmlns="" xmlns:m="http://schemas.openxmlformats.org/officeDocument/2006/math" xmlns:a14="http://schemas.microsoft.com/office/drawing/2010/main" xmlns:ma14="http://schemas.microsoft.com/office/mac/drawingml/2011/main" val="1"/>
+              <ma14:wrappingTextBoxFlag xmlns:ma14="http://schemas.microsoft.com/office/mac/drawingml/2011/main" xmlns:a14="http://schemas.microsoft.com/office/drawing/2010/main" xmlns:m="http://schemas.openxmlformats.org/officeDocument/2006/math" xmlns="" val="1"/>
             </a:ext>
           </a:extLst>
         </p:spPr>
@@ -18345,7 +18244,7 @@
           </a:ln>
           <a:extLst>
             <a:ext uri="{C572A759-6A51-4108-AA02-DFA0A04FC94B}">
-              <ma14:wrappingTextBoxFlag xmlns="" xmlns:m="http://schemas.openxmlformats.org/officeDocument/2006/math" xmlns:a14="http://schemas.microsoft.com/office/drawing/2010/main" xmlns:ma14="http://schemas.microsoft.com/office/mac/drawingml/2011/main" val="1"/>
+              <ma14:wrappingTextBoxFlag xmlns:ma14="http://schemas.microsoft.com/office/mac/drawingml/2011/main" xmlns:a14="http://schemas.microsoft.com/office/drawing/2010/main" xmlns:m="http://schemas.openxmlformats.org/officeDocument/2006/math" xmlns="" val="1"/>
             </a:ext>
           </a:extLst>
         </p:spPr>
@@ -19728,7 +19627,7 @@
           <a:effectLst/>
           <a:extLst>
             <a:ext uri="{C572A759-6A51-4108-AA02-DFA0A04FC94B}">
-              <ma14:wrappingTextBoxFlag xmlns="" xmlns:m="http://schemas.openxmlformats.org/officeDocument/2006/math" xmlns:a14="http://schemas.microsoft.com/office/drawing/2010/main" xmlns:ma14="http://schemas.microsoft.com/office/mac/drawingml/2011/main" val="1"/>
+              <ma14:wrappingTextBoxFlag xmlns:ma14="http://schemas.microsoft.com/office/mac/drawingml/2011/main" xmlns:a14="http://schemas.microsoft.com/office/drawing/2010/main" xmlns:m="http://schemas.openxmlformats.org/officeDocument/2006/math" xmlns="" val="1"/>
             </a:ext>
           </a:extLst>
         </p:spPr>
@@ -21211,10 +21110,15 @@
             <p:ph idx="1"/>
           </p:nvPr>
         </p:nvSpPr>
-        <p:spPr/>
+        <p:spPr>
+          <a:xfrm>
+            <a:off x="838200" y="1500159"/>
+            <a:ext cx="9623323" cy="4856191"/>
+          </a:xfrm>
+        </p:spPr>
         <p:txBody>
           <a:bodyPr>
-            <a:normAutofit fontScale="62500" lnSpcReduction="20000"/>
+            <a:normAutofit fontScale="77500" lnSpcReduction="20000"/>
           </a:bodyPr>
           <a:lstStyle/>
           <a:p>
@@ -21330,9 +21234,6 @@
               <a:rPr lang="en-US" dirty="0"/>
               <a:t> - Attackers gaining unauthorized access levels, obtaining higher permissions than intended, or moving laterally through your system.</a:t>
             </a:r>
-          </a:p>
-          <a:p>
-            <a:endParaRPr lang="en-US" dirty="0"/>
           </a:p>
         </p:txBody>
       </p:sp>
@@ -21910,135 +21811,6 @@
 </file>
 
 <file path=ppt/slides/slide44.xml><?xml version="1.0" encoding="utf-8"?>
-<p:sld xmlns:a="http://schemas.openxmlformats.org/drawingml/2006/main" xmlns:r="http://schemas.openxmlformats.org/officeDocument/2006/relationships" xmlns:p="http://schemas.openxmlformats.org/presentationml/2006/main" show="0">
-  <p:cSld>
-    <p:spTree>
-      <p:nvGrpSpPr>
-        <p:cNvPr id="1" name=""/>
-        <p:cNvGrpSpPr/>
-        <p:nvPr/>
-      </p:nvGrpSpPr>
-      <p:grpSpPr>
-        <a:xfrm>
-          <a:off x="0" y="0"/>
-          <a:ext cx="0" cy="0"/>
-          <a:chOff x="0" y="0"/>
-          <a:chExt cx="0" cy="0"/>
-        </a:xfrm>
-      </p:grpSpPr>
-      <p:sp>
-        <p:nvSpPr>
-          <p:cNvPr id="2" name="Title 1">
-            <a:extLst>
-              <a:ext uri="{FF2B5EF4-FFF2-40B4-BE49-F238E27FC236}">
-                <a16:creationId xmlns:a16="http://schemas.microsoft.com/office/drawing/2014/main" id="{CB3F4108-FF6F-613C-8466-6D6395C9E6D2}"/>
-              </a:ext>
-            </a:extLst>
-          </p:cNvPr>
-          <p:cNvSpPr>
-            <a:spLocks noGrp="1"/>
-          </p:cNvSpPr>
-          <p:nvPr>
-            <p:ph type="title"/>
-          </p:nvPr>
-        </p:nvSpPr>
-        <p:spPr/>
-        <p:txBody>
-          <a:bodyPr/>
-          <a:lstStyle/>
-          <a:p>
-            <a:r>
-              <a:rPr lang="en-US" dirty="0"/>
-              <a:t>Elements of a security culture</a:t>
-            </a:r>
-          </a:p>
-        </p:txBody>
-      </p:sp>
-      <p:sp>
-        <p:nvSpPr>
-          <p:cNvPr id="3" name="Content Placeholder 2">
-            <a:extLst>
-              <a:ext uri="{FF2B5EF4-FFF2-40B4-BE49-F238E27FC236}">
-                <a16:creationId xmlns:a16="http://schemas.microsoft.com/office/drawing/2014/main" id="{A6A51E1A-428A-71C9-87F9-8032C2DC5EB0}"/>
-              </a:ext>
-            </a:extLst>
-          </p:cNvPr>
-          <p:cNvSpPr>
-            <a:spLocks noGrp="1"/>
-          </p:cNvSpPr>
-          <p:nvPr>
-            <p:ph idx="1"/>
-          </p:nvPr>
-        </p:nvSpPr>
-        <p:spPr/>
-        <p:txBody>
-          <a:bodyPr/>
-          <a:lstStyle/>
-          <a:p>
-            <a:r>
-              <a:rPr lang="en-US" dirty="0"/>
-              <a:t>Make security a regular part of the process.</a:t>
-            </a:r>
-          </a:p>
-          <a:p>
-            <a:pPr lvl="1"/>
-            <a:r>
-              <a:rPr lang="en-US" dirty="0"/>
-              <a:t>Include security reviews as part of the build/release process</a:t>
-            </a:r>
-          </a:p>
-          <a:p>
-            <a:pPr lvl="1"/>
-            <a:r>
-              <a:rPr lang="en-US" dirty="0"/>
-              <a:t>Review security on small increments</a:t>
-            </a:r>
-          </a:p>
-        </p:txBody>
-      </p:sp>
-      <p:sp>
-        <p:nvSpPr>
-          <p:cNvPr id="4" name="Slide Number Placeholder 3">
-            <a:extLst>
-              <a:ext uri="{FF2B5EF4-FFF2-40B4-BE49-F238E27FC236}">
-                <a16:creationId xmlns:a16="http://schemas.microsoft.com/office/drawing/2014/main" id="{D59AECEC-4F13-E90B-FF91-7B7BDA015246}"/>
-              </a:ext>
-            </a:extLst>
-          </p:cNvPr>
-          <p:cNvSpPr>
-            <a:spLocks noGrp="1"/>
-          </p:cNvSpPr>
-          <p:nvPr>
-            <p:ph type="sldNum" sz="quarter" idx="12"/>
-          </p:nvPr>
-        </p:nvSpPr>
-        <p:spPr/>
-        <p:txBody>
-          <a:bodyPr/>
-          <a:lstStyle/>
-          <a:p>
-            <a:fld id="{20F37917-FD3A-4669-9018-DA04BCDD3D75}" type="slidenum">
-              <a:rPr lang="en-US" smtClean="0"/>
-              <a:t>44</a:t>
-            </a:fld>
-            <a:endParaRPr lang="en-US"/>
-          </a:p>
-        </p:txBody>
-      </p:sp>
-    </p:spTree>
-    <p:extLst>
-      <p:ext uri="{BB962C8B-B14F-4D97-AF65-F5344CB8AC3E}">
-        <p14:creationId xmlns:p14="http://schemas.microsoft.com/office/powerpoint/2010/main" val="3390111508"/>
-      </p:ext>
-    </p:extLst>
-  </p:cSld>
-  <p:clrMapOvr>
-    <a:masterClrMapping/>
-  </p:clrMapOvr>
-</p:sld>
-</file>
-
-<file path=ppt/slides/slide45.xml><?xml version="1.0" encoding="utf-8"?>
 <p:sld xmlns:a="http://schemas.openxmlformats.org/drawingml/2006/main" xmlns:r="http://schemas.openxmlformats.org/officeDocument/2006/relationships" xmlns:p="http://schemas.openxmlformats.org/presentationml/2006/main">
   <p:cSld>
     <p:spTree>

</xml_diff>

<commit_message>
added xkcd, PHP-hero slides; hid NCSU example
</commit_message>
<xml_diff>
--- a/Slides/Module 13 Security.pptx
+++ b/Slides/Module 13 Security.pptx
@@ -6,7 +6,7 @@
     <p:sldMasterId id="2147483675" r:id="rId2"/>
   </p:sldMasterIdLst>
   <p:notesMasterIdLst>
-    <p:notesMasterId r:id="rId47"/>
+    <p:notesMasterId r:id="rId49"/>
   </p:notesMasterIdLst>
   <p:sldIdLst>
     <p:sldId id="342" r:id="rId3"/>
@@ -38,21 +38,23 @@
     <p:sldId id="615" r:id="rId29"/>
     <p:sldId id="276" r:id="rId30"/>
     <p:sldId id="291" r:id="rId31"/>
-    <p:sldId id="331" r:id="rId32"/>
-    <p:sldId id="330" r:id="rId33"/>
-    <p:sldId id="312" r:id="rId34"/>
-    <p:sldId id="375" r:id="rId35"/>
-    <p:sldId id="348" r:id="rId36"/>
-    <p:sldId id="335" r:id="rId37"/>
-    <p:sldId id="292" r:id="rId38"/>
-    <p:sldId id="351" r:id="rId39"/>
-    <p:sldId id="340" r:id="rId40"/>
-    <p:sldId id="389" r:id="rId41"/>
-    <p:sldId id="377" r:id="rId42"/>
-    <p:sldId id="616" r:id="rId43"/>
-    <p:sldId id="392" r:id="rId44"/>
-    <p:sldId id="391" r:id="rId45"/>
-    <p:sldId id="343" r:id="rId46"/>
+    <p:sldId id="617" r:id="rId32"/>
+    <p:sldId id="618" r:id="rId33"/>
+    <p:sldId id="331" r:id="rId34"/>
+    <p:sldId id="330" r:id="rId35"/>
+    <p:sldId id="312" r:id="rId36"/>
+    <p:sldId id="375" r:id="rId37"/>
+    <p:sldId id="348" r:id="rId38"/>
+    <p:sldId id="335" r:id="rId39"/>
+    <p:sldId id="292" r:id="rId40"/>
+    <p:sldId id="351" r:id="rId41"/>
+    <p:sldId id="340" r:id="rId42"/>
+    <p:sldId id="389" r:id="rId43"/>
+    <p:sldId id="377" r:id="rId44"/>
+    <p:sldId id="616" r:id="rId45"/>
+    <p:sldId id="392" r:id="rId46"/>
+    <p:sldId id="391" r:id="rId47"/>
+    <p:sldId id="343" r:id="rId48"/>
   </p:sldIdLst>
   <p:sldSz cx="12192000" cy="6858000"/>
   <p:notesSz cx="6858000" cy="9144000"/>
@@ -162,7 +164,7 @@
 <file path=ppt/revisionInfo.xml><?xml version="1.0" encoding="utf-8"?>
 <p1510:revInfo xmlns:a="http://schemas.openxmlformats.org/drawingml/2006/main" xmlns:r="http://schemas.openxmlformats.org/officeDocument/2006/relationships" xmlns:p1510="http://schemas.microsoft.com/office/powerpoint/2015/10/main">
   <p1510:revLst>
-    <p1510:client id="{8AE2315A-F7E8-41EC-AC3F-B2934F1C8BDD}" v="8" dt="2026-10-11T01:32:17.050"/>
+    <p1510:client id="{8AE2315A-F7E8-41EC-AC3F-B2934F1C8BDD}" v="4" dt="2026-10-26T18:51:23.364"/>
   </p1510:revLst>
 </p1510:revInfo>
 </file>
@@ -172,7 +174,7 @@
   <pc:docChgLst>
     <pc:chgData name="Mitchell Wand" userId="de9b44c55c049659" providerId="LiveId" clId="{7A9D5940-B2CC-47DD-AF5E-71219F1A1E26}"/>
     <pc:docChg chg="undo custSel addSld delSld modSld sldOrd">
-      <pc:chgData name="Mitchell Wand" userId="de9b44c55c049659" providerId="LiveId" clId="{7A9D5940-B2CC-47DD-AF5E-71219F1A1E26}" dt="2026-10-11T01:33:49.148" v="961" actId="2696"/>
+      <pc:chgData name="Mitchell Wand" userId="de9b44c55c049659" providerId="LiveId" clId="{7A9D5940-B2CC-47DD-AF5E-71219F1A1E26}" dt="2026-10-26T18:50:51.287" v="1299" actId="20577"/>
       <pc:docMkLst>
         <pc:docMk/>
       </pc:docMkLst>
@@ -213,13 +215,6 @@
           <pc:sldMk cId="0" sldId="285"/>
         </pc:sldMkLst>
       </pc:sldChg>
-      <pc:sldChg chg="del">
-        <pc:chgData name="Mitchell Wand" userId="de9b44c55c049659" providerId="LiveId" clId="{7A9D5940-B2CC-47DD-AF5E-71219F1A1E26}" dt="2026-10-11T00:58:50.025" v="293" actId="2696"/>
-        <pc:sldMkLst>
-          <pc:docMk/>
-          <pc:sldMk cId="4161365394" sldId="286"/>
-        </pc:sldMkLst>
-      </pc:sldChg>
       <pc:sldChg chg="modSp mod">
         <pc:chgData name="Mitchell Wand" userId="de9b44c55c049659" providerId="LiveId" clId="{7A9D5940-B2CC-47DD-AF5E-71219F1A1E26}" dt="2026-10-11T01:03:06.015" v="576" actId="20577"/>
         <pc:sldMkLst>
@@ -235,68 +230,11 @@
           </ac:spMkLst>
         </pc:spChg>
       </pc:sldChg>
-      <pc:sldChg chg="del mod modShow">
-        <pc:chgData name="Mitchell Wand" userId="de9b44c55c049659" providerId="LiveId" clId="{7A9D5940-B2CC-47DD-AF5E-71219F1A1E26}" dt="2026-10-11T01:33:44.280" v="960" actId="2696"/>
-        <pc:sldMkLst>
-          <pc:docMk/>
-          <pc:sldMk cId="126056709" sldId="304"/>
-        </pc:sldMkLst>
-      </pc:sldChg>
-      <pc:sldChg chg="del">
-        <pc:chgData name="Mitchell Wand" userId="de9b44c55c049659" providerId="LiveId" clId="{7A9D5940-B2CC-47DD-AF5E-71219F1A1E26}" dt="2026-10-11T01:23:54.246" v="687" actId="2696"/>
-        <pc:sldMkLst>
-          <pc:docMk/>
-          <pc:sldMk cId="1482529099" sldId="313"/>
-        </pc:sldMkLst>
-      </pc:sldChg>
-      <pc:sldChg chg="del">
-        <pc:chgData name="Mitchell Wand" userId="de9b44c55c049659" providerId="LiveId" clId="{7A9D5940-B2CC-47DD-AF5E-71219F1A1E26}" dt="2026-10-11T01:32:57.106" v="956" actId="2696"/>
-        <pc:sldMkLst>
-          <pc:docMk/>
-          <pc:sldMk cId="1950794410" sldId="334"/>
-        </pc:sldMkLst>
-      </pc:sldChg>
-      <pc:sldChg chg="del mod modShow">
-        <pc:chgData name="Mitchell Wand" userId="de9b44c55c049659" providerId="LiveId" clId="{7A9D5940-B2CC-47DD-AF5E-71219F1A1E26}" dt="2026-10-11T01:33:49.148" v="961" actId="2696"/>
-        <pc:sldMkLst>
-          <pc:docMk/>
-          <pc:sldMk cId="3069861496" sldId="338"/>
-        </pc:sldMkLst>
-      </pc:sldChg>
-      <pc:sldChg chg="modSp mod">
-        <pc:chgData name="Mitchell Wand" userId="de9b44c55c049659" providerId="LiveId" clId="{7A9D5940-B2CC-47DD-AF5E-71219F1A1E26}" dt="2026-10-11T01:31:43.439" v="955" actId="20577"/>
-        <pc:sldMkLst>
-          <pc:docMk/>
-          <pc:sldMk cId="3390111508" sldId="341"/>
-        </pc:sldMkLst>
-        <pc:spChg chg="mod">
-          <ac:chgData name="Mitchell Wand" userId="de9b44c55c049659" providerId="LiveId" clId="{7A9D5940-B2CC-47DD-AF5E-71219F1A1E26}" dt="2026-10-11T01:31:43.439" v="955" actId="20577"/>
-          <ac:spMkLst>
-            <pc:docMk/>
-            <pc:sldMk cId="3390111508" sldId="341"/>
-            <ac:spMk id="3" creationId="{A6A51E1A-428A-71C9-87F9-8032C2DC5EB0}"/>
-          </ac:spMkLst>
-        </pc:spChg>
-      </pc:sldChg>
-      <pc:sldChg chg="del">
-        <pc:chgData name="Mitchell Wand" userId="de9b44c55c049659" providerId="LiveId" clId="{7A9D5940-B2CC-47DD-AF5E-71219F1A1E26}" dt="2026-10-11T01:33:00.093" v="957" actId="2696"/>
-        <pc:sldMkLst>
-          <pc:docMk/>
-          <pc:sldMk cId="3151719411" sldId="345"/>
-        </pc:sldMkLst>
-      </pc:sldChg>
       <pc:sldChg chg="mod modShow">
         <pc:chgData name="Mitchell Wand" userId="de9b44c55c049659" providerId="LiveId" clId="{7A9D5940-B2CC-47DD-AF5E-71219F1A1E26}" dt="2026-10-11T01:33:23.526" v="958" actId="34476"/>
         <pc:sldMkLst>
           <pc:docMk/>
           <pc:sldMk cId="4257251093" sldId="348"/>
-        </pc:sldMkLst>
-      </pc:sldChg>
-      <pc:sldChg chg="del mod modShow">
-        <pc:chgData name="Mitchell Wand" userId="de9b44c55c049659" providerId="LiveId" clId="{7A9D5940-B2CC-47DD-AF5E-71219F1A1E26}" dt="2026-10-11T01:33:39.894" v="959" actId="2696"/>
-        <pc:sldMkLst>
-          <pc:docMk/>
-          <pc:sldMk cId="2921844832" sldId="355"/>
         </pc:sldMkLst>
       </pc:sldChg>
       <pc:sldChg chg="modSp mod">
@@ -313,6 +251,13 @@
             <ac:spMk id="139" creationId="{951A5BBD-5F10-7357-F803-8C521C116E7D}"/>
           </ac:spMkLst>
         </pc:spChg>
+      </pc:sldChg>
+      <pc:sldChg chg="mod modShow">
+        <pc:chgData name="Mitchell Wand" userId="de9b44c55c049659" providerId="LiveId" clId="{7A9D5940-B2CC-47DD-AF5E-71219F1A1E26}" dt="2026-10-26T18:44:48.750" v="1297" actId="729"/>
+        <pc:sldMkLst>
+          <pc:docMk/>
+          <pc:sldMk cId="3029668800" sldId="375"/>
+        </pc:sldMkLst>
       </pc:sldChg>
       <pc:sldChg chg="modSp mod">
         <pc:chgData name="Mitchell Wand" userId="de9b44c55c049659" providerId="LiveId" clId="{7A9D5940-B2CC-47DD-AF5E-71219F1A1E26}" dt="2026-10-11T01:27:32.828" v="877" actId="20577"/>
@@ -337,13 +282,6 @@
           </ac:spMkLst>
         </pc:spChg>
       </pc:sldChg>
-      <pc:sldChg chg="del mod modShow">
-        <pc:chgData name="Mitchell Wand" userId="de9b44c55c049659" providerId="LiveId" clId="{7A9D5940-B2CC-47DD-AF5E-71219F1A1E26}" dt="2026-10-11T01:29:05.145" v="901" actId="2696"/>
-        <pc:sldMkLst>
-          <pc:docMk/>
-          <pc:sldMk cId="362832005" sldId="383"/>
-        </pc:sldMkLst>
-      </pc:sldChg>
       <pc:sldChg chg="modSp mod ord">
         <pc:chgData name="Mitchell Wand" userId="de9b44c55c049659" providerId="LiveId" clId="{7A9D5940-B2CC-47DD-AF5E-71219F1A1E26}" dt="2026-10-11T00:55:31.607" v="267"/>
         <pc:sldMkLst>
@@ -359,27 +297,6 @@
           </ac:spMkLst>
         </pc:spChg>
       </pc:sldChg>
-      <pc:sldChg chg="del">
-        <pc:chgData name="Mitchell Wand" userId="de9b44c55c049659" providerId="LiveId" clId="{7A9D5940-B2CC-47DD-AF5E-71219F1A1E26}" dt="2026-10-11T01:20:10.226" v="677" actId="2696"/>
-        <pc:sldMkLst>
-          <pc:docMk/>
-          <pc:sldMk cId="3870110143" sldId="386"/>
-        </pc:sldMkLst>
-      </pc:sldChg>
-      <pc:sldChg chg="del mod modShow">
-        <pc:chgData name="Mitchell Wand" userId="de9b44c55c049659" providerId="LiveId" clId="{7A9D5940-B2CC-47DD-AF5E-71219F1A1E26}" dt="2026-10-11T01:29:10.478" v="902" actId="2696"/>
-        <pc:sldMkLst>
-          <pc:docMk/>
-          <pc:sldMk cId="2264757717" sldId="387"/>
-        </pc:sldMkLst>
-      </pc:sldChg>
-      <pc:sldChg chg="del mod modShow">
-        <pc:chgData name="Mitchell Wand" userId="de9b44c55c049659" providerId="LiveId" clId="{7A9D5940-B2CC-47DD-AF5E-71219F1A1E26}" dt="2026-10-11T01:29:16.887" v="903" actId="2696"/>
-        <pc:sldMkLst>
-          <pc:docMk/>
-          <pc:sldMk cId="1441177639" sldId="388"/>
-        </pc:sldMkLst>
-      </pc:sldChg>
       <pc:sldChg chg="modSp mod ord">
         <pc:chgData name="Mitchell Wand" userId="de9b44c55c049659" providerId="LiveId" clId="{7A9D5940-B2CC-47DD-AF5E-71219F1A1E26}" dt="2026-10-11T01:28:32.712" v="900" actId="20577"/>
         <pc:sldMkLst>
@@ -394,13 +311,6 @@
             <ac:spMk id="2" creationId="{B974C6E5-8FE2-DF16-609E-9B7A086EBBD8}"/>
           </ac:spMkLst>
         </pc:spChg>
-      </pc:sldChg>
-      <pc:sldChg chg="del mod modShow">
-        <pc:chgData name="Mitchell Wand" userId="de9b44c55c049659" providerId="LiveId" clId="{7A9D5940-B2CC-47DD-AF5E-71219F1A1E26}" dt="2026-10-11T01:29:30.830" v="904" actId="2696"/>
-        <pc:sldMkLst>
-          <pc:docMk/>
-          <pc:sldMk cId="918350328" sldId="390"/>
-        </pc:sldMkLst>
       </pc:sldChg>
       <pc:sldChg chg="modSp mod">
         <pc:chgData name="Mitchell Wand" userId="de9b44c55c049659" providerId="LiveId" clId="{7A9D5940-B2CC-47DD-AF5E-71219F1A1E26}" dt="2026-10-11T01:29:58.342" v="905" actId="113"/>
@@ -492,6 +402,108 @@
           </ac:spMkLst>
         </pc:spChg>
       </pc:sldChg>
+      <pc:sldChg chg="addSp delSp modSp new mod ord modClrScheme chgLayout">
+        <pc:chgData name="Mitchell Wand" userId="de9b44c55c049659" providerId="LiveId" clId="{7A9D5940-B2CC-47DD-AF5E-71219F1A1E26}" dt="2026-10-26T18:30:22.973" v="1163" actId="20577"/>
+        <pc:sldMkLst>
+          <pc:docMk/>
+          <pc:sldMk cId="988594982" sldId="617"/>
+        </pc:sldMkLst>
+        <pc:spChg chg="mod ord">
+          <ac:chgData name="Mitchell Wand" userId="de9b44c55c049659" providerId="LiveId" clId="{7A9D5940-B2CC-47DD-AF5E-71219F1A1E26}" dt="2026-10-26T18:30:22.973" v="1163" actId="20577"/>
+          <ac:spMkLst>
+            <pc:docMk/>
+            <pc:sldMk cId="988594982" sldId="617"/>
+            <ac:spMk id="2" creationId="{6017E05F-085F-96DD-ACB3-1CA15578FE4E}"/>
+          </ac:spMkLst>
+        </pc:spChg>
+        <pc:spChg chg="del">
+          <ac:chgData name="Mitchell Wand" userId="de9b44c55c049659" providerId="LiveId" clId="{7A9D5940-B2CC-47DD-AF5E-71219F1A1E26}" dt="2026-10-26T18:25:33.405" v="975" actId="700"/>
+          <ac:spMkLst>
+            <pc:docMk/>
+            <pc:sldMk cId="988594982" sldId="617"/>
+            <ac:spMk id="3" creationId="{E33D5942-A1C6-0EF3-6B66-D68DF1348CB7}"/>
+          </ac:spMkLst>
+        </pc:spChg>
+        <pc:spChg chg="mod ord">
+          <ac:chgData name="Mitchell Wand" userId="de9b44c55c049659" providerId="LiveId" clId="{7A9D5940-B2CC-47DD-AF5E-71219F1A1E26}" dt="2026-10-26T18:28:14.282" v="984" actId="700"/>
+          <ac:spMkLst>
+            <pc:docMk/>
+            <pc:sldMk cId="988594982" sldId="617"/>
+            <ac:spMk id="4" creationId="{99A7475A-7825-E522-C819-9B4155925005}"/>
+          </ac:spMkLst>
+        </pc:spChg>
+        <pc:spChg chg="add mod">
+          <ac:chgData name="Mitchell Wand" userId="de9b44c55c049659" providerId="LiveId" clId="{7A9D5940-B2CC-47DD-AF5E-71219F1A1E26}" dt="2026-10-26T18:27:49.862" v="983" actId="1076"/>
+          <ac:spMkLst>
+            <pc:docMk/>
+            <pc:sldMk cId="988594982" sldId="617"/>
+            <ac:spMk id="7" creationId="{9CBED374-4E23-606F-DBBD-D700A133B367}"/>
+          </ac:spMkLst>
+        </pc:spChg>
+        <pc:spChg chg="add mod ord">
+          <ac:chgData name="Mitchell Wand" userId="de9b44c55c049659" providerId="LiveId" clId="{7A9D5940-B2CC-47DD-AF5E-71219F1A1E26}" dt="2026-10-26T18:29:43.947" v="1122" actId="20577"/>
+          <ac:spMkLst>
+            <pc:docMk/>
+            <pc:sldMk cId="988594982" sldId="617"/>
+            <ac:spMk id="8" creationId="{EE854DDD-7450-2A29-3611-B02DA479EEDB}"/>
+          </ac:spMkLst>
+        </pc:spChg>
+        <pc:picChg chg="add mod">
+          <ac:chgData name="Mitchell Wand" userId="de9b44c55c049659" providerId="LiveId" clId="{7A9D5940-B2CC-47DD-AF5E-71219F1A1E26}" dt="2026-10-26T18:25:46.861" v="978" actId="1076"/>
+          <ac:picMkLst>
+            <pc:docMk/>
+            <pc:sldMk cId="988594982" sldId="617"/>
+            <ac:picMk id="5" creationId="{6A73EA38-3064-03FC-3548-B6DF586EA1D5}"/>
+          </ac:picMkLst>
+        </pc:picChg>
+      </pc:sldChg>
+      <pc:sldChg chg="addSp delSp modSp new mod modNotesTx">
+        <pc:chgData name="Mitchell Wand" userId="de9b44c55c049659" providerId="LiveId" clId="{7A9D5940-B2CC-47DD-AF5E-71219F1A1E26}" dt="2026-10-26T18:50:51.287" v="1299" actId="20577"/>
+        <pc:sldMkLst>
+          <pc:docMk/>
+          <pc:sldMk cId="1264209119" sldId="618"/>
+        </pc:sldMkLst>
+        <pc:spChg chg="mod">
+          <ac:chgData name="Mitchell Wand" userId="de9b44c55c049659" providerId="LiveId" clId="{7A9D5940-B2CC-47DD-AF5E-71219F1A1E26}" dt="2026-10-26T18:36:36.935" v="1254" actId="20577"/>
+          <ac:spMkLst>
+            <pc:docMk/>
+            <pc:sldMk cId="1264209119" sldId="618"/>
+            <ac:spMk id="2" creationId="{00BCC61A-47BB-809E-A896-BA4746ABAFFB}"/>
+          </ac:spMkLst>
+        </pc:spChg>
+        <pc:spChg chg="mod">
+          <ac:chgData name="Mitchell Wand" userId="de9b44c55c049659" providerId="LiveId" clId="{7A9D5940-B2CC-47DD-AF5E-71219F1A1E26}" dt="2026-10-26T18:50:51.287" v="1299" actId="20577"/>
+          <ac:spMkLst>
+            <pc:docMk/>
+            <pc:sldMk cId="1264209119" sldId="618"/>
+            <ac:spMk id="3" creationId="{0A982635-02F4-0CA4-157E-05FFE131F791}"/>
+          </ac:spMkLst>
+        </pc:spChg>
+        <pc:spChg chg="add del mod">
+          <ac:chgData name="Mitchell Wand" userId="de9b44c55c049659" providerId="LiveId" clId="{7A9D5940-B2CC-47DD-AF5E-71219F1A1E26}" dt="2026-10-26T18:34:12.004" v="1199" actId="478"/>
+          <ac:spMkLst>
+            <pc:docMk/>
+            <pc:sldMk cId="1264209119" sldId="618"/>
+            <ac:spMk id="6" creationId="{D90C17E2-2B2C-F140-0729-266F616EFB89}"/>
+          </ac:spMkLst>
+        </pc:spChg>
+        <pc:spChg chg="add mod">
+          <ac:chgData name="Mitchell Wand" userId="de9b44c55c049659" providerId="LiveId" clId="{7A9D5940-B2CC-47DD-AF5E-71219F1A1E26}" dt="2026-10-26T18:36:13.182" v="1240" actId="1076"/>
+          <ac:spMkLst>
+            <pc:docMk/>
+            <pc:sldMk cId="1264209119" sldId="618"/>
+            <ac:spMk id="8" creationId="{EBB17C28-A5AB-070B-6971-11BD4BE4C441}"/>
+          </ac:spMkLst>
+        </pc:spChg>
+        <pc:spChg chg="add mod">
+          <ac:chgData name="Mitchell Wand" userId="de9b44c55c049659" providerId="LiveId" clId="{7A9D5940-B2CC-47DD-AF5E-71219F1A1E26}" dt="2026-10-26T18:36:17.412" v="1241" actId="1076"/>
+          <ac:spMkLst>
+            <pc:docMk/>
+            <pc:sldMk cId="1264209119" sldId="618"/>
+            <ac:spMk id="10" creationId="{17117F81-72B1-F1A2-F1E4-6570B982BB24}"/>
+          </ac:spMkLst>
+        </pc:spChg>
+      </pc:sldChg>
     </pc:docChg>
   </pc:docChgLst>
 </pc:chgInfo>
@@ -579,7 +591,7 @@
           <a:p>
             <a:fld id="{7C7E5181-6CF5-45F7-A87A-E0E0B1FD7549}" type="datetimeFigureOut">
               <a:rPr lang="en-US" smtClean="0"/>
-              <a:t>10/20/2026</a:t>
+              <a:t>10/26/2026</a:t>
             </a:fld>
             <a:endParaRPr lang="en-US" dirty="0"/>
           </a:p>
@@ -2728,13 +2740,6 @@
           </p:nvPr>
         </p:nvSpPr>
         <p:spPr/>
-        <p:txBody>
-          <a:bodyPr/>
-          <a:lstStyle/>
-          <a:p>
-            <a:endParaRPr lang="en-US"/>
-          </a:p>
-        </p:txBody>
       </p:sp>
       <p:sp>
         <p:nvSpPr>
@@ -2751,35 +2756,7 @@
           <a:bodyPr/>
           <a:lstStyle/>
           <a:p>
-            <a:r>
-              <a:rPr lang="en-US" dirty="0"/>
-              <a:t>Let’s look at a couple of examples.  In 2018, a malicious version of an </a:t>
-            </a:r>
-            <a:r>
-              <a:rPr lang="en-US" dirty="0" err="1"/>
-              <a:t>eslint</a:t>
-            </a:r>
-            <a:r>
-              <a:rPr lang="en-US" dirty="0"/>
-              <a:t> package called </a:t>
-            </a:r>
-            <a:r>
-              <a:rPr lang="en-US" dirty="0" err="1"/>
-              <a:t>eslint</a:t>
-            </a:r>
-            <a:r>
-              <a:rPr lang="en-US" dirty="0"/>
-              <a:t>-scope was published. This was a quite serious issue.</a:t>
-            </a:r>
-          </a:p>
-          <a:p>
             <a:endParaRPr lang="en-US" dirty="0"/>
-          </a:p>
-          <a:p>
-            <a:r>
-              <a:rPr lang="en-US" dirty="0"/>
-              <a:t>https://eslint.org/blog/2018/07/postmortem-for-malicious-package-publishes/</a:t>
-            </a:r>
           </a:p>
         </p:txBody>
       </p:sp>
@@ -2800,16 +2777,16 @@
           <a:p>
             <a:fld id="{07937F07-1250-4CCE-B198-1B2887014F41}" type="slidenum">
               <a:rPr lang="en-US" smtClean="0"/>
-              <a:t>30</a:t>
+              <a:t>31</a:t>
             </a:fld>
-            <a:endParaRPr lang="en-US"/>
+            <a:endParaRPr lang="en-US" dirty="0"/>
           </a:p>
         </p:txBody>
       </p:sp>
     </p:spTree>
     <p:extLst>
       <p:ext uri="{BB962C8B-B14F-4D97-AF65-F5344CB8AC3E}">
-        <p14:creationId xmlns:p14="http://schemas.microsoft.com/office/powerpoint/2010/main" val="2356916845"/>
+        <p14:creationId xmlns:p14="http://schemas.microsoft.com/office/powerpoint/2010/main" val="1754754629"/>
       </p:ext>
     </p:extLst>
   </p:cSld>
@@ -2872,7 +2849,23 @@
           <a:p>
             <a:r>
               <a:rPr lang="en-US" dirty="0"/>
-              <a:t>Let’s look at the sequence of events, as explained in the post-mortem report on the preceding slide.</a:t>
+              <a:t>Let’s look at a couple of examples.  In 2018, a malicious version of an </a:t>
+            </a:r>
+            <a:r>
+              <a:rPr lang="en-US" dirty="0" err="1"/>
+              <a:t>eslint</a:t>
+            </a:r>
+            <a:r>
+              <a:rPr lang="en-US" dirty="0"/>
+              <a:t> package called </a:t>
+            </a:r>
+            <a:r>
+              <a:rPr lang="en-US" dirty="0" err="1"/>
+              <a:t>eslint</a:t>
+            </a:r>
+            <a:r>
+              <a:rPr lang="en-US" dirty="0"/>
+              <a:t>-scope was published. This was a quite serious issue.</a:t>
             </a:r>
           </a:p>
           <a:p>
@@ -2881,59 +2874,8 @@
           <a:p>
             <a:r>
               <a:rPr lang="en-US" dirty="0"/>
-              <a:t>&lt;Read Slide&gt;</a:t>
-            </a:r>
-          </a:p>
-          <a:p>
-            <a:endParaRPr lang="en-US" dirty="0"/>
-          </a:p>
-          <a:p>
-            <a:r>
-              <a:rPr lang="en-US" dirty="0"/>
-              <a:t>Discuss:  how many violations of good security practices do you see here?</a:t>
-            </a:r>
-          </a:p>
-          <a:p>
-            <a:endParaRPr lang="en-US" dirty="0"/>
-          </a:p>
-          <a:p>
-            <a:pPr marL="228600" indent="-228600">
-              <a:buAutoNum type="arabicPeriod"/>
-            </a:pPr>
-            <a:r>
-              <a:rPr lang="en-US" dirty="0"/>
-              <a:t>The developer used the same password on two different sites</a:t>
-            </a:r>
-          </a:p>
-          <a:p>
-            <a:pPr marL="228600" indent="-228600">
-              <a:buAutoNum type="arabicPeriod"/>
-            </a:pPr>
-            <a:r>
-              <a:rPr lang="en-US" dirty="0"/>
-              <a:t>The other site did not use 2FA</a:t>
-            </a:r>
-          </a:p>
-          <a:p>
-            <a:pPr marL="228600" indent="-228600">
-              <a:buAutoNum type="arabicPeriod"/>
-            </a:pPr>
-            <a:r>
-              <a:rPr lang="en-US" dirty="0"/>
-              <a:t>The other site did something else that allowed the password to leak.</a:t>
-            </a:r>
-          </a:p>
-          <a:p>
-            <a:pPr marL="228600" indent="-228600">
-              <a:buAutoNum type="arabicPeriod"/>
-            </a:pPr>
-            <a:r>
-              <a:rPr lang="en-US" dirty="0"/>
-              <a:t>Users did not protect their packages against silent version updates.</a:t>
-            </a:r>
-          </a:p>
-          <a:p>
-            <a:endParaRPr lang="en-US" dirty="0"/>
+              <a:t>https://eslint.org/blog/2018/07/postmortem-for-malicious-package-publishes/</a:t>
+            </a:r>
           </a:p>
         </p:txBody>
       </p:sp>
@@ -2954,7 +2896,7 @@
           <a:p>
             <a:fld id="{07937F07-1250-4CCE-B198-1B2887014F41}" type="slidenum">
               <a:rPr lang="en-US" smtClean="0"/>
-              <a:t>31</a:t>
+              <a:t>32</a:t>
             </a:fld>
             <a:endParaRPr lang="en-US"/>
           </a:p>
@@ -2963,7 +2905,7 @@
     </p:spTree>
     <p:extLst>
       <p:ext uri="{BB962C8B-B14F-4D97-AF65-F5344CB8AC3E}">
-        <p14:creationId xmlns:p14="http://schemas.microsoft.com/office/powerpoint/2010/main" val="245557564"/>
+        <p14:creationId xmlns:p14="http://schemas.microsoft.com/office/powerpoint/2010/main" val="2356916845"/>
       </p:ext>
     </p:extLst>
   </p:cSld>
@@ -3000,6 +2942,160 @@
             <p:ph type="sldImg"/>
           </p:nvPr>
         </p:nvSpPr>
+        <p:spPr/>
+        <p:txBody>
+          <a:bodyPr/>
+          <a:lstStyle/>
+          <a:p>
+            <a:endParaRPr lang="en-US"/>
+          </a:p>
+        </p:txBody>
+      </p:sp>
+      <p:sp>
+        <p:nvSpPr>
+          <p:cNvPr id="3" name="Notes Placeholder 2"/>
+          <p:cNvSpPr>
+            <a:spLocks noGrp="1"/>
+          </p:cNvSpPr>
+          <p:nvPr>
+            <p:ph type="body" idx="1"/>
+          </p:nvPr>
+        </p:nvSpPr>
+        <p:spPr/>
+        <p:txBody>
+          <a:bodyPr/>
+          <a:lstStyle/>
+          <a:p>
+            <a:r>
+              <a:rPr lang="en-US" dirty="0"/>
+              <a:t>Let’s look at the sequence of events, as explained in the post-mortem report on the preceding slide.</a:t>
+            </a:r>
+          </a:p>
+          <a:p>
+            <a:endParaRPr lang="en-US" dirty="0"/>
+          </a:p>
+          <a:p>
+            <a:r>
+              <a:rPr lang="en-US" dirty="0"/>
+              <a:t>&lt;Read Slide&gt;</a:t>
+            </a:r>
+          </a:p>
+          <a:p>
+            <a:endParaRPr lang="en-US" dirty="0"/>
+          </a:p>
+          <a:p>
+            <a:r>
+              <a:rPr lang="en-US" dirty="0"/>
+              <a:t>Discuss:  how many violations of good security practices do you see here?</a:t>
+            </a:r>
+          </a:p>
+          <a:p>
+            <a:endParaRPr lang="en-US" dirty="0"/>
+          </a:p>
+          <a:p>
+            <a:pPr marL="228600" indent="-228600">
+              <a:buAutoNum type="arabicPeriod"/>
+            </a:pPr>
+            <a:r>
+              <a:rPr lang="en-US" dirty="0"/>
+              <a:t>The developer used the same password on two different sites</a:t>
+            </a:r>
+          </a:p>
+          <a:p>
+            <a:pPr marL="228600" indent="-228600">
+              <a:buAutoNum type="arabicPeriod"/>
+            </a:pPr>
+            <a:r>
+              <a:rPr lang="en-US" dirty="0"/>
+              <a:t>The other site did not use 2FA</a:t>
+            </a:r>
+          </a:p>
+          <a:p>
+            <a:pPr marL="228600" indent="-228600">
+              <a:buAutoNum type="arabicPeriod"/>
+            </a:pPr>
+            <a:r>
+              <a:rPr lang="en-US" dirty="0"/>
+              <a:t>The other site did something else that allowed the password to leak.</a:t>
+            </a:r>
+          </a:p>
+          <a:p>
+            <a:pPr marL="228600" indent="-228600">
+              <a:buAutoNum type="arabicPeriod"/>
+            </a:pPr>
+            <a:r>
+              <a:rPr lang="en-US" dirty="0"/>
+              <a:t>Users did not protect their packages against silent version updates.</a:t>
+            </a:r>
+          </a:p>
+          <a:p>
+            <a:endParaRPr lang="en-US" dirty="0"/>
+          </a:p>
+        </p:txBody>
+      </p:sp>
+      <p:sp>
+        <p:nvSpPr>
+          <p:cNvPr id="4" name="Slide Number Placeholder 3"/>
+          <p:cNvSpPr>
+            <a:spLocks noGrp="1"/>
+          </p:cNvSpPr>
+          <p:nvPr>
+            <p:ph type="sldNum" sz="quarter" idx="5"/>
+          </p:nvPr>
+        </p:nvSpPr>
+        <p:spPr/>
+        <p:txBody>
+          <a:bodyPr/>
+          <a:lstStyle/>
+          <a:p>
+            <a:fld id="{07937F07-1250-4CCE-B198-1B2887014F41}" type="slidenum">
+              <a:rPr lang="en-US" smtClean="0"/>
+              <a:t>33</a:t>
+            </a:fld>
+            <a:endParaRPr lang="en-US"/>
+          </a:p>
+        </p:txBody>
+      </p:sp>
+    </p:spTree>
+    <p:extLst>
+      <p:ext uri="{BB962C8B-B14F-4D97-AF65-F5344CB8AC3E}">
+        <p14:creationId xmlns:p14="http://schemas.microsoft.com/office/powerpoint/2010/main" val="245557564"/>
+      </p:ext>
+    </p:extLst>
+  </p:cSld>
+  <p:clrMapOvr>
+    <a:masterClrMapping/>
+  </p:clrMapOvr>
+</p:notes>
+</file>
+
+<file path=ppt/notesSlides/notesSlide26.xml><?xml version="1.0" encoding="utf-8"?>
+<p:notes xmlns:a="http://schemas.openxmlformats.org/drawingml/2006/main" xmlns:r="http://schemas.openxmlformats.org/officeDocument/2006/relationships" xmlns:p="http://schemas.openxmlformats.org/presentationml/2006/main">
+  <p:cSld>
+    <p:spTree>
+      <p:nvGrpSpPr>
+        <p:cNvPr id="1" name=""/>
+        <p:cNvGrpSpPr/>
+        <p:nvPr/>
+      </p:nvGrpSpPr>
+      <p:grpSpPr>
+        <a:xfrm>
+          <a:off x="0" y="0"/>
+          <a:ext cx="0" cy="0"/>
+          <a:chOff x="0" y="0"/>
+          <a:chExt cx="0" cy="0"/>
+        </a:xfrm>
+      </p:grpSpPr>
+      <p:sp>
+        <p:nvSpPr>
+          <p:cNvPr id="2" name="Slide Image Placeholder 1"/>
+          <p:cNvSpPr>
+            <a:spLocks noGrp="1" noRot="1" noChangeAspect="1"/>
+          </p:cNvSpPr>
+          <p:nvPr>
+            <p:ph type="sldImg"/>
+          </p:nvPr>
+        </p:nvSpPr>
         <p:spPr>
           <a:xfrm>
             <a:off x="381000" y="685800"/>
@@ -3052,7 +3148,7 @@
 </p:notes>
 </file>
 
-<file path=ppt/notesSlides/notesSlide26.xml><?xml version="1.0" encoding="utf-8"?>
+<file path=ppt/notesSlides/notesSlide27.xml><?xml version="1.0" encoding="utf-8"?>
 <p:notes xmlns:a="http://schemas.openxmlformats.org/drawingml/2006/main" xmlns:r="http://schemas.openxmlformats.org/officeDocument/2006/relationships" xmlns:p="http://schemas.openxmlformats.org/presentationml/2006/main">
   <p:cSld>
     <p:spTree>
@@ -3151,7 +3247,7 @@
           <a:p>
             <a:fld id="{07937F07-1250-4CCE-B198-1B2887014F41}" type="slidenum">
               <a:rPr lang="en-US" smtClean="0"/>
-              <a:t>33</a:t>
+              <a:t>35</a:t>
             </a:fld>
             <a:endParaRPr lang="en-US"/>
           </a:p>
@@ -3161,106 +3257,6 @@
     <p:extLst>
       <p:ext uri="{BB962C8B-B14F-4D97-AF65-F5344CB8AC3E}">
         <p14:creationId xmlns:p14="http://schemas.microsoft.com/office/powerpoint/2010/main" val="3874064985"/>
-      </p:ext>
-    </p:extLst>
-  </p:cSld>
-  <p:clrMapOvr>
-    <a:masterClrMapping/>
-  </p:clrMapOvr>
-</p:notes>
-</file>
-
-<file path=ppt/notesSlides/notesSlide27.xml><?xml version="1.0" encoding="utf-8"?>
-<p:notes xmlns:a="http://schemas.openxmlformats.org/drawingml/2006/main" xmlns:r="http://schemas.openxmlformats.org/officeDocument/2006/relationships" xmlns:p="http://schemas.openxmlformats.org/presentationml/2006/main">
-  <p:cSld>
-    <p:spTree>
-      <p:nvGrpSpPr>
-        <p:cNvPr id="1" name=""/>
-        <p:cNvGrpSpPr/>
-        <p:nvPr/>
-      </p:nvGrpSpPr>
-      <p:grpSpPr>
-        <a:xfrm>
-          <a:off x="0" y="0"/>
-          <a:ext cx="0" cy="0"/>
-          <a:chOff x="0" y="0"/>
-          <a:chExt cx="0" cy="0"/>
-        </a:xfrm>
-      </p:grpSpPr>
-      <p:sp>
-        <p:nvSpPr>
-          <p:cNvPr id="2" name="Slide Image Placeholder 1"/>
-          <p:cNvSpPr>
-            <a:spLocks noGrp="1" noRot="1" noChangeAspect="1"/>
-          </p:cNvSpPr>
-          <p:nvPr>
-            <p:ph type="sldImg"/>
-          </p:nvPr>
-        </p:nvSpPr>
-        <p:spPr/>
-        <p:txBody>
-          <a:bodyPr/>
-          <a:lstStyle/>
-          <a:p>
-            <a:endParaRPr lang="en-US"/>
-          </a:p>
-        </p:txBody>
-      </p:sp>
-      <p:sp>
-        <p:nvSpPr>
-          <p:cNvPr id="3" name="Notes Placeholder 2"/>
-          <p:cNvSpPr>
-            <a:spLocks noGrp="1"/>
-          </p:cNvSpPr>
-          <p:nvPr>
-            <p:ph type="body" idx="1"/>
-          </p:nvPr>
-        </p:nvSpPr>
-        <p:spPr/>
-        <p:txBody>
-          <a:bodyPr/>
-          <a:lstStyle/>
-          <a:p>
-            <a:r>
-              <a:rPr lang="en-US" dirty="0"/>
-              <a:t>Prof. Wand says:  I received two letters like this from two of my financial institutions within a week.</a:t>
-            </a:r>
-          </a:p>
-          <a:p>
-            <a:endParaRPr lang="en-US" dirty="0"/>
-          </a:p>
-          <a:p>
-            <a:endParaRPr lang="en-US" dirty="0"/>
-          </a:p>
-        </p:txBody>
-      </p:sp>
-      <p:sp>
-        <p:nvSpPr>
-          <p:cNvPr id="4" name="Slide Number Placeholder 3"/>
-          <p:cNvSpPr>
-            <a:spLocks noGrp="1"/>
-          </p:cNvSpPr>
-          <p:nvPr>
-            <p:ph type="sldNum" sz="quarter" idx="5"/>
-          </p:nvPr>
-        </p:nvSpPr>
-        <p:spPr/>
-        <p:txBody>
-          <a:bodyPr/>
-          <a:lstStyle/>
-          <a:p>
-            <a:fld id="{07937F07-1250-4CCE-B198-1B2887014F41}" type="slidenum">
-              <a:rPr lang="en-US" smtClean="0"/>
-              <a:t>34</a:t>
-            </a:fld>
-            <a:endParaRPr lang="en-US"/>
-          </a:p>
-        </p:txBody>
-      </p:sp>
-    </p:spTree>
-    <p:extLst>
-      <p:ext uri="{BB962C8B-B14F-4D97-AF65-F5344CB8AC3E}">
-        <p14:creationId xmlns:p14="http://schemas.microsoft.com/office/powerpoint/2010/main" val="1553005337"/>
       </p:ext>
     </p:extLst>
   </p:cSld>
@@ -3323,70 +3319,14 @@
           <a:p>
             <a:r>
               <a:rPr lang="en-US" dirty="0"/>
-              <a:t>Of course, supply-chain security risks include more than just software.  Your suppliers are subject to regulatory risks, transportation risks, </a:t>
-            </a:r>
-            <a:r>
-              <a:rPr lang="en-US" dirty="0" err="1"/>
-              <a:t>etc</a:t>
-            </a:r>
-            <a:r>
-              <a:rPr lang="en-US" dirty="0"/>
-              <a:t>, etc.  Will your supplier in West </a:t>
-            </a:r>
-            <a:r>
-              <a:rPr lang="en-US" dirty="0" err="1"/>
-              <a:t>Arstotzka</a:t>
-            </a:r>
-            <a:r>
-              <a:rPr lang="en-US" dirty="0"/>
-              <a:t> (*) be taken over by the government, or overrun by mercenaries or rioters?</a:t>
+              <a:t>Prof. Wand says:  I received two letters like this from two of my financial institutions within a week.</a:t>
             </a:r>
           </a:p>
           <a:p>
             <a:endParaRPr lang="en-US" dirty="0"/>
           </a:p>
           <a:p>
-            <a:pPr marL="0" marR="0" lvl="0" indent="0" algn="l" defTabSz="914400" rtl="0" eaLnBrk="1" fontAlgn="auto" latinLnBrk="0" hangingPunct="1">
-              <a:lnSpc>
-                <a:spcPct val="100000"/>
-              </a:lnSpc>
-              <a:spcBef>
-                <a:spcPts val="0"/>
-              </a:spcBef>
-              <a:spcAft>
-                <a:spcPts val="0"/>
-              </a:spcAft>
-              <a:buClrTx/>
-              <a:buSzTx/>
-              <a:buFontTx/>
-              <a:buNone/>
-              <a:tabLst/>
-              <a:defRPr/>
-            </a:pPr>
-            <a:r>
-              <a:rPr lang="en-US" dirty="0"/>
-              <a:t>So of course there are consultants to help you manage all that. Here’s the web page of one such firm. (found after 30 seconds of googling)</a:t>
-            </a:r>
-          </a:p>
-          <a:p>
             <a:endParaRPr lang="en-US" dirty="0"/>
-          </a:p>
-          <a:p>
-            <a:endParaRPr lang="en-US" dirty="0"/>
-          </a:p>
-          <a:p>
-            <a:r>
-              <a:rPr lang="en-US" dirty="0"/>
-              <a:t>[* </a:t>
-            </a:r>
-            <a:r>
-              <a:rPr lang="en-US" dirty="0" err="1"/>
-              <a:t>Arstzoska</a:t>
-            </a:r>
-            <a:r>
-              <a:rPr lang="en-US" dirty="0"/>
-              <a:t> is the name of a fictional country I  found on Wikipedia]</a:t>
-            </a:r>
           </a:p>
         </p:txBody>
       </p:sp>
@@ -3407,7 +3347,7 @@
           <a:p>
             <a:fld id="{07937F07-1250-4CCE-B198-1B2887014F41}" type="slidenum">
               <a:rPr lang="en-US" smtClean="0"/>
-              <a:t>35</a:t>
+              <a:t>36</a:t>
             </a:fld>
             <a:endParaRPr lang="en-US"/>
           </a:p>
@@ -3416,7 +3356,7 @@
     </p:spTree>
     <p:extLst>
       <p:ext uri="{BB962C8B-B14F-4D97-AF65-F5344CB8AC3E}">
-        <p14:creationId xmlns:p14="http://schemas.microsoft.com/office/powerpoint/2010/main" val="998101155"/>
+        <p14:creationId xmlns:p14="http://schemas.microsoft.com/office/powerpoint/2010/main" val="1553005337"/>
       </p:ext>
     </p:extLst>
   </p:cSld>
@@ -3453,12 +3393,7 @@
             <p:ph type="sldImg"/>
           </p:nvPr>
         </p:nvSpPr>
-        <p:spPr>
-          <a:xfrm>
-            <a:off x="381000" y="685800"/>
-            <a:ext cx="6096000" cy="3429000"/>
-          </a:xfrm>
-        </p:spPr>
+        <p:spPr/>
         <p:txBody>
           <a:bodyPr/>
           <a:lstStyle/>
@@ -3484,60 +3419,100 @@
           <a:p>
             <a:r>
               <a:rPr lang="en-US" dirty="0"/>
-              <a:t>While we could easily solve problems in our own code by bolting on some useful additional components (like using SSL), it’s not so easy to solve threats to our software supply chain process – there need to be process-based solutions for these process-based problems.</a:t>
+              <a:t>Of course, supply-chain security risks include more than just software.  Your suppliers are subject to regulatory risks, transportation risks, </a:t>
+            </a:r>
+            <a:r>
+              <a:rPr lang="en-US" dirty="0" err="1"/>
+              <a:t>etc</a:t>
+            </a:r>
+            <a:r>
+              <a:rPr lang="en-US" dirty="0"/>
+              <a:t>, etc.  Will your supplier in West </a:t>
+            </a:r>
+            <a:r>
+              <a:rPr lang="en-US" dirty="0" err="1"/>
+              <a:t>Arstotzka</a:t>
+            </a:r>
+            <a:r>
+              <a:rPr lang="en-US" dirty="0"/>
+              <a:t> (*) be taken over by the government, or overrun by mercenaries or rioters?</a:t>
             </a:r>
           </a:p>
           <a:p>
             <a:endParaRPr lang="en-US" dirty="0"/>
           </a:p>
           <a:p>
-            <a:r>
-              <a:rPr lang="en-US" dirty="0"/>
-              <a:t>These kinds of threats are currently some of the most-talked about (and most feared) because they are complex to defend against.</a:t>
+            <a:pPr marL="0" marR="0" lvl="0" indent="0" algn="l" defTabSz="914400" rtl="0" eaLnBrk="1" fontAlgn="auto" latinLnBrk="0" hangingPunct="1">
+              <a:lnSpc>
+                <a:spcPct val="100000"/>
+              </a:lnSpc>
+              <a:spcBef>
+                <a:spcPts val="0"/>
+              </a:spcBef>
+              <a:spcAft>
+                <a:spcPts val="0"/>
+              </a:spcAft>
+              <a:buClrTx/>
+              <a:buSzTx/>
+              <a:buFontTx/>
+              <a:buNone/>
+              <a:tabLst/>
+              <a:defRPr/>
+            </a:pPr>
+            <a:r>
+              <a:rPr lang="en-US" dirty="0"/>
+              <a:t>So of course there are consultants to help you manage all that. Here’s the web page of one such firm. (found after 30 seconds of googling)</a:t>
             </a:r>
           </a:p>
           <a:p>
             <a:endParaRPr lang="en-US" dirty="0"/>
           </a:p>
           <a:p>
-            <a:r>
-              <a:rPr lang="en-US" dirty="0"/>
-              <a:t>For example: how do we audit dependencies? Who does that, and when? What is “secure enough” for a dependency?</a:t>
-            </a:r>
-          </a:p>
-          <a:p>
             <a:endParaRPr lang="en-US" dirty="0"/>
           </a:p>
           <a:p>
             <a:r>
               <a:rPr lang="en-US" dirty="0"/>
-              <a:t>Who loves needing to do 2FA for every time you sign into canvas? How much worse is it if you had to do it for each git commit?</a:t>
-            </a:r>
-          </a:p>
-          <a:p>
-            <a:endParaRPr lang="en-US" dirty="0"/>
-          </a:p>
-          <a:p>
-            <a:r>
-              <a:rPr lang="en-US" dirty="0"/>
-              <a:t>Signatures are useful only insofar as we trust the signer. If a developer’s computer is compromised (say, through a phishing attack), what good is that signature? Same for distribution.</a:t>
-            </a:r>
-          </a:p>
-          <a:p>
-            <a:endParaRPr lang="en-US" dirty="0"/>
-          </a:p>
-          <a:p>
-            <a:r>
-              <a:rPr lang="en-US" dirty="0"/>
-              <a:t>Perhaps the best news-you-can-use here is to isolate each application in its own container or VM, reducing the scope of security breaches to be isolated within that environment and not directly impacting other applications.</a:t>
-            </a:r>
+              <a:t>[* </a:t>
+            </a:r>
+            <a:r>
+              <a:rPr lang="en-US" dirty="0" err="1"/>
+              <a:t>Arstzoska</a:t>
+            </a:r>
+            <a:r>
+              <a:rPr lang="en-US" dirty="0"/>
+              <a:t> is the name of a fictional country I  found on Wikipedia]</a:t>
+            </a:r>
+          </a:p>
+        </p:txBody>
+      </p:sp>
+      <p:sp>
+        <p:nvSpPr>
+          <p:cNvPr id="4" name="Slide Number Placeholder 3"/>
+          <p:cNvSpPr>
+            <a:spLocks noGrp="1"/>
+          </p:cNvSpPr>
+          <p:nvPr>
+            <p:ph type="sldNum" sz="quarter" idx="5"/>
+          </p:nvPr>
+        </p:nvSpPr>
+        <p:spPr/>
+        <p:txBody>
+          <a:bodyPr/>
+          <a:lstStyle/>
+          <a:p>
+            <a:fld id="{07937F07-1250-4CCE-B198-1B2887014F41}" type="slidenum">
+              <a:rPr lang="en-US" smtClean="0"/>
+              <a:t>37</a:t>
+            </a:fld>
+            <a:endParaRPr lang="en-US"/>
           </a:p>
         </p:txBody>
       </p:sp>
     </p:spTree>
     <p:extLst>
       <p:ext uri="{BB962C8B-B14F-4D97-AF65-F5344CB8AC3E}">
-        <p14:creationId xmlns:p14="http://schemas.microsoft.com/office/powerpoint/2010/main" val="3460412528"/>
+        <p14:creationId xmlns:p14="http://schemas.microsoft.com/office/powerpoint/2010/main" val="998101155"/>
       </p:ext>
     </p:extLst>
   </p:cSld>
@@ -3707,64 +3682,91 @@
             <p:ph type="sldImg"/>
           </p:nvPr>
         </p:nvSpPr>
+        <p:spPr>
+          <a:xfrm>
+            <a:off x="381000" y="685800"/>
+            <a:ext cx="6096000" cy="3429000"/>
+          </a:xfrm>
+        </p:spPr>
+        <p:txBody>
+          <a:bodyPr/>
+          <a:lstStyle/>
+          <a:p>
+            <a:endParaRPr lang="en-US"/>
+          </a:p>
+        </p:txBody>
+      </p:sp>
+      <p:sp>
+        <p:nvSpPr>
+          <p:cNvPr id="3" name="Notes Placeholder 2"/>
+          <p:cNvSpPr>
+            <a:spLocks noGrp="1"/>
+          </p:cNvSpPr>
+          <p:nvPr>
+            <p:ph type="body" idx="1"/>
+          </p:nvPr>
+        </p:nvSpPr>
         <p:spPr/>
         <p:txBody>
           <a:bodyPr/>
           <a:lstStyle/>
           <a:p>
-            <a:endParaRPr lang="en-US"/>
-          </a:p>
-        </p:txBody>
-      </p:sp>
-      <p:sp>
-        <p:nvSpPr>
-          <p:cNvPr id="3" name="Notes Placeholder 2"/>
-          <p:cNvSpPr>
-            <a:spLocks noGrp="1"/>
-          </p:cNvSpPr>
-          <p:nvPr>
-            <p:ph type="body" idx="1"/>
-          </p:nvPr>
-        </p:nvSpPr>
-        <p:spPr/>
-        <p:txBody>
-          <a:bodyPr/>
-          <a:lstStyle/>
-          <a:p>
-            <a:r>
-              <a:rPr lang="en-US" dirty="0"/>
-              <a:t>This brings us to the third item in our outline (from way back on slide 3)</a:t>
-            </a:r>
-          </a:p>
-        </p:txBody>
-      </p:sp>
-      <p:sp>
-        <p:nvSpPr>
-          <p:cNvPr id="4" name="Slide Number Placeholder 3"/>
-          <p:cNvSpPr>
-            <a:spLocks noGrp="1"/>
-          </p:cNvSpPr>
-          <p:nvPr>
-            <p:ph type="sldNum" sz="quarter" idx="5"/>
-          </p:nvPr>
-        </p:nvSpPr>
-        <p:spPr/>
-        <p:txBody>
-          <a:bodyPr/>
-          <a:lstStyle/>
-          <a:p>
-            <a:fld id="{07937F07-1250-4CCE-B198-1B2887014F41}" type="slidenum">
-              <a:rPr lang="en-US" smtClean="0"/>
-              <a:t>37</a:t>
-            </a:fld>
-            <a:endParaRPr lang="en-US"/>
+            <a:r>
+              <a:rPr lang="en-US" dirty="0"/>
+              <a:t>While we could easily solve problems in our own code by bolting on some useful additional components (like using SSL), it’s not so easy to solve threats to our software supply chain process – there need to be process-based solutions for these process-based problems.</a:t>
+            </a:r>
+          </a:p>
+          <a:p>
+            <a:endParaRPr lang="en-US" dirty="0"/>
+          </a:p>
+          <a:p>
+            <a:r>
+              <a:rPr lang="en-US" dirty="0"/>
+              <a:t>These kinds of threats are currently some of the most-talked about (and most feared) because they are complex to defend against.</a:t>
+            </a:r>
+          </a:p>
+          <a:p>
+            <a:endParaRPr lang="en-US" dirty="0"/>
+          </a:p>
+          <a:p>
+            <a:r>
+              <a:rPr lang="en-US" dirty="0"/>
+              <a:t>For example: how do we audit dependencies? Who does that, and when? What is “secure enough” for a dependency?</a:t>
+            </a:r>
+          </a:p>
+          <a:p>
+            <a:endParaRPr lang="en-US" dirty="0"/>
+          </a:p>
+          <a:p>
+            <a:r>
+              <a:rPr lang="en-US" dirty="0"/>
+              <a:t>Who loves needing to do 2FA for every time you sign into canvas? How much worse is it if you had to do it for each git commit?</a:t>
+            </a:r>
+          </a:p>
+          <a:p>
+            <a:endParaRPr lang="en-US" dirty="0"/>
+          </a:p>
+          <a:p>
+            <a:r>
+              <a:rPr lang="en-US" dirty="0"/>
+              <a:t>Signatures are useful only insofar as we trust the signer. If a developer’s computer is compromised (say, through a phishing attack), what good is that signature? Same for distribution.</a:t>
+            </a:r>
+          </a:p>
+          <a:p>
+            <a:endParaRPr lang="en-US" dirty="0"/>
+          </a:p>
+          <a:p>
+            <a:r>
+              <a:rPr lang="en-US" dirty="0"/>
+              <a:t>Perhaps the best news-you-can-use here is to isolate each application in its own container or VM, reducing the scope of security breaches to be isolated within that environment and not directly impacting other applications.</a:t>
+            </a:r>
           </a:p>
         </p:txBody>
       </p:sp>
     </p:spTree>
     <p:extLst>
       <p:ext uri="{BB962C8B-B14F-4D97-AF65-F5344CB8AC3E}">
-        <p14:creationId xmlns:p14="http://schemas.microsoft.com/office/powerpoint/2010/main" val="1754828707"/>
+        <p14:creationId xmlns:p14="http://schemas.microsoft.com/office/powerpoint/2010/main" val="3460412528"/>
       </p:ext>
     </p:extLst>
   </p:cSld>
@@ -3827,20 +3829,8 @@
           <a:p>
             <a:r>
               <a:rPr lang="en-US" dirty="0"/>
-              <a:t>As David Blank-Edelman(*) used to say: “the solution is in front of the screen, not behind it.”</a:t>
-            </a:r>
-          </a:p>
-          <a:p>
-            <a:endParaRPr lang="en-US" dirty="0"/>
-          </a:p>
-          <a:p>
-            <a:r>
-              <a:rPr lang="en-US" dirty="0"/>
-              <a:t>(*) former head of Systems at Khoury</a:t>
-            </a:r>
-          </a:p>
-          <a:p>
-            <a:endParaRPr lang="en-US" dirty="0"/>
+              <a:t>This brings us to the third item in our outline (from way back on slide 3)</a:t>
+            </a:r>
           </a:p>
         </p:txBody>
       </p:sp>
@@ -3861,7 +3851,113 @@
           <a:p>
             <a:fld id="{07937F07-1250-4CCE-B198-1B2887014F41}" type="slidenum">
               <a:rPr lang="en-US" smtClean="0"/>
-              <a:t>38</a:t>
+              <a:t>39</a:t>
+            </a:fld>
+            <a:endParaRPr lang="en-US"/>
+          </a:p>
+        </p:txBody>
+      </p:sp>
+    </p:spTree>
+    <p:extLst>
+      <p:ext uri="{BB962C8B-B14F-4D97-AF65-F5344CB8AC3E}">
+        <p14:creationId xmlns:p14="http://schemas.microsoft.com/office/powerpoint/2010/main" val="1754828707"/>
+      </p:ext>
+    </p:extLst>
+  </p:cSld>
+  <p:clrMapOvr>
+    <a:masterClrMapping/>
+  </p:clrMapOvr>
+</p:notes>
+</file>
+
+<file path=ppt/notesSlides/notesSlide32.xml><?xml version="1.0" encoding="utf-8"?>
+<p:notes xmlns:a="http://schemas.openxmlformats.org/drawingml/2006/main" xmlns:r="http://schemas.openxmlformats.org/officeDocument/2006/relationships" xmlns:p="http://schemas.openxmlformats.org/presentationml/2006/main">
+  <p:cSld>
+    <p:spTree>
+      <p:nvGrpSpPr>
+        <p:cNvPr id="1" name=""/>
+        <p:cNvGrpSpPr/>
+        <p:nvPr/>
+      </p:nvGrpSpPr>
+      <p:grpSpPr>
+        <a:xfrm>
+          <a:off x="0" y="0"/>
+          <a:ext cx="0" cy="0"/>
+          <a:chOff x="0" y="0"/>
+          <a:chExt cx="0" cy="0"/>
+        </a:xfrm>
+      </p:grpSpPr>
+      <p:sp>
+        <p:nvSpPr>
+          <p:cNvPr id="2" name="Slide Image Placeholder 1"/>
+          <p:cNvSpPr>
+            <a:spLocks noGrp="1" noRot="1" noChangeAspect="1"/>
+          </p:cNvSpPr>
+          <p:nvPr>
+            <p:ph type="sldImg"/>
+          </p:nvPr>
+        </p:nvSpPr>
+        <p:spPr/>
+        <p:txBody>
+          <a:bodyPr/>
+          <a:lstStyle/>
+          <a:p>
+            <a:endParaRPr lang="en-US"/>
+          </a:p>
+        </p:txBody>
+      </p:sp>
+      <p:sp>
+        <p:nvSpPr>
+          <p:cNvPr id="3" name="Notes Placeholder 2"/>
+          <p:cNvSpPr>
+            <a:spLocks noGrp="1"/>
+          </p:cNvSpPr>
+          <p:nvPr>
+            <p:ph type="body" idx="1"/>
+          </p:nvPr>
+        </p:nvSpPr>
+        <p:spPr/>
+        <p:txBody>
+          <a:bodyPr/>
+          <a:lstStyle/>
+          <a:p>
+            <a:r>
+              <a:rPr lang="en-US" dirty="0"/>
+              <a:t>As David Blank-Edelman(*) used to say: “the solution is in front of the screen, not behind it.”</a:t>
+            </a:r>
+          </a:p>
+          <a:p>
+            <a:endParaRPr lang="en-US" dirty="0"/>
+          </a:p>
+          <a:p>
+            <a:r>
+              <a:rPr lang="en-US" dirty="0"/>
+              <a:t>(*) former head of Systems at Khoury</a:t>
+            </a:r>
+          </a:p>
+          <a:p>
+            <a:endParaRPr lang="en-US" dirty="0"/>
+          </a:p>
+        </p:txBody>
+      </p:sp>
+      <p:sp>
+        <p:nvSpPr>
+          <p:cNvPr id="4" name="Slide Number Placeholder 3"/>
+          <p:cNvSpPr>
+            <a:spLocks noGrp="1"/>
+          </p:cNvSpPr>
+          <p:nvPr>
+            <p:ph type="sldNum" sz="quarter" idx="5"/>
+          </p:nvPr>
+        </p:nvSpPr>
+        <p:spPr/>
+        <p:txBody>
+          <a:bodyPr/>
+          <a:lstStyle/>
+          <a:p>
+            <a:fld id="{07937F07-1250-4CCE-B198-1B2887014F41}" type="slidenum">
+              <a:rPr lang="en-US" smtClean="0"/>
+              <a:t>40</a:t>
             </a:fld>
             <a:endParaRPr lang="en-US"/>
           </a:p>
@@ -3880,7 +3976,7 @@
 </p:notes>
 </file>
 
-<file path=ppt/notesSlides/notesSlide32.xml><?xml version="1.0" encoding="utf-8"?>
+<file path=ppt/notesSlides/notesSlide33.xml><?xml version="1.0" encoding="utf-8"?>
 <p:notes xmlns:a="http://schemas.openxmlformats.org/drawingml/2006/main" xmlns:r="http://schemas.openxmlformats.org/officeDocument/2006/relationships" xmlns:p="http://schemas.openxmlformats.org/presentationml/2006/main">
   <p:cSld>
     <p:spTree>
@@ -3979,7 +4075,7 @@
           <a:p>
             <a:fld id="{07937F07-1250-4CCE-B198-1B2887014F41}" type="slidenum">
               <a:rPr lang="en-US" smtClean="0"/>
-              <a:t>39</a:t>
+              <a:t>41</a:t>
             </a:fld>
             <a:endParaRPr lang="en-US"/>
           </a:p>
@@ -3998,7 +4094,7 @@
 </p:notes>
 </file>
 
-<file path=ppt/notesSlides/notesSlide33.xml><?xml version="1.0" encoding="utf-8"?>
+<file path=ppt/notesSlides/notesSlide34.xml><?xml version="1.0" encoding="utf-8"?>
 <p:notes xmlns:a="http://schemas.openxmlformats.org/drawingml/2006/main" xmlns:r="http://schemas.openxmlformats.org/officeDocument/2006/relationships" xmlns:p="http://schemas.openxmlformats.org/presentationml/2006/main">
   <p:cSld>
     <p:spTree>
@@ -4082,124 +4178,6 @@
     <p:extLst>
       <p:ext uri="{BB962C8B-B14F-4D97-AF65-F5344CB8AC3E}">
         <p14:creationId xmlns:p14="http://schemas.microsoft.com/office/powerpoint/2010/main" val="4036773944"/>
-      </p:ext>
-    </p:extLst>
-  </p:cSld>
-  <p:clrMapOvr>
-    <a:masterClrMapping/>
-  </p:clrMapOvr>
-</p:notes>
-</file>
-
-<file path=ppt/notesSlides/notesSlide34.xml><?xml version="1.0" encoding="utf-8"?>
-<p:notes xmlns:a="http://schemas.openxmlformats.org/drawingml/2006/main" xmlns:r="http://schemas.openxmlformats.org/officeDocument/2006/relationships" xmlns:p="http://schemas.openxmlformats.org/presentationml/2006/main">
-  <p:cSld>
-    <p:spTree>
-      <p:nvGrpSpPr>
-        <p:cNvPr id="1" name="">
-          <a:extLst>
-            <a:ext uri="{FF2B5EF4-FFF2-40B4-BE49-F238E27FC236}">
-              <a16:creationId xmlns:a16="http://schemas.microsoft.com/office/drawing/2014/main" id="{F7B2264C-DFEB-53E4-5B35-4BC6D2449264}"/>
-            </a:ext>
-          </a:extLst>
-        </p:cNvPr>
-        <p:cNvGrpSpPr/>
-        <p:nvPr/>
-      </p:nvGrpSpPr>
-      <p:grpSpPr>
-        <a:xfrm>
-          <a:off x="0" y="0"/>
-          <a:ext cx="0" cy="0"/>
-          <a:chOff x="0" y="0"/>
-          <a:chExt cx="0" cy="0"/>
-        </a:xfrm>
-      </p:grpSpPr>
-      <p:sp>
-        <p:nvSpPr>
-          <p:cNvPr id="2" name="Slide Image Placeholder 1">
-            <a:extLst>
-              <a:ext uri="{FF2B5EF4-FFF2-40B4-BE49-F238E27FC236}">
-                <a16:creationId xmlns:a16="http://schemas.microsoft.com/office/drawing/2014/main" id="{50D9F692-70A1-39A9-0EC0-C3C08A93BF2A}"/>
-              </a:ext>
-            </a:extLst>
-          </p:cNvPr>
-          <p:cNvSpPr>
-            <a:spLocks noGrp="1" noRot="1" noChangeAspect="1"/>
-          </p:cNvSpPr>
-          <p:nvPr>
-            <p:ph type="sldImg"/>
-          </p:nvPr>
-        </p:nvSpPr>
-        <p:spPr/>
-        <p:txBody>
-          <a:bodyPr/>
-          <a:lstStyle/>
-          <a:p>
-            <a:endParaRPr lang="en-US"/>
-          </a:p>
-        </p:txBody>
-      </p:sp>
-      <p:sp>
-        <p:nvSpPr>
-          <p:cNvPr id="3" name="Notes Placeholder 2">
-            <a:extLst>
-              <a:ext uri="{FF2B5EF4-FFF2-40B4-BE49-F238E27FC236}">
-                <a16:creationId xmlns:a16="http://schemas.microsoft.com/office/drawing/2014/main" id="{AB0DF6A1-3525-9D88-A1F3-DB794DC15C53}"/>
-              </a:ext>
-            </a:extLst>
-          </p:cNvPr>
-          <p:cNvSpPr>
-            <a:spLocks noGrp="1"/>
-          </p:cNvSpPr>
-          <p:nvPr>
-            <p:ph type="body" idx="1"/>
-          </p:nvPr>
-        </p:nvSpPr>
-        <p:spPr/>
-        <p:txBody>
-          <a:bodyPr/>
-          <a:lstStyle/>
-          <a:p>
-            <a:r>
-              <a:rPr lang="en-US" dirty="0"/>
-              <a:t>&lt;read slide&gt;</a:t>
-            </a:r>
-          </a:p>
-        </p:txBody>
-      </p:sp>
-      <p:sp>
-        <p:nvSpPr>
-          <p:cNvPr id="4" name="Slide Number Placeholder 3">
-            <a:extLst>
-              <a:ext uri="{FF2B5EF4-FFF2-40B4-BE49-F238E27FC236}">
-                <a16:creationId xmlns:a16="http://schemas.microsoft.com/office/drawing/2014/main" id="{8EC0CF62-788E-81B9-E348-BCCB3517B8C5}"/>
-              </a:ext>
-            </a:extLst>
-          </p:cNvPr>
-          <p:cNvSpPr>
-            <a:spLocks noGrp="1"/>
-          </p:cNvSpPr>
-          <p:nvPr>
-            <p:ph type="sldNum" sz="quarter" idx="5"/>
-          </p:nvPr>
-        </p:nvSpPr>
-        <p:spPr/>
-        <p:txBody>
-          <a:bodyPr/>
-          <a:lstStyle/>
-          <a:p>
-            <a:fld id="{07937F07-1250-4CCE-B198-1B2887014F41}" type="slidenum">
-              <a:rPr lang="en-US" smtClean="0"/>
-              <a:t>42</a:t>
-            </a:fld>
-            <a:endParaRPr lang="en-US"/>
-          </a:p>
-        </p:txBody>
-      </p:sp>
-    </p:spTree>
-    <p:extLst>
-      <p:ext uri="{BB962C8B-B14F-4D97-AF65-F5344CB8AC3E}">
-        <p14:creationId xmlns:p14="http://schemas.microsoft.com/office/powerpoint/2010/main" val="500095670"/>
       </p:ext>
     </p:extLst>
   </p:cSld>
@@ -4308,7 +4286,125 @@
           <a:p>
             <a:fld id="{07937F07-1250-4CCE-B198-1B2887014F41}" type="slidenum">
               <a:rPr lang="en-US" smtClean="0"/>
-              <a:t>43</a:t>
+              <a:t>44</a:t>
+            </a:fld>
+            <a:endParaRPr lang="en-US"/>
+          </a:p>
+        </p:txBody>
+      </p:sp>
+    </p:spTree>
+    <p:extLst>
+      <p:ext uri="{BB962C8B-B14F-4D97-AF65-F5344CB8AC3E}">
+        <p14:creationId xmlns:p14="http://schemas.microsoft.com/office/powerpoint/2010/main" val="500095670"/>
+      </p:ext>
+    </p:extLst>
+  </p:cSld>
+  <p:clrMapOvr>
+    <a:masterClrMapping/>
+  </p:clrMapOvr>
+</p:notes>
+</file>
+
+<file path=ppt/notesSlides/notesSlide36.xml><?xml version="1.0" encoding="utf-8"?>
+<p:notes xmlns:a="http://schemas.openxmlformats.org/drawingml/2006/main" xmlns:r="http://schemas.openxmlformats.org/officeDocument/2006/relationships" xmlns:p="http://schemas.openxmlformats.org/presentationml/2006/main">
+  <p:cSld>
+    <p:spTree>
+      <p:nvGrpSpPr>
+        <p:cNvPr id="1" name="">
+          <a:extLst>
+            <a:ext uri="{FF2B5EF4-FFF2-40B4-BE49-F238E27FC236}">
+              <a16:creationId xmlns:a16="http://schemas.microsoft.com/office/drawing/2014/main" id="{F7B2264C-DFEB-53E4-5B35-4BC6D2449264}"/>
+            </a:ext>
+          </a:extLst>
+        </p:cNvPr>
+        <p:cNvGrpSpPr/>
+        <p:nvPr/>
+      </p:nvGrpSpPr>
+      <p:grpSpPr>
+        <a:xfrm>
+          <a:off x="0" y="0"/>
+          <a:ext cx="0" cy="0"/>
+          <a:chOff x="0" y="0"/>
+          <a:chExt cx="0" cy="0"/>
+        </a:xfrm>
+      </p:grpSpPr>
+      <p:sp>
+        <p:nvSpPr>
+          <p:cNvPr id="2" name="Slide Image Placeholder 1">
+            <a:extLst>
+              <a:ext uri="{FF2B5EF4-FFF2-40B4-BE49-F238E27FC236}">
+                <a16:creationId xmlns:a16="http://schemas.microsoft.com/office/drawing/2014/main" id="{50D9F692-70A1-39A9-0EC0-C3C08A93BF2A}"/>
+              </a:ext>
+            </a:extLst>
+          </p:cNvPr>
+          <p:cNvSpPr>
+            <a:spLocks noGrp="1" noRot="1" noChangeAspect="1"/>
+          </p:cNvSpPr>
+          <p:nvPr>
+            <p:ph type="sldImg"/>
+          </p:nvPr>
+        </p:nvSpPr>
+        <p:spPr/>
+        <p:txBody>
+          <a:bodyPr/>
+          <a:lstStyle/>
+          <a:p>
+            <a:endParaRPr lang="en-US"/>
+          </a:p>
+        </p:txBody>
+      </p:sp>
+      <p:sp>
+        <p:nvSpPr>
+          <p:cNvPr id="3" name="Notes Placeholder 2">
+            <a:extLst>
+              <a:ext uri="{FF2B5EF4-FFF2-40B4-BE49-F238E27FC236}">
+                <a16:creationId xmlns:a16="http://schemas.microsoft.com/office/drawing/2014/main" id="{AB0DF6A1-3525-9D88-A1F3-DB794DC15C53}"/>
+              </a:ext>
+            </a:extLst>
+          </p:cNvPr>
+          <p:cNvSpPr>
+            <a:spLocks noGrp="1"/>
+          </p:cNvSpPr>
+          <p:nvPr>
+            <p:ph type="body" idx="1"/>
+          </p:nvPr>
+        </p:nvSpPr>
+        <p:spPr/>
+        <p:txBody>
+          <a:bodyPr/>
+          <a:lstStyle/>
+          <a:p>
+            <a:r>
+              <a:rPr lang="en-US" dirty="0"/>
+              <a:t>&lt;read slide&gt;</a:t>
+            </a:r>
+          </a:p>
+        </p:txBody>
+      </p:sp>
+      <p:sp>
+        <p:nvSpPr>
+          <p:cNvPr id="4" name="Slide Number Placeholder 3">
+            <a:extLst>
+              <a:ext uri="{FF2B5EF4-FFF2-40B4-BE49-F238E27FC236}">
+                <a16:creationId xmlns:a16="http://schemas.microsoft.com/office/drawing/2014/main" id="{8EC0CF62-788E-81B9-E348-BCCB3517B8C5}"/>
+              </a:ext>
+            </a:extLst>
+          </p:cNvPr>
+          <p:cNvSpPr>
+            <a:spLocks noGrp="1"/>
+          </p:cNvSpPr>
+          <p:nvPr>
+            <p:ph type="sldNum" sz="quarter" idx="5"/>
+          </p:nvPr>
+        </p:nvSpPr>
+        <p:spPr/>
+        <p:txBody>
+          <a:bodyPr/>
+          <a:lstStyle/>
+          <a:p>
+            <a:fld id="{07937F07-1250-4CCE-B198-1B2887014F41}" type="slidenum">
+              <a:rPr lang="en-US" smtClean="0"/>
+              <a:t>45</a:t>
             </a:fld>
             <a:endParaRPr lang="en-US"/>
           </a:p>
@@ -4327,7 +4423,7 @@
 </p:notes>
 </file>
 
-<file path=ppt/notesSlides/notesSlide36.xml><?xml version="1.0" encoding="utf-8"?>
+<file path=ppt/notesSlides/notesSlide37.xml><?xml version="1.0" encoding="utf-8"?>
 <p:notes xmlns:a="http://schemas.openxmlformats.org/drawingml/2006/main" xmlns:r="http://schemas.openxmlformats.org/officeDocument/2006/relationships" xmlns:p="http://schemas.openxmlformats.org/presentationml/2006/main">
   <p:cSld>
     <p:spTree>
@@ -5230,7 +5326,7 @@
           <a:p>
             <a:fld id="{5D2A64DE-480B-420F-9649-4F8E696E08E0}" type="datetime1">
               <a:rPr lang="en-US" smtClean="0"/>
-              <a:t>10/20/2026</a:t>
+              <a:t>10/26/2026</a:t>
             </a:fld>
             <a:endParaRPr lang="en-US" dirty="0"/>
           </a:p>
@@ -5352,7 +5448,7 @@
           </a:prstGeom>
           <a:extLst>
             <a:ext uri="{C572A759-6A51-4108-AA02-DFA0A04FC94B}">
-              <ma14:wrappingTextBoxFlag xmlns:ma14="http://schemas.microsoft.com/office/mac/drawingml/2011/main" xmlns:a14="http://schemas.microsoft.com/office/drawing/2010/main" xmlns:m="http://schemas.openxmlformats.org/officeDocument/2006/math" xmlns="" val="1"/>
+              <ma14:wrappingTextBoxFlag xmlns="" xmlns:m="http://schemas.openxmlformats.org/officeDocument/2006/math" xmlns:a14="http://schemas.microsoft.com/office/drawing/2010/main" xmlns:ma14="http://schemas.microsoft.com/office/mac/drawingml/2011/main" val="1"/>
             </a:ext>
           </a:extLst>
         </p:spPr>
@@ -5643,7 +5739,7 @@
           <a:p>
             <a:fld id="{EA476A42-A091-4468-A075-64A31BE59948}" type="datetime1">
               <a:rPr lang="en-US" smtClean="0"/>
-              <a:t>10/20/2026</a:t>
+              <a:t>10/26/2026</a:t>
             </a:fld>
             <a:endParaRPr lang="en-US" dirty="0"/>
           </a:p>
@@ -5841,7 +5937,7 @@
           <a:p>
             <a:fld id="{0D3616D0-8311-4107-9726-6B805E7D05BA}" type="datetime1">
               <a:rPr lang="en-US" smtClean="0"/>
-              <a:t>10/20/2026</a:t>
+              <a:t>10/26/2026</a:t>
             </a:fld>
             <a:endParaRPr lang="en-US" dirty="0"/>
           </a:p>
@@ -6049,7 +6145,7 @@
           <a:p>
             <a:fld id="{3BC2557A-5C88-417A-A763-5AC779462A5F}" type="datetime1">
               <a:rPr lang="en-US" smtClean="0"/>
-              <a:t>10/20/2026</a:t>
+              <a:t>10/26/2026</a:t>
             </a:fld>
             <a:endParaRPr lang="en-US" dirty="0"/>
           </a:p>
@@ -7008,7 +7104,7 @@
           <a:p>
             <a:fld id="{5D2A64DE-480B-420F-9649-4F8E696E08E0}" type="datetime1">
               <a:rPr lang="en-US" smtClean="0"/>
-              <a:t>10/20/2026</a:t>
+              <a:t>10/26/2026</a:t>
             </a:fld>
             <a:endParaRPr lang="en-US" dirty="0"/>
           </a:p>
@@ -7428,7 +7524,7 @@
           <a:p>
             <a:fld id="{07C7BFD4-467E-4EDE-93EA-052F5B39A4E5}" type="datetime1">
               <a:rPr lang="en-US" smtClean="0"/>
-              <a:t>10/20/2026</a:t>
+              <a:t>10/26/2026</a:t>
             </a:fld>
             <a:endParaRPr lang="en-US" dirty="0"/>
           </a:p>
@@ -7678,7 +7774,7 @@
           <a:p>
             <a:fld id="{07C7BFD4-467E-4EDE-93EA-052F5B39A4E5}" type="datetime1">
               <a:rPr lang="en-US" smtClean="0"/>
-              <a:t>10/20/2026</a:t>
+              <a:t>10/26/2026</a:t>
             </a:fld>
             <a:endParaRPr lang="en-US" dirty="0"/>
           </a:p>
@@ -7827,7 +7923,7 @@
           <a:p>
             <a:fld id="{109E55A0-C911-4F03-82FC-7E5926047D46}" type="datetime1">
               <a:rPr lang="en-US" smtClean="0"/>
-              <a:t>10/20/2026</a:t>
+              <a:t>10/26/2026</a:t>
             </a:fld>
             <a:endParaRPr lang="en-US" dirty="0"/>
           </a:p>
@@ -8015,7 +8111,7 @@
           <a:p>
             <a:fld id="{2B7B7EE0-7771-4CD5-9B2B-3550753A54A1}" type="datetime1">
               <a:rPr lang="en-US" smtClean="0"/>
-              <a:t>10/20/2026</a:t>
+              <a:t>10/26/2026</a:t>
             </a:fld>
             <a:endParaRPr lang="en-US" dirty="0"/>
           </a:p>
@@ -8229,7 +8325,7 @@
           <a:p>
             <a:fld id="{07C7BFD4-467E-4EDE-93EA-052F5B39A4E5}" type="datetime1">
               <a:rPr lang="en-US" smtClean="0"/>
-              <a:t>10/20/2026</a:t>
+              <a:t>10/26/2026</a:t>
             </a:fld>
             <a:endParaRPr lang="en-US" dirty="0"/>
           </a:p>
@@ -8417,7 +8513,7 @@
           <a:p>
             <a:fld id="{109E55A0-C911-4F03-82FC-7E5926047D46}" type="datetime1">
               <a:rPr lang="en-US" smtClean="0"/>
-              <a:t>10/20/2026</a:t>
+              <a:t>10/26/2026</a:t>
             </a:fld>
             <a:endParaRPr lang="en-US" dirty="0"/>
           </a:p>
@@ -8730,7 +8826,7 @@
           <a:p>
             <a:fld id="{A533CBE2-D5BE-47AC-ADC2-9CDFC1D0CF90}" type="datetime1">
               <a:rPr lang="en-US" smtClean="0"/>
-              <a:t>10/20/2026</a:t>
+              <a:t>10/26/2026</a:t>
             </a:fld>
             <a:endParaRPr lang="en-US" dirty="0"/>
           </a:p>
@@ -9031,7 +9127,7 @@
           <a:p>
             <a:fld id="{39B7EDB1-CE74-4951-85A2-0B01C2128E28}" type="datetime1">
               <a:rPr lang="en-US" smtClean="0"/>
-              <a:t>10/20/2026</a:t>
+              <a:t>10/26/2026</a:t>
             </a:fld>
             <a:endParaRPr lang="en-US" dirty="0"/>
           </a:p>
@@ -9479,7 +9575,7 @@
           <a:p>
             <a:fld id="{2BC7EB92-A5C2-4807-A9DC-9EDE6CBFB241}" type="datetime1">
               <a:rPr lang="en-US" smtClean="0"/>
-              <a:t>10/20/2026</a:t>
+              <a:t>10/26/2026</a:t>
             </a:fld>
             <a:endParaRPr lang="en-US" dirty="0"/>
           </a:p>
@@ -9592,7 +9688,7 @@
           <a:p>
             <a:fld id="{2B7B7EE0-7771-4CD5-9B2B-3550753A54A1}" type="datetime1">
               <a:rPr lang="en-US" smtClean="0"/>
-              <a:t>10/20/2026</a:t>
+              <a:t>10/26/2026</a:t>
             </a:fld>
             <a:endParaRPr lang="en-US" dirty="0"/>
           </a:p>
@@ -9903,7 +9999,7 @@
           <a:p>
             <a:fld id="{F8B318B3-0E87-4416-A9B8-D891968C2727}" type="datetime1">
               <a:rPr lang="en-US" smtClean="0"/>
-              <a:t>10/20/2026</a:t>
+              <a:t>10/26/2026</a:t>
             </a:fld>
             <a:endParaRPr lang="en-US" dirty="0"/>
           </a:p>
@@ -10144,7 +10240,7 @@
           <a:p>
             <a:fld id="{54D997E8-DDEE-43F1-8D9B-F8A1E11DE488}" type="datetime1">
               <a:rPr lang="en-US" smtClean="0"/>
-              <a:t>10/20/2026</a:t>
+              <a:t>10/26/2026</a:t>
             </a:fld>
             <a:endParaRPr lang="en-US" dirty="0"/>
           </a:p>
@@ -10719,7 +10815,7 @@
           <a:p>
             <a:fld id="{54D997E8-DDEE-43F1-8D9B-F8A1E11DE488}" type="datetime1">
               <a:rPr lang="en-US" smtClean="0"/>
-              <a:t>10/20/2026</a:t>
+              <a:t>10/26/2026</a:t>
             </a:fld>
             <a:endParaRPr lang="en-US" dirty="0"/>
           </a:p>
@@ -11286,7 +11382,7 @@
           </a:prstGeom>
           <a:extLst>
             <a:ext uri="{C572A759-6A51-4108-AA02-DFA0A04FC94B}">
-              <ma14:wrappingTextBoxFlag xmlns="" xmlns:m="http://schemas.openxmlformats.org/officeDocument/2006/math" xmlns:a14="http://schemas.microsoft.com/office/drawing/2010/main" xmlns:ma14="http://schemas.microsoft.com/office/mac/drawingml/2011/main" val="1"/>
+              <ma14:wrappingTextBoxFlag xmlns:ma14="http://schemas.microsoft.com/office/mac/drawingml/2011/main" xmlns:a14="http://schemas.microsoft.com/office/drawing/2010/main" xmlns:m="http://schemas.openxmlformats.org/officeDocument/2006/math" xmlns="" val="1"/>
             </a:ext>
           </a:extLst>
         </p:spPr>
@@ -12671,7 +12767,7 @@
           </a:ln>
           <a:extLst>
             <a:ext uri="{C572A759-6A51-4108-AA02-DFA0A04FC94B}">
-              <ma14:wrappingTextBoxFlag xmlns:ma14="http://schemas.microsoft.com/office/mac/drawingml/2011/main" xmlns:a14="http://schemas.microsoft.com/office/drawing/2010/main" xmlns:m="http://schemas.openxmlformats.org/officeDocument/2006/math" xmlns="" val="1"/>
+              <ma14:wrappingTextBoxFlag xmlns="" xmlns:m="http://schemas.openxmlformats.org/officeDocument/2006/math" xmlns:a14="http://schemas.microsoft.com/office/drawing/2010/main" xmlns:ma14="http://schemas.microsoft.com/office/mac/drawingml/2011/main" val="1"/>
             </a:ext>
           </a:extLst>
         </p:spPr>
@@ -12908,7 +13004,7 @@
           </a:ln>
           <a:extLst>
             <a:ext uri="{C572A759-6A51-4108-AA02-DFA0A04FC94B}">
-              <ma14:wrappingTextBoxFlag xmlns:ma14="http://schemas.microsoft.com/office/mac/drawingml/2011/main" xmlns:a14="http://schemas.microsoft.com/office/drawing/2010/main" xmlns:m="http://schemas.openxmlformats.org/officeDocument/2006/math" xmlns="" val="1"/>
+              <ma14:wrappingTextBoxFlag xmlns="" xmlns:m="http://schemas.openxmlformats.org/officeDocument/2006/math" xmlns:a14="http://schemas.microsoft.com/office/drawing/2010/main" xmlns:ma14="http://schemas.microsoft.com/office/mac/drawingml/2011/main" val="1"/>
             </a:ext>
           </a:extLst>
         </p:spPr>
@@ -13004,7 +13100,7 @@
           </a:ln>
           <a:extLst>
             <a:ext uri="{C572A759-6A51-4108-AA02-DFA0A04FC94B}">
-              <ma14:wrappingTextBoxFlag xmlns:ma14="http://schemas.microsoft.com/office/mac/drawingml/2011/main" xmlns:a14="http://schemas.microsoft.com/office/drawing/2010/main" xmlns:m="http://schemas.openxmlformats.org/officeDocument/2006/math" xmlns="" val="1"/>
+              <ma14:wrappingTextBoxFlag xmlns="" xmlns:m="http://schemas.openxmlformats.org/officeDocument/2006/math" xmlns:a14="http://schemas.microsoft.com/office/drawing/2010/main" xmlns:ma14="http://schemas.microsoft.com/office/mac/drawingml/2011/main" val="1"/>
             </a:ext>
           </a:extLst>
         </p:spPr>
@@ -13234,7 +13330,7 @@
           </a:ln>
           <a:extLst>
             <a:ext uri="{C572A759-6A51-4108-AA02-DFA0A04FC94B}">
-              <ma14:wrappingTextBoxFlag xmlns:ma14="http://schemas.microsoft.com/office/mac/drawingml/2011/main" xmlns:a14="http://schemas.microsoft.com/office/drawing/2010/main" xmlns:m="http://schemas.openxmlformats.org/officeDocument/2006/math" xmlns="" val="1"/>
+              <ma14:wrappingTextBoxFlag xmlns="" xmlns:m="http://schemas.openxmlformats.org/officeDocument/2006/math" xmlns:a14="http://schemas.microsoft.com/office/drawing/2010/main" xmlns:ma14="http://schemas.microsoft.com/office/mac/drawingml/2011/main" val="1"/>
             </a:ext>
           </a:extLst>
         </p:spPr>
@@ -13898,7 +13994,7 @@
           </a:prstGeom>
           <a:extLst>
             <a:ext uri="{C572A759-6A51-4108-AA02-DFA0A04FC94B}">
-              <ma14:wrappingTextBoxFlag xmlns:ma14="http://schemas.microsoft.com/office/mac/drawingml/2011/main" xmlns:a14="http://schemas.microsoft.com/office/drawing/2010/main" xmlns:m="http://schemas.openxmlformats.org/officeDocument/2006/math" xmlns="" val="1"/>
+              <ma14:wrappingTextBoxFlag xmlns="" xmlns:m="http://schemas.openxmlformats.org/officeDocument/2006/math" xmlns:a14="http://schemas.microsoft.com/office/drawing/2010/main" xmlns:ma14="http://schemas.microsoft.com/office/mac/drawingml/2011/main" val="1"/>
             </a:ext>
           </a:extLst>
         </p:spPr>
@@ -13954,7 +14050,7 @@
           </a:ln>
           <a:extLst>
             <a:ext uri="{C572A759-6A51-4108-AA02-DFA0A04FC94B}">
-              <ma14:wrappingTextBoxFlag xmlns:ma14="http://schemas.microsoft.com/office/mac/drawingml/2011/main" xmlns:a14="http://schemas.microsoft.com/office/drawing/2010/main" xmlns:m="http://schemas.openxmlformats.org/officeDocument/2006/math" xmlns="" val="1"/>
+              <ma14:wrappingTextBoxFlag xmlns="" xmlns:m="http://schemas.openxmlformats.org/officeDocument/2006/math" xmlns:a14="http://schemas.microsoft.com/office/drawing/2010/main" xmlns:ma14="http://schemas.microsoft.com/office/mac/drawingml/2011/main" val="1"/>
             </a:ext>
           </a:extLst>
         </p:spPr>
@@ -14816,7 +14912,7 @@
             <a:effectLst/>
             <a:extLst>
               <a:ext uri="{C572A759-6A51-4108-AA02-DFA0A04FC94B}">
-                <ma14:wrappingTextBoxFlag xmlns:ma14="http://schemas.microsoft.com/office/mac/drawingml/2011/main" xmlns:a14="http://schemas.microsoft.com/office/drawing/2010/main" xmlns:m="http://schemas.openxmlformats.org/officeDocument/2006/math" xmlns="" val="1"/>
+                <ma14:wrappingTextBoxFlag xmlns="" xmlns:m="http://schemas.openxmlformats.org/officeDocument/2006/math" xmlns:a14="http://schemas.microsoft.com/office/drawing/2010/main" xmlns:ma14="http://schemas.microsoft.com/office/mac/drawingml/2011/main" val="1"/>
               </a:ext>
             </a:extLst>
           </p:spPr>
@@ -15118,7 +15214,7 @@
           </a:ln>
           <a:extLst>
             <a:ext uri="{C572A759-6A51-4108-AA02-DFA0A04FC94B}">
-              <ma14:wrappingTextBoxFlag xmlns:ma14="http://schemas.microsoft.com/office/mac/drawingml/2011/main" xmlns:a14="http://schemas.microsoft.com/office/drawing/2010/main" xmlns:m="http://schemas.openxmlformats.org/officeDocument/2006/math" xmlns="" val="1"/>
+              <ma14:wrappingTextBoxFlag xmlns="" xmlns:m="http://schemas.openxmlformats.org/officeDocument/2006/math" xmlns:a14="http://schemas.microsoft.com/office/drawing/2010/main" xmlns:ma14="http://schemas.microsoft.com/office/mac/drawingml/2011/main" val="1"/>
             </a:ext>
           </a:extLst>
         </p:spPr>
@@ -15559,7 +15655,7 @@
           <a:effectLst/>
           <a:extLst>
             <a:ext uri="{C572A759-6A51-4108-AA02-DFA0A04FC94B}">
-              <ma14:wrappingTextBoxFlag xmlns:ma14="http://schemas.microsoft.com/office/mac/drawingml/2011/main" xmlns:a14="http://schemas.microsoft.com/office/drawing/2010/main" xmlns:m="http://schemas.openxmlformats.org/officeDocument/2006/math" xmlns="" val="1"/>
+              <ma14:wrappingTextBoxFlag xmlns="" xmlns:m="http://schemas.openxmlformats.org/officeDocument/2006/math" xmlns:a14="http://schemas.microsoft.com/office/drawing/2010/main" xmlns:ma14="http://schemas.microsoft.com/office/mac/drawingml/2011/main" val="1"/>
             </a:ext>
           </a:extLst>
         </p:spPr>
@@ -16877,7 +16973,7 @@
           <a:effectLst/>
           <a:extLst>
             <a:ext uri="{C572A759-6A51-4108-AA02-DFA0A04FC94B}">
-              <ma14:wrappingTextBoxFlag xmlns:ma14="http://schemas.microsoft.com/office/mac/drawingml/2011/main" xmlns:a14="http://schemas.microsoft.com/office/drawing/2010/main" xmlns:m="http://schemas.openxmlformats.org/officeDocument/2006/math" xmlns="" val="1"/>
+              <ma14:wrappingTextBoxFlag xmlns="" xmlns:m="http://schemas.openxmlformats.org/officeDocument/2006/math" xmlns:a14="http://schemas.microsoft.com/office/drawing/2010/main" xmlns:ma14="http://schemas.microsoft.com/office/mac/drawingml/2011/main" val="1"/>
             </a:ext>
           </a:extLst>
         </p:spPr>
@@ -17900,7 +17996,7 @@
           </a:ln>
           <a:extLst>
             <a:ext uri="{C572A759-6A51-4108-AA02-DFA0A04FC94B}">
-              <ma14:wrappingTextBoxFlag xmlns:ma14="http://schemas.microsoft.com/office/mac/drawingml/2011/main" xmlns:a14="http://schemas.microsoft.com/office/drawing/2010/main" xmlns:m="http://schemas.openxmlformats.org/officeDocument/2006/math" xmlns="" val="1"/>
+              <ma14:wrappingTextBoxFlag xmlns="" xmlns:m="http://schemas.openxmlformats.org/officeDocument/2006/math" xmlns:a14="http://schemas.microsoft.com/office/drawing/2010/main" xmlns:ma14="http://schemas.microsoft.com/office/mac/drawingml/2011/main" val="1"/>
             </a:ext>
           </a:extLst>
         </p:spPr>
@@ -17995,7 +18091,7 @@
           </a:ln>
           <a:extLst>
             <a:ext uri="{C572A759-6A51-4108-AA02-DFA0A04FC94B}">
-              <ma14:wrappingTextBoxFlag xmlns:ma14="http://schemas.microsoft.com/office/mac/drawingml/2011/main" xmlns:a14="http://schemas.microsoft.com/office/drawing/2010/main" xmlns:m="http://schemas.openxmlformats.org/officeDocument/2006/math" xmlns="" val="1"/>
+              <ma14:wrappingTextBoxFlag xmlns="" xmlns:m="http://schemas.openxmlformats.org/officeDocument/2006/math" xmlns:a14="http://schemas.microsoft.com/office/drawing/2010/main" xmlns:ma14="http://schemas.microsoft.com/office/mac/drawingml/2011/main" val="1"/>
             </a:ext>
           </a:extLst>
         </p:spPr>
@@ -18054,7 +18150,7 @@
           </a:ln>
           <a:extLst>
             <a:ext uri="{C572A759-6A51-4108-AA02-DFA0A04FC94B}">
-              <ma14:wrappingTextBoxFlag xmlns:ma14="http://schemas.microsoft.com/office/mac/drawingml/2011/main" xmlns:a14="http://schemas.microsoft.com/office/drawing/2010/main" xmlns:m="http://schemas.openxmlformats.org/officeDocument/2006/math" xmlns="" val="1"/>
+              <ma14:wrappingTextBoxFlag xmlns="" xmlns:m="http://schemas.openxmlformats.org/officeDocument/2006/math" xmlns:a14="http://schemas.microsoft.com/office/drawing/2010/main" xmlns:ma14="http://schemas.microsoft.com/office/mac/drawingml/2011/main" val="1"/>
             </a:ext>
           </a:extLst>
         </p:spPr>
@@ -18113,7 +18209,7 @@
           </a:ln>
           <a:extLst>
             <a:ext uri="{C572A759-6A51-4108-AA02-DFA0A04FC94B}">
-              <ma14:wrappingTextBoxFlag xmlns:ma14="http://schemas.microsoft.com/office/mac/drawingml/2011/main" xmlns:a14="http://schemas.microsoft.com/office/drawing/2010/main" xmlns:m="http://schemas.openxmlformats.org/officeDocument/2006/math" xmlns="" val="1"/>
+              <ma14:wrappingTextBoxFlag xmlns="" xmlns:m="http://schemas.openxmlformats.org/officeDocument/2006/math" xmlns:a14="http://schemas.microsoft.com/office/drawing/2010/main" xmlns:ma14="http://schemas.microsoft.com/office/mac/drawingml/2011/main" val="1"/>
             </a:ext>
           </a:extLst>
         </p:spPr>
@@ -18244,7 +18340,7 @@
           </a:ln>
           <a:extLst>
             <a:ext uri="{C572A759-6A51-4108-AA02-DFA0A04FC94B}">
-              <ma14:wrappingTextBoxFlag xmlns:ma14="http://schemas.microsoft.com/office/mac/drawingml/2011/main" xmlns:a14="http://schemas.microsoft.com/office/drawing/2010/main" xmlns:m="http://schemas.openxmlformats.org/officeDocument/2006/math" xmlns="" val="1"/>
+              <ma14:wrappingTextBoxFlag xmlns="" xmlns:m="http://schemas.openxmlformats.org/officeDocument/2006/math" xmlns:a14="http://schemas.microsoft.com/office/drawing/2010/main" xmlns:ma14="http://schemas.microsoft.com/office/mac/drawingml/2011/main" val="1"/>
             </a:ext>
           </a:extLst>
         </p:spPr>
@@ -18492,6 +18588,644 @@
           <p:cNvPr id="2" name="Title 1">
             <a:extLst>
               <a:ext uri="{FF2B5EF4-FFF2-40B4-BE49-F238E27FC236}">
+                <a16:creationId xmlns:a16="http://schemas.microsoft.com/office/drawing/2014/main" id="{6017E05F-085F-96DD-ACB3-1CA15578FE4E}"/>
+              </a:ext>
+            </a:extLst>
+          </p:cNvPr>
+          <p:cNvSpPr>
+            <a:spLocks noGrp="1"/>
+          </p:cNvSpPr>
+          <p:nvPr>
+            <p:ph type="title"/>
+          </p:nvPr>
+        </p:nvSpPr>
+        <p:spPr/>
+        <p:txBody>
+          <a:bodyPr/>
+          <a:lstStyle/>
+          <a:p>
+            <a:r>
+              <a:rPr lang="en-US" dirty="0"/>
+              <a:t>Third-party dependencies are everywhere</a:t>
+            </a:r>
+          </a:p>
+        </p:txBody>
+      </p:sp>
+      <p:sp>
+        <p:nvSpPr>
+          <p:cNvPr id="8" name="Content Placeholder 7">
+            <a:extLst>
+              <a:ext uri="{FF2B5EF4-FFF2-40B4-BE49-F238E27FC236}">
+                <a16:creationId xmlns:a16="http://schemas.microsoft.com/office/drawing/2014/main" id="{EE854DDD-7450-2A29-3611-B02DA479EEDB}"/>
+              </a:ext>
+            </a:extLst>
+          </p:cNvPr>
+          <p:cNvSpPr>
+            <a:spLocks noGrp="1"/>
+          </p:cNvSpPr>
+          <p:nvPr>
+            <p:ph idx="1"/>
+          </p:nvPr>
+        </p:nvSpPr>
+        <p:spPr>
+          <a:xfrm>
+            <a:off x="7204053" y="1639886"/>
+            <a:ext cx="3107528" cy="4351338"/>
+          </a:xfrm>
+        </p:spPr>
+        <p:txBody>
+          <a:bodyPr/>
+          <a:lstStyle/>
+          <a:p>
+            <a:r>
+              <a:rPr lang="en-US" dirty="0"/>
+              <a:t>The whole structure of the internet was built ad hoc, and has numerous weak links</a:t>
+            </a:r>
+          </a:p>
+        </p:txBody>
+      </p:sp>
+      <p:sp>
+        <p:nvSpPr>
+          <p:cNvPr id="4" name="Slide Number Placeholder 3">
+            <a:extLst>
+              <a:ext uri="{FF2B5EF4-FFF2-40B4-BE49-F238E27FC236}">
+                <a16:creationId xmlns:a16="http://schemas.microsoft.com/office/drawing/2014/main" id="{99A7475A-7825-E522-C819-9B4155925005}"/>
+              </a:ext>
+            </a:extLst>
+          </p:cNvPr>
+          <p:cNvSpPr>
+            <a:spLocks noGrp="1"/>
+          </p:cNvSpPr>
+          <p:nvPr>
+            <p:ph type="sldNum" sz="quarter" idx="12"/>
+          </p:nvPr>
+        </p:nvSpPr>
+        <p:spPr/>
+        <p:txBody>
+          <a:bodyPr/>
+          <a:lstStyle/>
+          <a:p>
+            <a:fld id="{20F37917-FD3A-4669-9018-DA04BCDD3D75}" type="slidenum">
+              <a:rPr lang="en-US" smtClean="0"/>
+              <a:t>30</a:t>
+            </a:fld>
+            <a:endParaRPr lang="en-US" dirty="0"/>
+          </a:p>
+        </p:txBody>
+      </p:sp>
+      <p:pic>
+        <p:nvPicPr>
+          <p:cNvPr id="5" name="Picture 4" descr="Dependency">
+            <a:extLst>
+              <a:ext uri="{FF2B5EF4-FFF2-40B4-BE49-F238E27FC236}">
+                <a16:creationId xmlns:a16="http://schemas.microsoft.com/office/drawing/2014/main" id="{6A73EA38-3064-03FC-3548-B6DF586EA1D5}"/>
+              </a:ext>
+            </a:extLst>
+          </p:cNvPr>
+          <p:cNvPicPr>
+            <a:picLocks noChangeAspect="1"/>
+          </p:cNvPicPr>
+          <p:nvPr/>
+        </p:nvPicPr>
+        <p:blipFill>
+          <a:blip r:embed="rId2"/>
+          <a:stretch>
+            <a:fillRect/>
+          </a:stretch>
+        </p:blipFill>
+        <p:spPr>
+          <a:xfrm>
+            <a:off x="2009568" y="1512094"/>
+            <a:ext cx="3667125" cy="4657725"/>
+          </a:xfrm>
+          <a:prstGeom prst="rect">
+            <a:avLst/>
+          </a:prstGeom>
+        </p:spPr>
+      </p:pic>
+      <p:sp>
+        <p:nvSpPr>
+          <p:cNvPr id="7" name="TextBox 6">
+            <a:extLst>
+              <a:ext uri="{FF2B5EF4-FFF2-40B4-BE49-F238E27FC236}">
+                <a16:creationId xmlns:a16="http://schemas.microsoft.com/office/drawing/2014/main" id="{9CBED374-4E23-606F-DBBD-D700A133B367}"/>
+              </a:ext>
+            </a:extLst>
+          </p:cNvPr>
+          <p:cNvSpPr txBox="1"/>
+          <p:nvPr/>
+        </p:nvSpPr>
+        <p:spPr>
+          <a:xfrm>
+            <a:off x="7331868" y="6108330"/>
+            <a:ext cx="2557464" cy="496039"/>
+          </a:xfrm>
+          <a:prstGeom prst="rect">
+            <a:avLst/>
+          </a:prstGeom>
+          <a:noFill/>
+          <a:ln>
+            <a:noFill/>
+          </a:ln>
+        </p:spPr>
+        <p:style>
+          <a:lnRef idx="2">
+            <a:schemeClr val="accent1">
+              <a:shade val="50000"/>
+            </a:schemeClr>
+          </a:lnRef>
+          <a:fillRef idx="1">
+            <a:schemeClr val="accent1"/>
+          </a:fillRef>
+          <a:effectRef idx="0">
+            <a:schemeClr val="accent1"/>
+          </a:effectRef>
+          <a:fontRef idx="minor">
+            <a:schemeClr val="lt1"/>
+          </a:fontRef>
+        </p:style>
+        <p:txBody>
+          <a:bodyPr rot="0" spcFirstLastPara="0" vertOverflow="overflow" horzOverflow="overflow" vert="horz" wrap="square" lIns="91440" tIns="45720" rIns="91440" bIns="45720" numCol="1" spcCol="0" rtlCol="0" fromWordArt="0" anchor="ctr" anchorCtr="0" forceAA="0" compatLnSpc="1">
+            <a:prstTxWarp prst="textNoShape">
+              <a:avLst/>
+            </a:prstTxWarp>
+            <a:noAutofit/>
+          </a:bodyPr>
+          <a:lstStyle/>
+          <a:p>
+            <a:r>
+              <a:rPr lang="en-US" dirty="0">
+                <a:solidFill>
+                  <a:schemeClr val="tx1"/>
+                </a:solidFill>
+                <a:hlinkClick r:id="rId3"/>
+              </a:rPr>
+              <a:t>https://xkcd.com/2347/</a:t>
+            </a:r>
+            <a:endParaRPr lang="en-US" dirty="0">
+              <a:solidFill>
+                <a:schemeClr val="tx1"/>
+              </a:solidFill>
+            </a:endParaRPr>
+          </a:p>
+        </p:txBody>
+      </p:sp>
+    </p:spTree>
+    <p:extLst>
+      <p:ext uri="{BB962C8B-B14F-4D97-AF65-F5344CB8AC3E}">
+        <p14:creationId xmlns:p14="http://schemas.microsoft.com/office/powerpoint/2010/main" val="988594982"/>
+      </p:ext>
+    </p:extLst>
+  </p:cSld>
+  <p:clrMapOvr>
+    <a:masterClrMapping/>
+  </p:clrMapOvr>
+</p:sld>
+</file>
+
+<file path=ppt/slides/slide31.xml><?xml version="1.0" encoding="utf-8"?>
+<p:sld xmlns:a="http://schemas.openxmlformats.org/drawingml/2006/main" xmlns:r="http://schemas.openxmlformats.org/officeDocument/2006/relationships" xmlns:p="http://schemas.openxmlformats.org/presentationml/2006/main">
+  <p:cSld>
+    <p:spTree>
+      <p:nvGrpSpPr>
+        <p:cNvPr id="1" name=""/>
+        <p:cNvGrpSpPr/>
+        <p:nvPr/>
+      </p:nvGrpSpPr>
+      <p:grpSpPr>
+        <a:xfrm>
+          <a:off x="0" y="0"/>
+          <a:ext cx="0" cy="0"/>
+          <a:chOff x="0" y="0"/>
+          <a:chExt cx="0" cy="0"/>
+        </a:xfrm>
+      </p:grpSpPr>
+      <p:sp>
+        <p:nvSpPr>
+          <p:cNvPr id="2" name="Title 1">
+            <a:extLst>
+              <a:ext uri="{FF2B5EF4-FFF2-40B4-BE49-F238E27FC236}">
+                <a16:creationId xmlns:a16="http://schemas.microsoft.com/office/drawing/2014/main" id="{00BCC61A-47BB-809E-A896-BA4746ABAFFB}"/>
+              </a:ext>
+            </a:extLst>
+          </p:cNvPr>
+          <p:cNvSpPr>
+            <a:spLocks noGrp="1"/>
+          </p:cNvSpPr>
+          <p:nvPr>
+            <p:ph type="title"/>
+          </p:nvPr>
+        </p:nvSpPr>
+        <p:spPr/>
+        <p:txBody>
+          <a:bodyPr/>
+          <a:lstStyle/>
+          <a:p>
+            <a:r>
+              <a:rPr lang="en-US" dirty="0"/>
+              <a:t>The 10/21/26 PHP vulnerability</a:t>
+            </a:r>
+          </a:p>
+        </p:txBody>
+      </p:sp>
+      <p:sp>
+        <p:nvSpPr>
+          <p:cNvPr id="3" name="Content Placeholder 2">
+            <a:extLst>
+              <a:ext uri="{FF2B5EF4-FFF2-40B4-BE49-F238E27FC236}">
+                <a16:creationId xmlns:a16="http://schemas.microsoft.com/office/drawing/2014/main" id="{0A982635-02F4-0CA4-157E-05FFE131F791}"/>
+              </a:ext>
+            </a:extLst>
+          </p:cNvPr>
+          <p:cNvSpPr>
+            <a:spLocks noGrp="1"/>
+          </p:cNvSpPr>
+          <p:nvPr>
+            <p:ph idx="1"/>
+          </p:nvPr>
+        </p:nvSpPr>
+        <p:spPr/>
+        <p:txBody>
+          <a:bodyPr/>
+          <a:lstStyle/>
+          <a:p>
+            <a:r>
+              <a:rPr lang="en-US" dirty="0"/>
+              <a:t>From </a:t>
+            </a:r>
+            <a:r>
+              <a:rPr lang="en-US" i="1" dirty="0"/>
+              <a:t>The Atlantic…</a:t>
+            </a:r>
+          </a:p>
+          <a:p>
+            <a:r>
+              <a:rPr lang="en-US" i="1">
+                <a:hlinkClick r:id="rId3"/>
+              </a:rPr>
+              <a:t>The Man Who Saved the Internet</a:t>
+            </a:r>
+            <a:endParaRPr lang="en-US" i="1"/>
+          </a:p>
+          <a:p>
+            <a:endParaRPr lang="en-US" dirty="0"/>
+          </a:p>
+        </p:txBody>
+      </p:sp>
+      <p:sp>
+        <p:nvSpPr>
+          <p:cNvPr id="4" name="Slide Number Placeholder 3">
+            <a:extLst>
+              <a:ext uri="{FF2B5EF4-FFF2-40B4-BE49-F238E27FC236}">
+                <a16:creationId xmlns:a16="http://schemas.microsoft.com/office/drawing/2014/main" id="{BBC4241F-F518-AB10-7C82-59E58A664E4B}"/>
+              </a:ext>
+            </a:extLst>
+          </p:cNvPr>
+          <p:cNvSpPr>
+            <a:spLocks noGrp="1"/>
+          </p:cNvSpPr>
+          <p:nvPr>
+            <p:ph type="sldNum" sz="quarter" idx="12"/>
+          </p:nvPr>
+        </p:nvSpPr>
+        <p:spPr/>
+        <p:txBody>
+          <a:bodyPr/>
+          <a:lstStyle/>
+          <a:p>
+            <a:fld id="{20F37917-FD3A-4669-9018-DA04BCDD3D75}" type="slidenum">
+              <a:rPr lang="en-US" smtClean="0"/>
+              <a:t>31</a:t>
+            </a:fld>
+            <a:endParaRPr lang="en-US" dirty="0"/>
+          </a:p>
+        </p:txBody>
+      </p:sp>
+      <p:sp>
+        <p:nvSpPr>
+          <p:cNvPr id="8" name="TextBox 7">
+            <a:extLst>
+              <a:ext uri="{FF2B5EF4-FFF2-40B4-BE49-F238E27FC236}">
+                <a16:creationId xmlns:a16="http://schemas.microsoft.com/office/drawing/2014/main" id="{EBB17C28-A5AB-070B-6971-11BD4BE4C441}"/>
+              </a:ext>
+            </a:extLst>
+          </p:cNvPr>
+          <p:cNvSpPr txBox="1"/>
+          <p:nvPr/>
+        </p:nvSpPr>
+        <p:spPr>
+          <a:xfrm>
+            <a:off x="838200" y="1451497"/>
+            <a:ext cx="6096000" cy="2355966"/>
+          </a:xfrm>
+          <a:prstGeom prst="rect">
+            <a:avLst/>
+          </a:prstGeom>
+          <a:noFill/>
+          <a:ln w="12700" cap="flat" cmpd="sng" algn="ctr">
+            <a:noFill/>
+            <a:prstDash val="solid"/>
+            <a:miter lim="800000"/>
+          </a:ln>
+          <a:effectLst/>
+        </p:spPr>
+        <p:style>
+          <a:lnRef idx="2">
+            <a:schemeClr val="accent1">
+              <a:shade val="50000"/>
+            </a:schemeClr>
+          </a:lnRef>
+          <a:fillRef idx="1">
+            <a:schemeClr val="accent1"/>
+          </a:fillRef>
+          <a:effectRef idx="0">
+            <a:schemeClr val="accent1"/>
+          </a:effectRef>
+          <a:fontRef idx="minor">
+            <a:schemeClr val="lt1"/>
+          </a:fontRef>
+        </p:style>
+        <p:txBody>
+          <a:bodyPr wrap="square">
+            <a:spAutoFit/>
+          </a:bodyPr>
+          <a:lstStyle/>
+          <a:p>
+            <a:pPr marL="0" marR="0" indent="0" algn="l">
+              <a:lnSpc>
+                <a:spcPct val="94203"/>
+              </a:lnSpc>
+              <a:spcAft>
+                <a:spcPts val="1350"/>
+              </a:spcAft>
+              <a:buNone/>
+            </a:pPr>
+            <a:r>
+              <a:rPr lang="en-US" sz="3450" b="0" i="0" dirty="0">
+                <a:solidFill>
+                  <a:srgbClr val="000000"/>
+                </a:solidFill>
+                <a:effectLst/>
+                <a:latin typeface="AGaramondPro"/>
+              </a:rPr>
+              <a:t>‘If Anything Happens to This Guy … Everyone Is Screwed’</a:t>
+            </a:r>
+          </a:p>
+          <a:p>
+            <a:pPr marL="0" marR="0" indent="0" algn="l">
+              <a:lnSpc>
+                <a:spcPct val="111111"/>
+              </a:lnSpc>
+              <a:spcAft>
+                <a:spcPts val="1350"/>
+              </a:spcAft>
+              <a:buNone/>
+            </a:pPr>
+            <a:r>
+              <a:rPr lang="en-US" sz="1800" b="0" i="0" dirty="0">
+                <a:solidFill>
+                  <a:srgbClr val="000000"/>
+                </a:solidFill>
+                <a:effectLst/>
+                <a:latin typeface="AGaramondPro"/>
+              </a:rPr>
+              <a:t>Ondřej </a:t>
+            </a:r>
+            <a:r>
+              <a:rPr lang="en-US" sz="1800" b="0" i="0" dirty="0" err="1">
+                <a:solidFill>
+                  <a:srgbClr val="000000"/>
+                </a:solidFill>
+                <a:effectLst/>
+                <a:latin typeface="AGaramondPro"/>
+              </a:rPr>
+              <a:t>Surý</a:t>
+            </a:r>
+            <a:r>
+              <a:rPr lang="en-US" sz="1800" b="0" i="0" dirty="0">
+                <a:solidFill>
+                  <a:srgbClr val="000000"/>
+                </a:solidFill>
+                <a:effectLst/>
+                <a:latin typeface="AGaramondPro"/>
+              </a:rPr>
+              <a:t> was a relatively anonymous volunteer working on PHP security. Then the internet exploded.</a:t>
+            </a:r>
+          </a:p>
+          <a:p>
+            <a:pPr indent="0" algn="l">
+              <a:lnSpc>
+                <a:spcPct val="111111"/>
+              </a:lnSpc>
+              <a:spcAft>
+                <a:spcPts val="4200"/>
+              </a:spcAft>
+              <a:buNone/>
+            </a:pPr>
+            <a:r>
+              <a:rPr lang="en-US" sz="1800" b="0" i="0" dirty="0">
+                <a:solidFill>
+                  <a:srgbClr val="000000"/>
+                </a:solidFill>
+                <a:effectLst/>
+                <a:latin typeface="AGaramondPro"/>
+              </a:rPr>
+              <a:t>By </a:t>
+            </a:r>
+            <a:r>
+              <a:rPr lang="en-US" sz="1800" b="0" i="0" u="none" strike="noStrike" dirty="0">
+                <a:solidFill>
+                  <a:srgbClr val="000000"/>
+                </a:solidFill>
+                <a:effectLst/>
+                <a:latin typeface="AGaramondPro"/>
+                <a:hlinkClick r:id="rId4"/>
+              </a:rPr>
+              <a:t>Charlie Warzel</a:t>
+            </a:r>
+            <a:endParaRPr lang="en-US" sz="1800" b="0" i="0" dirty="0">
+              <a:solidFill>
+                <a:srgbClr val="000000"/>
+              </a:solidFill>
+              <a:effectLst/>
+              <a:latin typeface="AGaramondPro"/>
+            </a:endParaRPr>
+          </a:p>
+        </p:txBody>
+      </p:sp>
+      <p:sp>
+        <p:nvSpPr>
+          <p:cNvPr id="10" name="TextBox 9">
+            <a:extLst>
+              <a:ext uri="{FF2B5EF4-FFF2-40B4-BE49-F238E27FC236}">
+                <a16:creationId xmlns:a16="http://schemas.microsoft.com/office/drawing/2014/main" id="{17117F81-72B1-F1A2-F1E4-6570B982BB24}"/>
+              </a:ext>
+            </a:extLst>
+          </p:cNvPr>
+          <p:cNvSpPr txBox="1"/>
+          <p:nvPr/>
+        </p:nvSpPr>
+        <p:spPr>
+          <a:xfrm>
+            <a:off x="766916" y="3943282"/>
+            <a:ext cx="6096000" cy="2926442"/>
+          </a:xfrm>
+          <a:prstGeom prst="rect">
+            <a:avLst/>
+          </a:prstGeom>
+          <a:noFill/>
+          <a:ln w="12700" cap="flat" cmpd="sng" algn="ctr">
+            <a:noFill/>
+            <a:prstDash val="solid"/>
+            <a:miter lim="800000"/>
+          </a:ln>
+          <a:effectLst/>
+        </p:spPr>
+        <p:style>
+          <a:lnRef idx="2">
+            <a:schemeClr val="accent1">
+              <a:shade val="50000"/>
+            </a:schemeClr>
+          </a:lnRef>
+          <a:fillRef idx="1">
+            <a:schemeClr val="accent1"/>
+          </a:fillRef>
+          <a:effectRef idx="0">
+            <a:schemeClr val="accent1"/>
+          </a:effectRef>
+          <a:fontRef idx="minor">
+            <a:schemeClr val="lt1"/>
+          </a:fontRef>
+        </p:style>
+        <p:txBody>
+          <a:bodyPr wrap="square">
+            <a:spAutoFit/>
+          </a:bodyPr>
+          <a:lstStyle/>
+          <a:p>
+            <a:pPr indent="0" algn="l">
+              <a:spcAft>
+                <a:spcPts val="2250"/>
+              </a:spcAft>
+              <a:buNone/>
+            </a:pPr>
+            <a:r>
+              <a:rPr lang="en-US" sz="1650" b="0" i="0" dirty="0">
+                <a:solidFill>
+                  <a:srgbClr val="000000"/>
+                </a:solidFill>
+                <a:effectLst/>
+                <a:latin typeface="AGaramondPro"/>
+              </a:rPr>
+              <a:t>“Explaining to my wife how there’s this one guy. And he alone is responsible for most of the world’s distribution of PHP,” a software developer named Ian Landsman </a:t>
+            </a:r>
+            <a:r>
+              <a:rPr lang="en-US" sz="1650" b="0" i="0" dirty="0">
+                <a:solidFill>
+                  <a:srgbClr val="000000"/>
+                </a:solidFill>
+                <a:effectLst/>
+                <a:latin typeface="AGaramondPro"/>
+                <a:hlinkClick r:id="rId5"/>
+              </a:rPr>
+              <a:t>wrote</a:t>
+            </a:r>
+            <a:r>
+              <a:rPr lang="en-US" sz="1650" b="0" i="0" dirty="0">
+                <a:solidFill>
+                  <a:srgbClr val="000000"/>
+                </a:solidFill>
+                <a:effectLst/>
+                <a:latin typeface="AGaramondPro"/>
+              </a:rPr>
+              <a:t> on X. “And if anything happens to this guy, that’s just it. Everyone is screwed.” He was referring to </a:t>
+            </a:r>
+            <a:r>
+              <a:rPr lang="en-US" sz="1650" b="0" i="0" dirty="0" err="1">
+                <a:solidFill>
+                  <a:srgbClr val="000000"/>
+                </a:solidFill>
+                <a:effectLst/>
+                <a:latin typeface="AGaramondPro"/>
+              </a:rPr>
+              <a:t>Surý</a:t>
+            </a:r>
+            <a:r>
+              <a:rPr lang="en-US" sz="1650" b="0" i="0" dirty="0">
+                <a:solidFill>
+                  <a:srgbClr val="000000"/>
+                </a:solidFill>
+                <a:effectLst/>
+                <a:latin typeface="AGaramondPro"/>
+              </a:rPr>
+              <a:t>.</a:t>
+            </a:r>
+          </a:p>
+          <a:p>
+            <a:pPr indent="0" algn="l">
+              <a:spcAft>
+                <a:spcPts val="2250"/>
+              </a:spcAft>
+              <a:buNone/>
+            </a:pPr>
+            <a:r>
+              <a:rPr lang="en-US" sz="1650" b="0" i="0" dirty="0" err="1">
+                <a:solidFill>
+                  <a:srgbClr val="000000"/>
+                </a:solidFill>
+                <a:effectLst/>
+                <a:latin typeface="AGaramondPro"/>
+              </a:rPr>
+              <a:t>Surý</a:t>
+            </a:r>
+            <a:r>
+              <a:rPr lang="en-US" sz="1650" b="0" i="0" dirty="0">
+                <a:solidFill>
+                  <a:srgbClr val="000000"/>
+                </a:solidFill>
+                <a:effectLst/>
+                <a:latin typeface="AGaramondPro"/>
+              </a:rPr>
+              <a:t>, who lives in Czechia, does not work for the PHP Foundation. But alongside his day job as director of domain-name-system engineering at the nonprofit Internet Systems Consortium, in a volunteer capacity, he maintains and helps automate patches for the coding language.</a:t>
+            </a:r>
+          </a:p>
+        </p:txBody>
+      </p:sp>
+    </p:spTree>
+    <p:extLst>
+      <p:ext uri="{BB962C8B-B14F-4D97-AF65-F5344CB8AC3E}">
+        <p14:creationId xmlns:p14="http://schemas.microsoft.com/office/powerpoint/2010/main" val="1264209119"/>
+      </p:ext>
+    </p:extLst>
+  </p:cSld>
+  <p:clrMapOvr>
+    <a:masterClrMapping/>
+  </p:clrMapOvr>
+</p:sld>
+</file>
+
+<file path=ppt/slides/slide32.xml><?xml version="1.0" encoding="utf-8"?>
+<p:sld xmlns:a="http://schemas.openxmlformats.org/drawingml/2006/main" xmlns:r="http://schemas.openxmlformats.org/officeDocument/2006/relationships" xmlns:p="http://schemas.openxmlformats.org/presentationml/2006/main">
+  <p:cSld>
+    <p:spTree>
+      <p:nvGrpSpPr>
+        <p:cNvPr id="1" name=""/>
+        <p:cNvGrpSpPr/>
+        <p:nvPr/>
+      </p:nvGrpSpPr>
+      <p:grpSpPr>
+        <a:xfrm>
+          <a:off x="0" y="0"/>
+          <a:ext cx="0" cy="0"/>
+          <a:chOff x="0" y="0"/>
+          <a:chExt cx="0" cy="0"/>
+        </a:xfrm>
+      </p:grpSpPr>
+      <p:sp>
+        <p:nvSpPr>
+          <p:cNvPr id="2" name="Title 1">
+            <a:extLst>
+              <a:ext uri="{FF2B5EF4-FFF2-40B4-BE49-F238E27FC236}">
                 <a16:creationId xmlns:a16="http://schemas.microsoft.com/office/drawing/2014/main" id="{37634E01-2FA1-197A-5356-A65E7B0A2B57}"/>
               </a:ext>
             </a:extLst>
@@ -18632,7 +19366,7 @@
           <a:p>
             <a:fld id="{20F37917-FD3A-4669-9018-DA04BCDD3D75}" type="slidenum">
               <a:rPr lang="en-US" smtClean="0"/>
-              <a:t>30</a:t>
+              <a:t>32</a:t>
             </a:fld>
             <a:endParaRPr lang="en-US"/>
           </a:p>
@@ -18755,7 +19489,7 @@
 </p:sld>
 </file>
 
-<file path=ppt/slides/slide31.xml><?xml version="1.0" encoding="utf-8"?>
+<file path=ppt/slides/slide33.xml><?xml version="1.0" encoding="utf-8"?>
 <p:sld xmlns:a="http://schemas.openxmlformats.org/drawingml/2006/main" xmlns:r="http://schemas.openxmlformats.org/officeDocument/2006/relationships" xmlns:p="http://schemas.openxmlformats.org/presentationml/2006/main">
   <p:cSld>
     <p:spTree>
@@ -18921,7 +19655,7 @@
           <a:p>
             <a:fld id="{20F37917-FD3A-4669-9018-DA04BCDD3D75}" type="slidenum">
               <a:rPr lang="en-US" smtClean="0"/>
-              <a:t>31</a:t>
+              <a:t>33</a:t>
             </a:fld>
             <a:endParaRPr lang="en-US"/>
           </a:p>
@@ -18940,7 +19674,7 @@
 </p:sld>
 </file>
 
-<file path=ppt/slides/slide32.xml><?xml version="1.0" encoding="utf-8"?>
+<file path=ppt/slides/slide34.xml><?xml version="1.0" encoding="utf-8"?>
 <p:sld xmlns:a="http://schemas.openxmlformats.org/drawingml/2006/main" xmlns:r="http://schemas.openxmlformats.org/officeDocument/2006/relationships" xmlns:p="http://schemas.openxmlformats.org/presentationml/2006/main">
   <p:cSld>
     <p:spTree>
@@ -19394,8 +20128,8 @@
 </p:sld>
 </file>
 
-<file path=ppt/slides/slide33.xml><?xml version="1.0" encoding="utf-8"?>
-<p:sld xmlns:a="http://schemas.openxmlformats.org/drawingml/2006/main" xmlns:r="http://schemas.openxmlformats.org/officeDocument/2006/relationships" xmlns:p="http://schemas.openxmlformats.org/presentationml/2006/main">
+<file path=ppt/slides/slide35.xml><?xml version="1.0" encoding="utf-8"?>
+<p:sld xmlns:a="http://schemas.openxmlformats.org/drawingml/2006/main" xmlns:r="http://schemas.openxmlformats.org/officeDocument/2006/relationships" xmlns:p="http://schemas.openxmlformats.org/presentationml/2006/main" show="0">
   <p:cSld>
     <p:spTree>
       <p:nvGrpSpPr>
@@ -19563,7 +20297,7 @@
           <a:p>
             <a:fld id="{20F37917-FD3A-4669-9018-DA04BCDD3D75}" type="slidenum">
               <a:rPr lang="en-US" smtClean="0"/>
-              <a:t>33</a:t>
+              <a:t>35</a:t>
             </a:fld>
             <a:endParaRPr lang="en-US"/>
           </a:p>
@@ -19627,7 +20361,7 @@
           <a:effectLst/>
           <a:extLst>
             <a:ext uri="{C572A759-6A51-4108-AA02-DFA0A04FC94B}">
-              <ma14:wrappingTextBoxFlag xmlns:ma14="http://schemas.microsoft.com/office/mac/drawingml/2011/main" xmlns:a14="http://schemas.microsoft.com/office/drawing/2010/main" xmlns:m="http://schemas.openxmlformats.org/officeDocument/2006/math" xmlns="" val="1"/>
+              <ma14:wrappingTextBoxFlag xmlns="" xmlns:m="http://schemas.openxmlformats.org/officeDocument/2006/math" xmlns:a14="http://schemas.microsoft.com/office/drawing/2010/main" xmlns:ma14="http://schemas.microsoft.com/office/mac/drawingml/2011/main" val="1"/>
             </a:ext>
           </a:extLst>
         </p:spPr>
@@ -19751,7 +20485,7 @@
 </p:sld>
 </file>
 
-<file path=ppt/slides/slide34.xml><?xml version="1.0" encoding="utf-8"?>
+<file path=ppt/slides/slide36.xml><?xml version="1.0" encoding="utf-8"?>
 <p:sld xmlns:a="http://schemas.openxmlformats.org/drawingml/2006/main" xmlns:r="http://schemas.openxmlformats.org/officeDocument/2006/relationships" xmlns:p="http://schemas.openxmlformats.org/presentationml/2006/main">
   <p:cSld>
     <p:spTree>
@@ -19888,7 +20622,7 @@
           <a:p>
             <a:fld id="{20F37917-FD3A-4669-9018-DA04BCDD3D75}" type="slidenum">
               <a:rPr lang="en-US" smtClean="0"/>
-              <a:t>34</a:t>
+              <a:t>36</a:t>
             </a:fld>
             <a:endParaRPr lang="en-US"/>
           </a:p>
@@ -19907,7 +20641,7 @@
 </p:sld>
 </file>
 
-<file path=ppt/slides/slide35.xml><?xml version="1.0" encoding="utf-8"?>
+<file path=ppt/slides/slide37.xml><?xml version="1.0" encoding="utf-8"?>
 <p:sld xmlns:a="http://schemas.openxmlformats.org/drawingml/2006/main" xmlns:r="http://schemas.openxmlformats.org/officeDocument/2006/relationships" xmlns:p="http://schemas.openxmlformats.org/presentationml/2006/main" show="0">
   <p:cSld>
     <p:spTree>
@@ -19975,7 +20709,7 @@
           <a:p>
             <a:fld id="{20F37917-FD3A-4669-9018-DA04BCDD3D75}" type="slidenum">
               <a:rPr lang="en-US" smtClean="0"/>
-              <a:t>35</a:t>
+              <a:t>37</a:t>
             </a:fld>
             <a:endParaRPr lang="en-US"/>
           </a:p>
@@ -20063,344 +20797,6 @@
 </p:sld>
 </file>
 
-<file path=ppt/slides/slide36.xml><?xml version="1.0" encoding="utf-8"?>
-<p:sld xmlns:a="http://schemas.openxmlformats.org/drawingml/2006/main" xmlns:r="http://schemas.openxmlformats.org/officeDocument/2006/relationships" xmlns:p="http://schemas.openxmlformats.org/presentationml/2006/main">
-  <p:cSld>
-    <p:spTree>
-      <p:nvGrpSpPr>
-        <p:cNvPr id="1" name=""/>
-        <p:cNvGrpSpPr/>
-        <p:nvPr/>
-      </p:nvGrpSpPr>
-      <p:grpSpPr>
-        <a:xfrm>
-          <a:off x="0" y="0"/>
-          <a:ext cx="0" cy="0"/>
-          <a:chOff x="0" y="0"/>
-          <a:chExt cx="0" cy="0"/>
-        </a:xfrm>
-      </p:grpSpPr>
-      <p:sp>
-        <p:nvSpPr>
-          <p:cNvPr id="2" name="Title 1">
-            <a:extLst>
-              <a:ext uri="{FF2B5EF4-FFF2-40B4-BE49-F238E27FC236}">
-                <a16:creationId xmlns:a16="http://schemas.microsoft.com/office/drawing/2014/main" id="{A9E99567-945A-A649-A6D6-B4FE1391686D}"/>
-              </a:ext>
-            </a:extLst>
-          </p:cNvPr>
-          <p:cNvSpPr>
-            <a:spLocks noGrp="1"/>
-          </p:cNvSpPr>
-          <p:nvPr>
-            <p:ph type="title"/>
-          </p:nvPr>
-        </p:nvSpPr>
-        <p:spPr/>
-        <p:txBody>
-          <a:bodyPr/>
-          <a:lstStyle/>
-          <a:p>
-            <a:r>
-              <a:rPr lang="en-US" dirty="0"/>
-              <a:t>Process-level Threat Mitigations</a:t>
-            </a:r>
-          </a:p>
-        </p:txBody>
-      </p:sp>
-      <p:sp>
-        <p:nvSpPr>
-          <p:cNvPr id="3" name="Text Placeholder 2">
-            <a:extLst>
-              <a:ext uri="{FF2B5EF4-FFF2-40B4-BE49-F238E27FC236}">
-                <a16:creationId xmlns:a16="http://schemas.microsoft.com/office/drawing/2014/main" id="{B7B5497D-6087-DB49-8031-3C71B1856A1B}"/>
-              </a:ext>
-            </a:extLst>
-          </p:cNvPr>
-          <p:cNvSpPr>
-            <a:spLocks noGrp="1"/>
-          </p:cNvSpPr>
-          <p:nvPr>
-            <p:ph idx="1"/>
-          </p:nvPr>
-        </p:nvSpPr>
-        <p:spPr/>
-        <p:txBody>
-          <a:bodyPr>
-            <a:normAutofit fontScale="92500" lnSpcReduction="20000"/>
-          </a:bodyPr>
-          <a:lstStyle/>
-          <a:p>
-            <a:r>
-              <a:rPr lang="en-US" dirty="0"/>
-              <a:t>External dependencies</a:t>
-            </a:r>
-          </a:p>
-          <a:p>
-            <a:pPr lvl="1">
-              <a:spcBef>
-                <a:spcPts val="1000"/>
-              </a:spcBef>
-            </a:pPr>
-            <a:r>
-              <a:rPr lang="en-US" dirty="0"/>
-              <a:t>Audit all dependencies and their updates before applying them</a:t>
-            </a:r>
-          </a:p>
-          <a:p>
-            <a:r>
-              <a:rPr lang="en-US" dirty="0"/>
-              <a:t>In-house code</a:t>
-            </a:r>
-          </a:p>
-          <a:p>
-            <a:pPr lvl="1">
-              <a:spcBef>
-                <a:spcPts val="1000"/>
-              </a:spcBef>
-            </a:pPr>
-            <a:r>
-              <a:rPr lang="en-US" dirty="0"/>
-              <a:t>Require developers to sign code before committing, require 2FA for signing keys, rotate signing keys regularly</a:t>
-            </a:r>
-          </a:p>
-          <a:p>
-            <a:r>
-              <a:rPr lang="en-US" dirty="0"/>
-              <a:t>Build process</a:t>
-            </a:r>
-          </a:p>
-          <a:p>
-            <a:pPr lvl="1">
-              <a:spcBef>
-                <a:spcPts val="1000"/>
-              </a:spcBef>
-            </a:pPr>
-            <a:r>
-              <a:rPr lang="en-US" dirty="0"/>
-              <a:t>Audit build software, use trusted compilers and build chains</a:t>
-            </a:r>
-          </a:p>
-          <a:p>
-            <a:r>
-              <a:rPr lang="en-US" dirty="0"/>
-              <a:t>Distribution process</a:t>
-            </a:r>
-          </a:p>
-          <a:p>
-            <a:pPr lvl="1">
-              <a:spcBef>
-                <a:spcPts val="1000"/>
-              </a:spcBef>
-            </a:pPr>
-            <a:r>
-              <a:rPr lang="en-US" dirty="0"/>
-              <a:t>Sign all packages, protect signing keys</a:t>
-            </a:r>
-          </a:p>
-          <a:p>
-            <a:r>
-              <a:rPr lang="en-US" dirty="0"/>
-              <a:t>Operating environment</a:t>
-            </a:r>
-          </a:p>
-          <a:p>
-            <a:pPr lvl="1">
-              <a:spcBef>
-                <a:spcPts val="1000"/>
-              </a:spcBef>
-            </a:pPr>
-            <a:r>
-              <a:rPr lang="en-US" dirty="0"/>
-              <a:t>Isolate applications in containers or VMs</a:t>
-            </a:r>
-          </a:p>
-        </p:txBody>
-      </p:sp>
-    </p:spTree>
-    <p:extLst>
-      <p:ext uri="{BB962C8B-B14F-4D97-AF65-F5344CB8AC3E}">
-        <p14:creationId xmlns:p14="http://schemas.microsoft.com/office/powerpoint/2010/main" val="52659804"/>
-      </p:ext>
-    </p:extLst>
-  </p:cSld>
-  <p:clrMapOvr>
-    <a:masterClrMapping/>
-  </p:clrMapOvr>
-</p:sld>
-</file>
-
-<file path=ppt/slides/slide37.xml><?xml version="1.0" encoding="utf-8"?>
-<p:sld xmlns:a="http://schemas.openxmlformats.org/drawingml/2006/main" xmlns:r="http://schemas.openxmlformats.org/officeDocument/2006/relationships" xmlns:p="http://schemas.openxmlformats.org/presentationml/2006/main">
-  <p:cSld>
-    <p:spTree>
-      <p:nvGrpSpPr>
-        <p:cNvPr id="1" name=""/>
-        <p:cNvGrpSpPr/>
-        <p:nvPr/>
-      </p:nvGrpSpPr>
-      <p:grpSpPr>
-        <a:xfrm>
-          <a:off x="0" y="0"/>
-          <a:ext cx="0" cy="0"/>
-          <a:chOff x="0" y="0"/>
-          <a:chExt cx="0" cy="0"/>
-        </a:xfrm>
-      </p:grpSpPr>
-      <p:sp>
-        <p:nvSpPr>
-          <p:cNvPr id="2" name="Title 1">
-            <a:extLst>
-              <a:ext uri="{FF2B5EF4-FFF2-40B4-BE49-F238E27FC236}">
-                <a16:creationId xmlns:a16="http://schemas.microsoft.com/office/drawing/2014/main" id="{13A96010-2848-3F79-FC80-A141A47E7F3F}"/>
-              </a:ext>
-            </a:extLst>
-          </p:cNvPr>
-          <p:cNvSpPr>
-            <a:spLocks noGrp="1"/>
-          </p:cNvSpPr>
-          <p:nvPr>
-            <p:ph type="title"/>
-          </p:nvPr>
-        </p:nvSpPr>
-        <p:spPr/>
-        <p:txBody>
-          <a:bodyPr/>
-          <a:lstStyle/>
-          <a:p>
-            <a:r>
-              <a:rPr lang="en-US" dirty="0"/>
-              <a:t>Vulnerability #5: Failure to Apply Security Policies</a:t>
-            </a:r>
-          </a:p>
-        </p:txBody>
-      </p:sp>
-      <p:sp>
-        <p:nvSpPr>
-          <p:cNvPr id="3" name="Content Placeholder 2">
-            <a:extLst>
-              <a:ext uri="{FF2B5EF4-FFF2-40B4-BE49-F238E27FC236}">
-                <a16:creationId xmlns:a16="http://schemas.microsoft.com/office/drawing/2014/main" id="{8EF9911C-7C41-FC72-C3DB-359B3DDE35C7}"/>
-              </a:ext>
-            </a:extLst>
-          </p:cNvPr>
-          <p:cNvSpPr>
-            <a:spLocks noGrp="1"/>
-          </p:cNvSpPr>
-          <p:nvPr>
-            <p:ph idx="1"/>
-          </p:nvPr>
-        </p:nvSpPr>
-        <p:spPr/>
-        <p:txBody>
-          <a:bodyPr/>
-          <a:lstStyle/>
-          <a:p>
-            <a:pPr marL="0" indent="0">
-              <a:buNone/>
-            </a:pPr>
-            <a:r>
-              <a:rPr lang="en-US" dirty="0"/>
-              <a:t>Remember the outline of our lecture:</a:t>
-            </a:r>
-          </a:p>
-          <a:p>
-            <a:pPr marL="514350" indent="-514350">
-              <a:buFont typeface="+mj-lt"/>
-              <a:buAutoNum type="arabicPeriod"/>
-            </a:pPr>
-            <a:r>
-              <a:rPr lang="en-US" dirty="0">
-                <a:solidFill>
-                  <a:schemeClr val="bg2">
-                    <a:lumMod val="75000"/>
-                  </a:schemeClr>
-                </a:solidFill>
-              </a:rPr>
-              <a:t>Definition of key vocabulary</a:t>
-            </a:r>
-          </a:p>
-          <a:p>
-            <a:pPr marL="514350" indent="-514350">
-              <a:buFont typeface="+mj-lt"/>
-              <a:buAutoNum type="arabicPeriod"/>
-            </a:pPr>
-            <a:r>
-              <a:rPr lang="en-US" dirty="0">
-                <a:solidFill>
-                  <a:schemeClr val="bg2">
-                    <a:lumMod val="75000"/>
-                  </a:schemeClr>
-                </a:solidFill>
-              </a:rPr>
-              <a:t>Some common vulnerabilities, and possible mitigations</a:t>
-            </a:r>
-          </a:p>
-          <a:p>
-            <a:pPr marL="514350" indent="-514350">
-              <a:buFont typeface="+mj-lt"/>
-              <a:buAutoNum type="arabicPeriod"/>
-            </a:pPr>
-            <a:r>
-              <a:rPr lang="en-US" dirty="0">
-                <a:solidFill>
-                  <a:srgbClr val="FF0000"/>
-                </a:solidFill>
-              </a:rPr>
-              <a:t>Getting security right is about people as well as software.</a:t>
-            </a:r>
-          </a:p>
-          <a:p>
-            <a:pPr marL="514350" indent="-514350">
-              <a:buFont typeface="+mj-lt"/>
-              <a:buAutoNum type="arabicPeriod"/>
-            </a:pPr>
-            <a:endParaRPr lang="en-US" dirty="0"/>
-          </a:p>
-        </p:txBody>
-      </p:sp>
-      <p:sp>
-        <p:nvSpPr>
-          <p:cNvPr id="4" name="Slide Number Placeholder 3">
-            <a:extLst>
-              <a:ext uri="{FF2B5EF4-FFF2-40B4-BE49-F238E27FC236}">
-                <a16:creationId xmlns:a16="http://schemas.microsoft.com/office/drawing/2014/main" id="{2A7DE133-ADDD-9C96-A427-C9A2BD0FB364}"/>
-              </a:ext>
-            </a:extLst>
-          </p:cNvPr>
-          <p:cNvSpPr>
-            <a:spLocks noGrp="1"/>
-          </p:cNvSpPr>
-          <p:nvPr>
-            <p:ph type="sldNum" sz="quarter" idx="12"/>
-          </p:nvPr>
-        </p:nvSpPr>
-        <p:spPr/>
-        <p:txBody>
-          <a:bodyPr/>
-          <a:lstStyle/>
-          <a:p>
-            <a:fld id="{20F37917-FD3A-4669-9018-DA04BCDD3D75}" type="slidenum">
-              <a:rPr lang="en-US" smtClean="0"/>
-              <a:t>37</a:t>
-            </a:fld>
-            <a:endParaRPr lang="en-US"/>
-          </a:p>
-        </p:txBody>
-      </p:sp>
-    </p:spTree>
-    <p:extLst>
-      <p:ext uri="{BB962C8B-B14F-4D97-AF65-F5344CB8AC3E}">
-        <p14:creationId xmlns:p14="http://schemas.microsoft.com/office/powerpoint/2010/main" val="1364659895"/>
-      </p:ext>
-    </p:extLst>
-  </p:cSld>
-  <p:clrMapOvr>
-    <a:masterClrMapping/>
-  </p:clrMapOvr>
-</p:sld>
-</file>
-
 <file path=ppt/slides/slide38.xml><?xml version="1.0" encoding="utf-8"?>
 <p:sld xmlns:a="http://schemas.openxmlformats.org/drawingml/2006/main" xmlns:r="http://schemas.openxmlformats.org/officeDocument/2006/relationships" xmlns:p="http://schemas.openxmlformats.org/presentationml/2006/main">
   <p:cSld>
@@ -20423,6 +20819,480 @@
           <p:cNvPr id="2" name="Title 1">
             <a:extLst>
               <a:ext uri="{FF2B5EF4-FFF2-40B4-BE49-F238E27FC236}">
+                <a16:creationId xmlns:a16="http://schemas.microsoft.com/office/drawing/2014/main" id="{A9E99567-945A-A649-A6D6-B4FE1391686D}"/>
+              </a:ext>
+            </a:extLst>
+          </p:cNvPr>
+          <p:cNvSpPr>
+            <a:spLocks noGrp="1"/>
+          </p:cNvSpPr>
+          <p:nvPr>
+            <p:ph type="title"/>
+          </p:nvPr>
+        </p:nvSpPr>
+        <p:spPr/>
+        <p:txBody>
+          <a:bodyPr/>
+          <a:lstStyle/>
+          <a:p>
+            <a:r>
+              <a:rPr lang="en-US" dirty="0"/>
+              <a:t>Process-level Threat Mitigations</a:t>
+            </a:r>
+          </a:p>
+        </p:txBody>
+      </p:sp>
+      <p:sp>
+        <p:nvSpPr>
+          <p:cNvPr id="3" name="Text Placeholder 2">
+            <a:extLst>
+              <a:ext uri="{FF2B5EF4-FFF2-40B4-BE49-F238E27FC236}">
+                <a16:creationId xmlns:a16="http://schemas.microsoft.com/office/drawing/2014/main" id="{B7B5497D-6087-DB49-8031-3C71B1856A1B}"/>
+              </a:ext>
+            </a:extLst>
+          </p:cNvPr>
+          <p:cNvSpPr>
+            <a:spLocks noGrp="1"/>
+          </p:cNvSpPr>
+          <p:nvPr>
+            <p:ph idx="1"/>
+          </p:nvPr>
+        </p:nvSpPr>
+        <p:spPr/>
+        <p:txBody>
+          <a:bodyPr>
+            <a:normAutofit fontScale="92500" lnSpcReduction="20000"/>
+          </a:bodyPr>
+          <a:lstStyle/>
+          <a:p>
+            <a:r>
+              <a:rPr lang="en-US" dirty="0"/>
+              <a:t>External dependencies</a:t>
+            </a:r>
+          </a:p>
+          <a:p>
+            <a:pPr lvl="1">
+              <a:spcBef>
+                <a:spcPts val="1000"/>
+              </a:spcBef>
+            </a:pPr>
+            <a:r>
+              <a:rPr lang="en-US" dirty="0"/>
+              <a:t>Audit all dependencies and their updates before applying them</a:t>
+            </a:r>
+          </a:p>
+          <a:p>
+            <a:r>
+              <a:rPr lang="en-US" dirty="0"/>
+              <a:t>In-house code</a:t>
+            </a:r>
+          </a:p>
+          <a:p>
+            <a:pPr lvl="1">
+              <a:spcBef>
+                <a:spcPts val="1000"/>
+              </a:spcBef>
+            </a:pPr>
+            <a:r>
+              <a:rPr lang="en-US" dirty="0"/>
+              <a:t>Require developers to sign code before committing, require 2FA for signing keys, rotate signing keys regularly</a:t>
+            </a:r>
+          </a:p>
+          <a:p>
+            <a:r>
+              <a:rPr lang="en-US" dirty="0"/>
+              <a:t>Build process</a:t>
+            </a:r>
+          </a:p>
+          <a:p>
+            <a:pPr lvl="1">
+              <a:spcBef>
+                <a:spcPts val="1000"/>
+              </a:spcBef>
+            </a:pPr>
+            <a:r>
+              <a:rPr lang="en-US" dirty="0"/>
+              <a:t>Audit build software, use trusted compilers and build chains</a:t>
+            </a:r>
+          </a:p>
+          <a:p>
+            <a:r>
+              <a:rPr lang="en-US" dirty="0"/>
+              <a:t>Distribution process</a:t>
+            </a:r>
+          </a:p>
+          <a:p>
+            <a:pPr lvl="1">
+              <a:spcBef>
+                <a:spcPts val="1000"/>
+              </a:spcBef>
+            </a:pPr>
+            <a:r>
+              <a:rPr lang="en-US" dirty="0"/>
+              <a:t>Sign all packages, protect signing keys</a:t>
+            </a:r>
+          </a:p>
+          <a:p>
+            <a:r>
+              <a:rPr lang="en-US" dirty="0"/>
+              <a:t>Operating environment</a:t>
+            </a:r>
+          </a:p>
+          <a:p>
+            <a:pPr lvl="1">
+              <a:spcBef>
+                <a:spcPts val="1000"/>
+              </a:spcBef>
+            </a:pPr>
+            <a:r>
+              <a:rPr lang="en-US" dirty="0"/>
+              <a:t>Isolate applications in containers or VMs</a:t>
+            </a:r>
+          </a:p>
+        </p:txBody>
+      </p:sp>
+    </p:spTree>
+    <p:extLst>
+      <p:ext uri="{BB962C8B-B14F-4D97-AF65-F5344CB8AC3E}">
+        <p14:creationId xmlns:p14="http://schemas.microsoft.com/office/powerpoint/2010/main" val="52659804"/>
+      </p:ext>
+    </p:extLst>
+  </p:cSld>
+  <p:clrMapOvr>
+    <a:masterClrMapping/>
+  </p:clrMapOvr>
+</p:sld>
+</file>
+
+<file path=ppt/slides/slide39.xml><?xml version="1.0" encoding="utf-8"?>
+<p:sld xmlns:a="http://schemas.openxmlformats.org/drawingml/2006/main" xmlns:r="http://schemas.openxmlformats.org/officeDocument/2006/relationships" xmlns:p="http://schemas.openxmlformats.org/presentationml/2006/main">
+  <p:cSld>
+    <p:spTree>
+      <p:nvGrpSpPr>
+        <p:cNvPr id="1" name=""/>
+        <p:cNvGrpSpPr/>
+        <p:nvPr/>
+      </p:nvGrpSpPr>
+      <p:grpSpPr>
+        <a:xfrm>
+          <a:off x="0" y="0"/>
+          <a:ext cx="0" cy="0"/>
+          <a:chOff x="0" y="0"/>
+          <a:chExt cx="0" cy="0"/>
+        </a:xfrm>
+      </p:grpSpPr>
+      <p:sp>
+        <p:nvSpPr>
+          <p:cNvPr id="2" name="Title 1">
+            <a:extLst>
+              <a:ext uri="{FF2B5EF4-FFF2-40B4-BE49-F238E27FC236}">
+                <a16:creationId xmlns:a16="http://schemas.microsoft.com/office/drawing/2014/main" id="{13A96010-2848-3F79-FC80-A141A47E7F3F}"/>
+              </a:ext>
+            </a:extLst>
+          </p:cNvPr>
+          <p:cNvSpPr>
+            <a:spLocks noGrp="1"/>
+          </p:cNvSpPr>
+          <p:nvPr>
+            <p:ph type="title"/>
+          </p:nvPr>
+        </p:nvSpPr>
+        <p:spPr/>
+        <p:txBody>
+          <a:bodyPr/>
+          <a:lstStyle/>
+          <a:p>
+            <a:r>
+              <a:rPr lang="en-US" dirty="0"/>
+              <a:t>Vulnerability #5: Failure to Apply Security Policies</a:t>
+            </a:r>
+          </a:p>
+        </p:txBody>
+      </p:sp>
+      <p:sp>
+        <p:nvSpPr>
+          <p:cNvPr id="3" name="Content Placeholder 2">
+            <a:extLst>
+              <a:ext uri="{FF2B5EF4-FFF2-40B4-BE49-F238E27FC236}">
+                <a16:creationId xmlns:a16="http://schemas.microsoft.com/office/drawing/2014/main" id="{8EF9911C-7C41-FC72-C3DB-359B3DDE35C7}"/>
+              </a:ext>
+            </a:extLst>
+          </p:cNvPr>
+          <p:cNvSpPr>
+            <a:spLocks noGrp="1"/>
+          </p:cNvSpPr>
+          <p:nvPr>
+            <p:ph idx="1"/>
+          </p:nvPr>
+        </p:nvSpPr>
+        <p:spPr/>
+        <p:txBody>
+          <a:bodyPr/>
+          <a:lstStyle/>
+          <a:p>
+            <a:pPr marL="0" indent="0">
+              <a:buNone/>
+            </a:pPr>
+            <a:r>
+              <a:rPr lang="en-US" dirty="0"/>
+              <a:t>Remember the outline of our lecture:</a:t>
+            </a:r>
+          </a:p>
+          <a:p>
+            <a:pPr marL="514350" indent="-514350">
+              <a:buFont typeface="+mj-lt"/>
+              <a:buAutoNum type="arabicPeriod"/>
+            </a:pPr>
+            <a:r>
+              <a:rPr lang="en-US" dirty="0">
+                <a:solidFill>
+                  <a:schemeClr val="bg2">
+                    <a:lumMod val="75000"/>
+                  </a:schemeClr>
+                </a:solidFill>
+              </a:rPr>
+              <a:t>Definition of key vocabulary</a:t>
+            </a:r>
+          </a:p>
+          <a:p>
+            <a:pPr marL="514350" indent="-514350">
+              <a:buFont typeface="+mj-lt"/>
+              <a:buAutoNum type="arabicPeriod"/>
+            </a:pPr>
+            <a:r>
+              <a:rPr lang="en-US" dirty="0">
+                <a:solidFill>
+                  <a:schemeClr val="bg2">
+                    <a:lumMod val="75000"/>
+                  </a:schemeClr>
+                </a:solidFill>
+              </a:rPr>
+              <a:t>Some common vulnerabilities, and possible mitigations</a:t>
+            </a:r>
+          </a:p>
+          <a:p>
+            <a:pPr marL="514350" indent="-514350">
+              <a:buFont typeface="+mj-lt"/>
+              <a:buAutoNum type="arabicPeriod"/>
+            </a:pPr>
+            <a:r>
+              <a:rPr lang="en-US" dirty="0">
+                <a:solidFill>
+                  <a:srgbClr val="FF0000"/>
+                </a:solidFill>
+              </a:rPr>
+              <a:t>Getting security right is about people as well as software.</a:t>
+            </a:r>
+          </a:p>
+          <a:p>
+            <a:pPr marL="514350" indent="-514350">
+              <a:buFont typeface="+mj-lt"/>
+              <a:buAutoNum type="arabicPeriod"/>
+            </a:pPr>
+            <a:endParaRPr lang="en-US" dirty="0"/>
+          </a:p>
+        </p:txBody>
+      </p:sp>
+      <p:sp>
+        <p:nvSpPr>
+          <p:cNvPr id="4" name="Slide Number Placeholder 3">
+            <a:extLst>
+              <a:ext uri="{FF2B5EF4-FFF2-40B4-BE49-F238E27FC236}">
+                <a16:creationId xmlns:a16="http://schemas.microsoft.com/office/drawing/2014/main" id="{2A7DE133-ADDD-9C96-A427-C9A2BD0FB364}"/>
+              </a:ext>
+            </a:extLst>
+          </p:cNvPr>
+          <p:cNvSpPr>
+            <a:spLocks noGrp="1"/>
+          </p:cNvSpPr>
+          <p:nvPr>
+            <p:ph type="sldNum" sz="quarter" idx="12"/>
+          </p:nvPr>
+        </p:nvSpPr>
+        <p:spPr/>
+        <p:txBody>
+          <a:bodyPr/>
+          <a:lstStyle/>
+          <a:p>
+            <a:fld id="{20F37917-FD3A-4669-9018-DA04BCDD3D75}" type="slidenum">
+              <a:rPr lang="en-US" smtClean="0"/>
+              <a:t>39</a:t>
+            </a:fld>
+            <a:endParaRPr lang="en-US"/>
+          </a:p>
+        </p:txBody>
+      </p:sp>
+    </p:spTree>
+    <p:extLst>
+      <p:ext uri="{BB962C8B-B14F-4D97-AF65-F5344CB8AC3E}">
+        <p14:creationId xmlns:p14="http://schemas.microsoft.com/office/powerpoint/2010/main" val="1364659895"/>
+      </p:ext>
+    </p:extLst>
+  </p:cSld>
+  <p:clrMapOvr>
+    <a:masterClrMapping/>
+  </p:clrMapOvr>
+</p:sld>
+</file>
+
+<file path=ppt/slides/slide4.xml><?xml version="1.0" encoding="utf-8"?>
+<p:sld xmlns:a="http://schemas.openxmlformats.org/drawingml/2006/main" xmlns:r="http://schemas.openxmlformats.org/officeDocument/2006/relationships" xmlns:p="http://schemas.openxmlformats.org/presentationml/2006/main">
+  <p:cSld>
+    <p:spTree>
+      <p:nvGrpSpPr>
+        <p:cNvPr id="1" name=""/>
+        <p:cNvGrpSpPr/>
+        <p:nvPr/>
+      </p:nvGrpSpPr>
+      <p:grpSpPr>
+        <a:xfrm>
+          <a:off x="0" y="0"/>
+          <a:ext cx="0" cy="0"/>
+          <a:chOff x="0" y="0"/>
+          <a:chExt cx="0" cy="0"/>
+        </a:xfrm>
+      </p:grpSpPr>
+      <p:sp>
+        <p:nvSpPr>
+          <p:cNvPr id="2" name="Title 1">
+            <a:extLst>
+              <a:ext uri="{FF2B5EF4-FFF2-40B4-BE49-F238E27FC236}">
+                <a16:creationId xmlns:a16="http://schemas.microsoft.com/office/drawing/2014/main" id="{1FD5EE76-9285-238F-5EE7-FE6F356AA0D1}"/>
+              </a:ext>
+            </a:extLst>
+          </p:cNvPr>
+          <p:cNvSpPr>
+            <a:spLocks noGrp="1"/>
+          </p:cNvSpPr>
+          <p:nvPr>
+            <p:ph type="title"/>
+          </p:nvPr>
+        </p:nvSpPr>
+        <p:spPr/>
+        <p:txBody>
+          <a:bodyPr/>
+          <a:lstStyle/>
+          <a:p>
+            <a:r>
+              <a:rPr lang="en-US" dirty="0"/>
+              <a:t>Security: Basic Vocabulary (1)</a:t>
+            </a:r>
+          </a:p>
+        </p:txBody>
+      </p:sp>
+      <p:sp>
+        <p:nvSpPr>
+          <p:cNvPr id="3" name="Content Placeholder 2">
+            <a:extLst>
+              <a:ext uri="{FF2B5EF4-FFF2-40B4-BE49-F238E27FC236}">
+                <a16:creationId xmlns:a16="http://schemas.microsoft.com/office/drawing/2014/main" id="{51FF7043-E4F9-A17C-F3B8-FD58CA6A73D6}"/>
+              </a:ext>
+            </a:extLst>
+          </p:cNvPr>
+          <p:cNvSpPr>
+            <a:spLocks noGrp="1"/>
+          </p:cNvSpPr>
+          <p:nvPr>
+            <p:ph idx="1"/>
+          </p:nvPr>
+        </p:nvSpPr>
+        <p:spPr/>
+        <p:txBody>
+          <a:bodyPr/>
+          <a:lstStyle/>
+          <a:p>
+            <a:r>
+              <a:rPr lang="en-US" dirty="0"/>
+              <a:t>Security is a set of non-functional requirements (sometimes called “CIA”):</a:t>
+            </a:r>
+          </a:p>
+          <a:p>
+            <a:r>
+              <a:rPr lang="en-US" dirty="0"/>
+              <a:t>Confidentiality: is information disclosed to unauthorized individuals?</a:t>
+            </a:r>
+          </a:p>
+          <a:p>
+            <a:r>
+              <a:rPr lang="en-US" dirty="0"/>
+              <a:t>Integrity: is code or data tampered with?</a:t>
+            </a:r>
+          </a:p>
+          <a:p>
+            <a:r>
+              <a:rPr lang="en-US" dirty="0"/>
+              <a:t>Availability: is the system accessible and usable?</a:t>
+            </a:r>
+          </a:p>
+          <a:p>
+            <a:endParaRPr lang="en-US" dirty="0"/>
+          </a:p>
+        </p:txBody>
+      </p:sp>
+      <p:sp>
+        <p:nvSpPr>
+          <p:cNvPr id="4" name="Slide Number Placeholder 3">
+            <a:extLst>
+              <a:ext uri="{FF2B5EF4-FFF2-40B4-BE49-F238E27FC236}">
+                <a16:creationId xmlns:a16="http://schemas.microsoft.com/office/drawing/2014/main" id="{87774AF4-9C48-112F-56C4-79515273B15D}"/>
+              </a:ext>
+            </a:extLst>
+          </p:cNvPr>
+          <p:cNvSpPr>
+            <a:spLocks noGrp="1"/>
+          </p:cNvSpPr>
+          <p:nvPr>
+            <p:ph type="sldNum" sz="quarter" idx="12"/>
+          </p:nvPr>
+        </p:nvSpPr>
+        <p:spPr/>
+        <p:txBody>
+          <a:bodyPr/>
+          <a:lstStyle/>
+          <a:p>
+            <a:fld id="{20F37917-FD3A-4669-9018-DA04BCDD3D75}" type="slidenum">
+              <a:rPr lang="en-US" smtClean="0"/>
+              <a:t>4</a:t>
+            </a:fld>
+            <a:endParaRPr lang="en-US" dirty="0"/>
+          </a:p>
+        </p:txBody>
+      </p:sp>
+    </p:spTree>
+    <p:extLst>
+      <p:ext uri="{BB962C8B-B14F-4D97-AF65-F5344CB8AC3E}">
+        <p14:creationId xmlns:p14="http://schemas.microsoft.com/office/powerpoint/2010/main" val="747519108"/>
+      </p:ext>
+    </p:extLst>
+  </p:cSld>
+  <p:clrMapOvr>
+    <a:masterClrMapping/>
+  </p:clrMapOvr>
+</p:sld>
+</file>
+
+<file path=ppt/slides/slide40.xml><?xml version="1.0" encoding="utf-8"?>
+<p:sld xmlns:a="http://schemas.openxmlformats.org/drawingml/2006/main" xmlns:r="http://schemas.openxmlformats.org/officeDocument/2006/relationships" xmlns:p="http://schemas.openxmlformats.org/presentationml/2006/main">
+  <p:cSld>
+    <p:spTree>
+      <p:nvGrpSpPr>
+        <p:cNvPr id="1" name=""/>
+        <p:cNvGrpSpPr/>
+        <p:nvPr/>
+      </p:nvGrpSpPr>
+      <p:grpSpPr>
+        <a:xfrm>
+          <a:off x="0" y="0"/>
+          <a:ext cx="0" cy="0"/>
+          <a:chOff x="0" y="0"/>
+          <a:chExt cx="0" cy="0"/>
+        </a:xfrm>
+      </p:grpSpPr>
+      <p:sp>
+        <p:nvSpPr>
+          <p:cNvPr id="2" name="Title 1">
+            <a:extLst>
+              <a:ext uri="{FF2B5EF4-FFF2-40B4-BE49-F238E27FC236}">
                 <a16:creationId xmlns:a16="http://schemas.microsoft.com/office/drawing/2014/main" id="{ED7460F2-402D-B9AA-A614-91E800A3128D}"/>
               </a:ext>
             </a:extLst>
@@ -20507,7 +21377,7 @@
           <a:p>
             <a:fld id="{20F37917-FD3A-4669-9018-DA04BCDD3D75}" type="slidenum">
               <a:rPr lang="en-US" smtClean="0"/>
-              <a:t>38</a:t>
+              <a:t>40</a:t>
             </a:fld>
             <a:endParaRPr lang="en-US"/>
           </a:p>
@@ -20573,7 +21443,7 @@
 </p:sld>
 </file>
 
-<file path=ppt/slides/slide39.xml><?xml version="1.0" encoding="utf-8"?>
+<file path=ppt/slides/slide41.xml><?xml version="1.0" encoding="utf-8"?>
 <p:sld xmlns:a="http://schemas.openxmlformats.org/drawingml/2006/main" xmlns:r="http://schemas.openxmlformats.org/officeDocument/2006/relationships" xmlns:p="http://schemas.openxmlformats.org/presentationml/2006/main">
   <p:cSld>
     <p:spTree>
@@ -20708,7 +21578,7 @@
           <a:p>
             <a:fld id="{20F37917-FD3A-4669-9018-DA04BCDD3D75}" type="slidenum">
               <a:rPr lang="en-US" smtClean="0"/>
-              <a:t>39</a:t>
+              <a:t>41</a:t>
             </a:fld>
             <a:endParaRPr lang="en-US" dirty="0"/>
           </a:p>
@@ -20773,7 +21643,7 @@
 </p:sld>
 </file>
 
-<file path=ppt/slides/slide4.xml><?xml version="1.0" encoding="utf-8"?>
+<file path=ppt/slides/slide42.xml><?xml version="1.0" encoding="utf-8"?>
 <p:sld xmlns:a="http://schemas.openxmlformats.org/drawingml/2006/main" xmlns:r="http://schemas.openxmlformats.org/officeDocument/2006/relationships" xmlns:p="http://schemas.openxmlformats.org/presentationml/2006/main">
   <p:cSld>
     <p:spTree>
@@ -20795,7 +21665,7 @@
           <p:cNvPr id="2" name="Title 1">
             <a:extLst>
               <a:ext uri="{FF2B5EF4-FFF2-40B4-BE49-F238E27FC236}">
-                <a16:creationId xmlns:a16="http://schemas.microsoft.com/office/drawing/2014/main" id="{1FD5EE76-9285-238F-5EE7-FE6F356AA0D1}"/>
+                <a16:creationId xmlns:a16="http://schemas.microsoft.com/office/drawing/2014/main" id="{E4B90FE1-AAC9-DB49-958F-35F87E447664}"/>
               </a:ext>
             </a:extLst>
           </p:cNvPr>
@@ -20813,17 +21683,17 @@
           <a:p>
             <a:r>
               <a:rPr lang="en-US" dirty="0"/>
-              <a:t>Security: Basic Vocabulary (1)</a:t>
-            </a:r>
-          </a:p>
-        </p:txBody>
-      </p:sp>
-      <p:sp>
-        <p:nvSpPr>
-          <p:cNvPr id="3" name="Content Placeholder 2">
-            <a:extLst>
-              <a:ext uri="{FF2B5EF4-FFF2-40B4-BE49-F238E27FC236}">
-                <a16:creationId xmlns:a16="http://schemas.microsoft.com/office/drawing/2014/main" id="{51FF7043-E4F9-A17C-F3B8-FD58CA6A73D6}"/>
+              <a:t>Systematically review security needs on each attack surface</a:t>
+            </a:r>
+          </a:p>
+        </p:txBody>
+      </p:sp>
+      <p:sp>
+        <p:nvSpPr>
+          <p:cNvPr id="4" name="Text Placeholder 3">
+            <a:extLst>
+              <a:ext uri="{FF2B5EF4-FFF2-40B4-BE49-F238E27FC236}">
+                <a16:creationId xmlns:a16="http://schemas.microsoft.com/office/drawing/2014/main" id="{C7537FBD-FAC6-EB42-B286-483FD564DAFD}"/>
               </a:ext>
             </a:extLst>
           </p:cNvPr>
@@ -20834,72 +21704,76 @@
             <p:ph idx="1"/>
           </p:nvPr>
         </p:nvSpPr>
-        <p:spPr/>
-        <p:txBody>
-          <a:bodyPr/>
-          <a:lstStyle/>
-          <a:p>
-            <a:r>
-              <a:rPr lang="en-US" dirty="0"/>
-              <a:t>Security is a set of non-functional requirements (sometimes called “CIA”):</a:t>
-            </a:r>
-          </a:p>
-          <a:p>
-            <a:r>
-              <a:rPr lang="en-US" dirty="0"/>
-              <a:t>Confidentiality: is information disclosed to unauthorized individuals?</a:t>
-            </a:r>
-          </a:p>
-          <a:p>
-            <a:r>
-              <a:rPr lang="en-US" dirty="0"/>
-              <a:t>Integrity: is code or data tampered with?</a:t>
-            </a:r>
-          </a:p>
-          <a:p>
-            <a:r>
-              <a:rPr lang="en-US" dirty="0"/>
-              <a:t>Availability: is the system accessible and usable?</a:t>
-            </a:r>
-          </a:p>
-          <a:p>
-            <a:endParaRPr lang="en-US" dirty="0"/>
-          </a:p>
-        </p:txBody>
-      </p:sp>
-      <p:sp>
-        <p:nvSpPr>
-          <p:cNvPr id="4" name="Slide Number Placeholder 3">
-            <a:extLst>
-              <a:ext uri="{FF2B5EF4-FFF2-40B4-BE49-F238E27FC236}">
-                <a16:creationId xmlns:a16="http://schemas.microsoft.com/office/drawing/2014/main" id="{87774AF4-9C48-112F-56C4-79515273B15D}"/>
-              </a:ext>
-            </a:extLst>
-          </p:cNvPr>
-          <p:cNvSpPr>
-            <a:spLocks noGrp="1"/>
-          </p:cNvSpPr>
-          <p:nvPr>
-            <p:ph type="sldNum" sz="quarter" idx="12"/>
-          </p:nvPr>
-        </p:nvSpPr>
-        <p:spPr/>
-        <p:txBody>
-          <a:bodyPr/>
-          <a:lstStyle/>
-          <a:p>
-            <a:fld id="{20F37917-FD3A-4669-9018-DA04BCDD3D75}" type="slidenum">
-              <a:rPr lang="en-US" smtClean="0"/>
-              <a:t>4</a:t>
-            </a:fld>
-            <a:endParaRPr lang="en-US" dirty="0"/>
+        <p:spPr>
+          <a:xfrm>
+            <a:off x="838199" y="1749542"/>
+            <a:ext cx="9209050" cy="4351338"/>
+          </a:xfrm>
+        </p:spPr>
+        <p:txBody>
+          <a:bodyPr>
+            <a:normAutofit/>
+          </a:bodyPr>
+          <a:lstStyle/>
+          <a:p>
+            <a:r>
+              <a:rPr lang="en-US" dirty="0"/>
+              <a:t>Collaborate with stakeholders to understand security needs for each data flow and identify the most vulnerable of them.</a:t>
+            </a:r>
+          </a:p>
+          <a:p>
+            <a:r>
+              <a:rPr lang="en-US" dirty="0"/>
+              <a:t>Frequent and small iterations</a:t>
+            </a:r>
+          </a:p>
+          <a:p>
+            <a:pPr lvl="1"/>
+            <a:r>
+              <a:rPr lang="en-US" sz="2800" dirty="0"/>
+              <a:t>Start with the thinnest slice of the system. e.g.,</a:t>
+            </a:r>
+          </a:p>
+          <a:p>
+            <a:pPr lvl="2"/>
+            <a:r>
+              <a:rPr lang="en-US" sz="2800" dirty="0"/>
+              <a:t>User registration flow</a:t>
+            </a:r>
+          </a:p>
+          <a:p>
+            <a:pPr lvl="2"/>
+            <a:r>
+              <a:rPr lang="en-US" sz="2800" dirty="0"/>
+              <a:t>A microservice and its collaborating services</a:t>
+            </a:r>
+          </a:p>
+          <a:p>
+            <a:pPr lvl="2"/>
+            <a:r>
+              <a:rPr lang="en-US" sz="2800" dirty="0"/>
+              <a:t>Current iteration</a:t>
+            </a:r>
+          </a:p>
+          <a:p>
+            <a:pPr lvl="1"/>
+            <a:r>
+              <a:rPr lang="en-US" sz="2800" dirty="0"/>
+              <a:t>Repeat and refine them.</a:t>
+            </a:r>
+          </a:p>
+          <a:p>
+            <a:r>
+              <a:rPr lang="en-US" sz="3200" dirty="0"/>
+              <a:t>Make this a regular part of the overall QA process</a:t>
+            </a:r>
           </a:p>
         </p:txBody>
       </p:sp>
     </p:spTree>
     <p:extLst>
       <p:ext uri="{BB962C8B-B14F-4D97-AF65-F5344CB8AC3E}">
-        <p14:creationId xmlns:p14="http://schemas.microsoft.com/office/powerpoint/2010/main" val="747519108"/>
+        <p14:creationId xmlns:p14="http://schemas.microsoft.com/office/powerpoint/2010/main" val="3870596137"/>
       </p:ext>
     </p:extLst>
   </p:cSld>
@@ -20909,7 +21783,7 @@
 </p:sld>
 </file>
 
-<file path=ppt/slides/slide40.xml><?xml version="1.0" encoding="utf-8"?>
+<file path=ppt/slides/slide43.xml><?xml version="1.0" encoding="utf-8"?>
 <p:sld xmlns:a="http://schemas.openxmlformats.org/drawingml/2006/main" xmlns:r="http://schemas.openxmlformats.org/officeDocument/2006/relationships" xmlns:p="http://schemas.openxmlformats.org/presentationml/2006/main">
   <p:cSld>
     <p:spTree>
@@ -20931,146 +21805,6 @@
           <p:cNvPr id="2" name="Title 1">
             <a:extLst>
               <a:ext uri="{FF2B5EF4-FFF2-40B4-BE49-F238E27FC236}">
-                <a16:creationId xmlns:a16="http://schemas.microsoft.com/office/drawing/2014/main" id="{E4B90FE1-AAC9-DB49-958F-35F87E447664}"/>
-              </a:ext>
-            </a:extLst>
-          </p:cNvPr>
-          <p:cNvSpPr>
-            <a:spLocks noGrp="1"/>
-          </p:cNvSpPr>
-          <p:nvPr>
-            <p:ph type="title"/>
-          </p:nvPr>
-        </p:nvSpPr>
-        <p:spPr/>
-        <p:txBody>
-          <a:bodyPr/>
-          <a:lstStyle/>
-          <a:p>
-            <a:r>
-              <a:rPr lang="en-US" dirty="0"/>
-              <a:t>Systematically review security needs on each attack surface</a:t>
-            </a:r>
-          </a:p>
-        </p:txBody>
-      </p:sp>
-      <p:sp>
-        <p:nvSpPr>
-          <p:cNvPr id="4" name="Text Placeholder 3">
-            <a:extLst>
-              <a:ext uri="{FF2B5EF4-FFF2-40B4-BE49-F238E27FC236}">
-                <a16:creationId xmlns:a16="http://schemas.microsoft.com/office/drawing/2014/main" id="{C7537FBD-FAC6-EB42-B286-483FD564DAFD}"/>
-              </a:ext>
-            </a:extLst>
-          </p:cNvPr>
-          <p:cNvSpPr>
-            <a:spLocks noGrp="1"/>
-          </p:cNvSpPr>
-          <p:nvPr>
-            <p:ph idx="1"/>
-          </p:nvPr>
-        </p:nvSpPr>
-        <p:spPr>
-          <a:xfrm>
-            <a:off x="838199" y="1749542"/>
-            <a:ext cx="9209050" cy="4351338"/>
-          </a:xfrm>
-        </p:spPr>
-        <p:txBody>
-          <a:bodyPr>
-            <a:normAutofit/>
-          </a:bodyPr>
-          <a:lstStyle/>
-          <a:p>
-            <a:r>
-              <a:rPr lang="en-US" dirty="0"/>
-              <a:t>Collaborate with stakeholders to understand security needs for each data flow and identify the most vulnerable of them.</a:t>
-            </a:r>
-          </a:p>
-          <a:p>
-            <a:r>
-              <a:rPr lang="en-US" dirty="0"/>
-              <a:t>Frequent and small iterations</a:t>
-            </a:r>
-          </a:p>
-          <a:p>
-            <a:pPr lvl="1"/>
-            <a:r>
-              <a:rPr lang="en-US" sz="2800" dirty="0"/>
-              <a:t>Start with the thinnest slice of the system. e.g.,</a:t>
-            </a:r>
-          </a:p>
-          <a:p>
-            <a:pPr lvl="2"/>
-            <a:r>
-              <a:rPr lang="en-US" sz="2800" dirty="0"/>
-              <a:t>User registration flow</a:t>
-            </a:r>
-          </a:p>
-          <a:p>
-            <a:pPr lvl="2"/>
-            <a:r>
-              <a:rPr lang="en-US" sz="2800" dirty="0"/>
-              <a:t>A microservice and its collaborating services</a:t>
-            </a:r>
-          </a:p>
-          <a:p>
-            <a:pPr lvl="2"/>
-            <a:r>
-              <a:rPr lang="en-US" sz="2800" dirty="0"/>
-              <a:t>Current iteration</a:t>
-            </a:r>
-          </a:p>
-          <a:p>
-            <a:pPr lvl="1"/>
-            <a:r>
-              <a:rPr lang="en-US" sz="2800" dirty="0"/>
-              <a:t>Repeat and refine them.</a:t>
-            </a:r>
-          </a:p>
-          <a:p>
-            <a:r>
-              <a:rPr lang="en-US" sz="3200" dirty="0"/>
-              <a:t>Make this a regular part of the overall QA process</a:t>
-            </a:r>
-          </a:p>
-        </p:txBody>
-      </p:sp>
-    </p:spTree>
-    <p:extLst>
-      <p:ext uri="{BB962C8B-B14F-4D97-AF65-F5344CB8AC3E}">
-        <p14:creationId xmlns:p14="http://schemas.microsoft.com/office/powerpoint/2010/main" val="3870596137"/>
-      </p:ext>
-    </p:extLst>
-  </p:cSld>
-  <p:clrMapOvr>
-    <a:masterClrMapping/>
-  </p:clrMapOvr>
-</p:sld>
-</file>
-
-<file path=ppt/slides/slide41.xml><?xml version="1.0" encoding="utf-8"?>
-<p:sld xmlns:a="http://schemas.openxmlformats.org/drawingml/2006/main" xmlns:r="http://schemas.openxmlformats.org/officeDocument/2006/relationships" xmlns:p="http://schemas.openxmlformats.org/presentationml/2006/main">
-  <p:cSld>
-    <p:spTree>
-      <p:nvGrpSpPr>
-        <p:cNvPr id="1" name=""/>
-        <p:cNvGrpSpPr/>
-        <p:nvPr/>
-      </p:nvGrpSpPr>
-      <p:grpSpPr>
-        <a:xfrm>
-          <a:off x="0" y="0"/>
-          <a:ext cx="0" cy="0"/>
-          <a:chOff x="0" y="0"/>
-          <a:chExt cx="0" cy="0"/>
-        </a:xfrm>
-      </p:grpSpPr>
-      <p:sp>
-        <p:nvSpPr>
-          <p:cNvPr id="2" name="Title 1">
-            <a:extLst>
-              <a:ext uri="{FF2B5EF4-FFF2-40B4-BE49-F238E27FC236}">
                 <a16:creationId xmlns:a16="http://schemas.microsoft.com/office/drawing/2014/main" id="{745AB5F6-8402-21D1-FE7E-9E95F8EAEE7E}"/>
               </a:ext>
             </a:extLst>
@@ -21260,7 +21994,7 @@
           <a:p>
             <a:fld id="{20F37917-FD3A-4669-9018-DA04BCDD3D75}" type="slidenum">
               <a:rPr lang="en-US" smtClean="0"/>
-              <a:t>41</a:t>
+              <a:t>43</a:t>
             </a:fld>
             <a:endParaRPr lang="en-US"/>
           </a:p>
@@ -21279,7 +22013,7 @@
 </p:sld>
 </file>
 
-<file path=ppt/slides/slide42.xml><?xml version="1.0" encoding="utf-8"?>
+<file path=ppt/slides/slide44.xml><?xml version="1.0" encoding="utf-8"?>
 <p:sld xmlns:a="http://schemas.openxmlformats.org/drawingml/2006/main" xmlns:r="http://schemas.openxmlformats.org/officeDocument/2006/relationships" xmlns:p="http://schemas.openxmlformats.org/presentationml/2006/main">
   <p:cSld>
     <p:spTree>
@@ -21396,7 +22130,7 @@
           <a:p>
             <a:fld id="{20F37917-FD3A-4669-9018-DA04BCDD3D75}" type="slidenum">
               <a:rPr lang="en-US" smtClean="0"/>
-              <a:t>42</a:t>
+              <a:t>44</a:t>
             </a:fld>
             <a:endParaRPr lang="en-US" dirty="0"/>
           </a:p>
@@ -21508,7 +22242,7 @@
 </p:sld>
 </file>
 
-<file path=ppt/slides/slide43.xml><?xml version="1.0" encoding="utf-8"?>
+<file path=ppt/slides/slide45.xml><?xml version="1.0" encoding="utf-8"?>
 <p:sld xmlns:a="http://schemas.openxmlformats.org/drawingml/2006/main" xmlns:r="http://schemas.openxmlformats.org/officeDocument/2006/relationships" xmlns:p="http://schemas.openxmlformats.org/presentationml/2006/main">
   <p:cSld>
     <p:spTree>
@@ -21682,7 +22416,7 @@
           <a:p>
             <a:fld id="{20F37917-FD3A-4669-9018-DA04BCDD3D75}" type="slidenum">
               <a:rPr lang="en-US" smtClean="0"/>
-              <a:t>43</a:t>
+              <a:t>45</a:t>
             </a:fld>
             <a:endParaRPr lang="en-US" dirty="0"/>
           </a:p>
@@ -21810,7 +22544,7 @@
 </p:sld>
 </file>
 
-<file path=ppt/slides/slide44.xml><?xml version="1.0" encoding="utf-8"?>
+<file path=ppt/slides/slide46.xml><?xml version="1.0" encoding="utf-8"?>
 <p:sld xmlns:a="http://schemas.openxmlformats.org/drawingml/2006/main" xmlns:r="http://schemas.openxmlformats.org/officeDocument/2006/relationships" xmlns:p="http://schemas.openxmlformats.org/presentationml/2006/main">
   <p:cSld>
     <p:spTree>

</xml_diff>

<commit_message>
added a couple of slides for better flow - m13
</commit_message>
<xml_diff>
--- a/Slides/Module 13 Security.pptx
+++ b/Slides/Module 13 Security.pptx
@@ -6,7 +6,7 @@
     <p:sldMasterId id="2147483675" r:id="rId2"/>
   </p:sldMasterIdLst>
   <p:notesMasterIdLst>
-    <p:notesMasterId r:id="rId49"/>
+    <p:notesMasterId r:id="rId51"/>
   </p:notesMasterIdLst>
   <p:sldIdLst>
     <p:sldId id="342" r:id="rId3"/>
@@ -48,13 +48,15 @@
     <p:sldId id="335" r:id="rId39"/>
     <p:sldId id="292" r:id="rId40"/>
     <p:sldId id="351" r:id="rId41"/>
-    <p:sldId id="340" r:id="rId42"/>
-    <p:sldId id="389" r:id="rId43"/>
-    <p:sldId id="377" r:id="rId44"/>
-    <p:sldId id="616" r:id="rId45"/>
-    <p:sldId id="392" r:id="rId46"/>
-    <p:sldId id="391" r:id="rId47"/>
-    <p:sldId id="343" r:id="rId48"/>
+    <p:sldId id="355" r:id="rId42"/>
+    <p:sldId id="304" r:id="rId43"/>
+    <p:sldId id="340" r:id="rId44"/>
+    <p:sldId id="389" r:id="rId45"/>
+    <p:sldId id="377" r:id="rId46"/>
+    <p:sldId id="390" r:id="rId47"/>
+    <p:sldId id="616" r:id="rId48"/>
+    <p:sldId id="391" r:id="rId49"/>
+    <p:sldId id="343" r:id="rId50"/>
   </p:sldIdLst>
   <p:sldSz cx="12192000" cy="6858000"/>
   <p:notesSz cx="6858000" cy="9144000"/>
@@ -591,7 +593,7 @@
           <a:p>
             <a:fld id="{7C7E5181-6CF5-45F7-A87A-E0E0B1FD7549}" type="datetimeFigureOut">
               <a:rPr lang="en-US" smtClean="0"/>
-              <a:t>10/26/2026</a:t>
+              <a:t>10/29/2026</a:t>
             </a:fld>
             <a:endParaRPr lang="en-US" dirty="0"/>
           </a:p>
@@ -3897,6 +3899,334 @@
             <p:ph type="sldImg"/>
           </p:nvPr>
         </p:nvSpPr>
+        <p:spPr>
+          <a:xfrm>
+            <a:off x="381000" y="685800"/>
+            <a:ext cx="6096000" cy="3429000"/>
+          </a:xfrm>
+        </p:spPr>
+      </p:sp>
+      <p:sp>
+        <p:nvSpPr>
+          <p:cNvPr id="3" name="Notes Placeholder 2"/>
+          <p:cNvSpPr>
+            <a:spLocks noGrp="1"/>
+          </p:cNvSpPr>
+          <p:nvPr>
+            <p:ph type="body" idx="1"/>
+          </p:nvPr>
+        </p:nvSpPr>
+        <p:spPr/>
+        <p:txBody>
+          <a:bodyPr/>
+          <a:lstStyle/>
+          <a:p>
+            <a:pPr marL="0" marR="0" lvl="0" indent="0" defTabSz="457200" eaLnBrk="1" fontAlgn="auto" latinLnBrk="0" hangingPunct="1">
+              <a:lnSpc>
+                <a:spcPct val="117999"/>
+              </a:lnSpc>
+              <a:spcBef>
+                <a:spcPts val="0"/>
+              </a:spcBef>
+              <a:spcAft>
+                <a:spcPts val="0"/>
+              </a:spcAft>
+              <a:buClrTx/>
+              <a:buSzTx/>
+              <a:buFontTx/>
+              <a:buNone/>
+              <a:tabLst/>
+              <a:defRPr/>
+            </a:pPr>
+            <a:r>
+              <a:rPr lang="en-US" dirty="0"/>
+              <a:t>Simply using a secret detection tool isn’t enough. This is an interesting study. </a:t>
+            </a:r>
+          </a:p>
+          <a:p>
+            <a:pPr marL="0" marR="0" lvl="0" indent="0" defTabSz="457200" eaLnBrk="1" fontAlgn="auto" latinLnBrk="0" hangingPunct="1">
+              <a:lnSpc>
+                <a:spcPct val="117999"/>
+              </a:lnSpc>
+              <a:spcBef>
+                <a:spcPts val="0"/>
+              </a:spcBef>
+              <a:spcAft>
+                <a:spcPts val="0"/>
+              </a:spcAft>
+              <a:buClrTx/>
+              <a:buSzTx/>
+              <a:buFontTx/>
+              <a:buNone/>
+              <a:tabLst/>
+              <a:defRPr/>
+            </a:pPr>
+            <a:endParaRPr lang="en-US" dirty="0"/>
+          </a:p>
+          <a:p>
+            <a:pPr marL="0" marR="0" lvl="0" indent="0" defTabSz="457200" eaLnBrk="1" fontAlgn="auto" latinLnBrk="0" hangingPunct="1">
+              <a:lnSpc>
+                <a:spcPct val="117999"/>
+              </a:lnSpc>
+              <a:spcBef>
+                <a:spcPts val="0"/>
+              </a:spcBef>
+              <a:spcAft>
+                <a:spcPts val="0"/>
+              </a:spcAft>
+              <a:buClrTx/>
+              <a:buSzTx/>
+              <a:buFontTx/>
+              <a:buNone/>
+              <a:tabLst/>
+              <a:defRPr/>
+            </a:pPr>
+            <a:r>
+              <a:rPr lang="en-US" dirty="0"/>
+              <a:t>(Read slide for key findings)</a:t>
+            </a:r>
+          </a:p>
+          <a:p>
+            <a:pPr marL="0" marR="0" lvl="0" indent="0" defTabSz="457200" eaLnBrk="1" fontAlgn="auto" latinLnBrk="0" hangingPunct="1">
+              <a:lnSpc>
+                <a:spcPct val="117999"/>
+              </a:lnSpc>
+              <a:spcBef>
+                <a:spcPts val="0"/>
+              </a:spcBef>
+              <a:spcAft>
+                <a:spcPts val="0"/>
+              </a:spcAft>
+              <a:buClrTx/>
+              <a:buSzTx/>
+              <a:buFontTx/>
+              <a:buNone/>
+              <a:tabLst/>
+              <a:defRPr/>
+            </a:pPr>
+            <a:endParaRPr lang="en-US" dirty="0"/>
+          </a:p>
+          <a:p>
+            <a:pPr marL="0" marR="0" lvl="0" indent="0" defTabSz="457200" eaLnBrk="1" fontAlgn="auto" latinLnBrk="0" hangingPunct="1">
+              <a:lnSpc>
+                <a:spcPct val="117999"/>
+              </a:lnSpc>
+              <a:spcBef>
+                <a:spcPts val="0"/>
+              </a:spcBef>
+              <a:spcAft>
+                <a:spcPts val="0"/>
+              </a:spcAft>
+              <a:buClrTx/>
+              <a:buSzTx/>
+              <a:buFontTx/>
+              <a:buNone/>
+              <a:tabLst/>
+              <a:defRPr/>
+            </a:pPr>
+            <a:r>
+              <a:rPr lang="en-US" dirty="0"/>
+              <a:t>Discussion:</a:t>
+            </a:r>
+          </a:p>
+          <a:p>
+            <a:pPr marL="0" marR="0" lvl="0" indent="0" defTabSz="457200" eaLnBrk="1" fontAlgn="auto" latinLnBrk="0" hangingPunct="1">
+              <a:lnSpc>
+                <a:spcPct val="117999"/>
+              </a:lnSpc>
+              <a:spcBef>
+                <a:spcPts val="0"/>
+              </a:spcBef>
+              <a:spcAft>
+                <a:spcPts val="0"/>
+              </a:spcAft>
+              <a:buClrTx/>
+              <a:buSzTx/>
+              <a:buFontTx/>
+              <a:buNone/>
+              <a:tabLst/>
+              <a:defRPr/>
+            </a:pPr>
+            <a:r>
+              <a:rPr lang="en-US" dirty="0"/>
+              <a:t>Bypassing warnings for false positives (e.g. not an actual credential) are reasonable (although perhaps annoying); the remaining reasons that are “development related” such as:</a:t>
+            </a:r>
+            <a:br>
+              <a:rPr lang="en-US" dirty="0"/>
+            </a:br>
+            <a:r>
+              <a:rPr lang="en-US" dirty="0"/>
+              <a:t>* </a:t>
+            </a:r>
+            <a:r>
+              <a:rPr lang="en-US" sz="2200" dirty="0">
+                <a:effectLst/>
+                <a:latin typeface="+mn-lt"/>
+                <a:ea typeface="+mn-ea"/>
+                <a:cs typeface="+mn-cs"/>
+                <a:sym typeface="Helvetica Neue"/>
+              </a:rPr>
+              <a:t>It is not a production credential (for example, it is a credential for a non-shipping prototype) </a:t>
+            </a:r>
+            <a:endParaRPr lang="en-US" dirty="0"/>
+          </a:p>
+          <a:p>
+            <a:pPr marL="342900" marR="0" lvl="0" indent="-342900" defTabSz="457200" eaLnBrk="1" fontAlgn="auto" latinLnBrk="0" hangingPunct="1">
+              <a:lnSpc>
+                <a:spcPct val="117999"/>
+              </a:lnSpc>
+              <a:spcBef>
+                <a:spcPts val="0"/>
+              </a:spcBef>
+              <a:spcAft>
+                <a:spcPts val="0"/>
+              </a:spcAft>
+              <a:buClrTx/>
+              <a:buSzTx/>
+              <a:buFont typeface="Arial" panose="020B0604020202020204" pitchFamily="34" charset="0"/>
+              <a:buChar char="•"/>
+              <a:tabLst/>
+              <a:defRPr/>
+            </a:pPr>
+            <a:r>
+              <a:rPr lang="en-US" sz="2200" dirty="0">
+                <a:effectLst/>
+                <a:latin typeface="+mn-lt"/>
+                <a:ea typeface="+mn-ea"/>
+                <a:cs typeface="+mn-cs"/>
+                <a:sym typeface="Helvetica Neue"/>
+              </a:rPr>
+              <a:t>The credential doesn’t protect any data, service, etc., with significant security value</a:t>
+            </a:r>
+            <a:endParaRPr lang="en-US" dirty="0"/>
+          </a:p>
+          <a:p>
+            <a:r>
+              <a:rPr lang="en-US" dirty="0"/>
+              <a:t>Rely on judgement calls of the developer that do not reflect overall security model. Many successful attacks rely on chaining multiple vulnerabilities together, getting a foothold in one system to then be able to access another. These kinds of judgement calls should not be made at the level of individual developers who may not see the whole security landscape.</a:t>
+            </a:r>
+          </a:p>
+          <a:p>
+            <a:endParaRPr lang="en-US" dirty="0"/>
+          </a:p>
+          <a:p>
+            <a:r>
+              <a:rPr lang="en-US" dirty="0"/>
+              <a:t>Other reasons why secrets not promptly removed:</a:t>
+            </a:r>
+          </a:p>
+          <a:p>
+            <a:pPr marL="0" marR="0" lvl="0" indent="0" defTabSz="457200" eaLnBrk="1" fontAlgn="auto" latinLnBrk="0" hangingPunct="1">
+              <a:lnSpc>
+                <a:spcPct val="117999"/>
+              </a:lnSpc>
+              <a:spcBef>
+                <a:spcPts val="0"/>
+              </a:spcBef>
+              <a:spcAft>
+                <a:spcPts val="0"/>
+              </a:spcAft>
+              <a:buClrTx/>
+              <a:buSzTx/>
+              <a:buFontTx/>
+              <a:buNone/>
+              <a:tabLst/>
+              <a:defRPr/>
+            </a:pPr>
+            <a:r>
+              <a:rPr lang="en-US" sz="2200" dirty="0">
+                <a:effectLst/>
+                <a:latin typeface="+mn-lt"/>
+                <a:ea typeface="+mn-ea"/>
+                <a:cs typeface="+mn-cs"/>
+                <a:sym typeface="Helvetica Neue"/>
+              </a:rPr>
+              <a:t>* Removing the credential now would break services. etc., that belong to other teams </a:t>
+            </a:r>
+            <a:endParaRPr lang="en-US" dirty="0"/>
+          </a:p>
+          <a:p>
+            <a:pPr marL="0" marR="0" lvl="0" indent="0" defTabSz="457200" eaLnBrk="1" fontAlgn="auto" latinLnBrk="0" hangingPunct="1">
+              <a:lnSpc>
+                <a:spcPct val="117999"/>
+              </a:lnSpc>
+              <a:spcBef>
+                <a:spcPts val="0"/>
+              </a:spcBef>
+              <a:spcAft>
+                <a:spcPts val="0"/>
+              </a:spcAft>
+              <a:buClrTx/>
+              <a:buSzTx/>
+              <a:buFontTx/>
+              <a:buNone/>
+              <a:tabLst/>
+              <a:defRPr/>
+            </a:pPr>
+            <a:r>
+              <a:rPr lang="en-US" dirty="0"/>
+              <a:t>* </a:t>
+            </a:r>
+            <a:r>
+              <a:rPr lang="en-US" sz="2200" dirty="0">
+                <a:effectLst/>
+                <a:latin typeface="+mn-lt"/>
+                <a:ea typeface="+mn-ea"/>
+                <a:cs typeface="+mn-cs"/>
+                <a:sym typeface="Helvetica Neue"/>
+              </a:rPr>
+              <a:t>We were not sure what secret management/other solution we can use to resolve the problem. </a:t>
+            </a:r>
+            <a:endParaRPr lang="en-US" dirty="0"/>
+          </a:p>
+          <a:p>
+            <a:r>
+              <a:rPr lang="en-US" dirty="0"/>
+              <a:t>These are process-related issues, and require </a:t>
+            </a:r>
+          </a:p>
+        </p:txBody>
+      </p:sp>
+    </p:spTree>
+    <p:extLst>
+      <p:ext uri="{BB962C8B-B14F-4D97-AF65-F5344CB8AC3E}">
+        <p14:creationId xmlns:p14="http://schemas.microsoft.com/office/powerpoint/2010/main" val="1755172191"/>
+      </p:ext>
+    </p:extLst>
+  </p:cSld>
+  <p:clrMapOvr>
+    <a:masterClrMapping/>
+  </p:clrMapOvr>
+</p:notes>
+</file>
+
+<file path=ppt/notesSlides/notesSlide33.xml><?xml version="1.0" encoding="utf-8"?>
+<p:notes xmlns:a="http://schemas.openxmlformats.org/drawingml/2006/main" xmlns:r="http://schemas.openxmlformats.org/officeDocument/2006/relationships" xmlns:p="http://schemas.openxmlformats.org/presentationml/2006/main">
+  <p:cSld>
+    <p:spTree>
+      <p:nvGrpSpPr>
+        <p:cNvPr id="1" name=""/>
+        <p:cNvGrpSpPr/>
+        <p:nvPr/>
+      </p:nvGrpSpPr>
+      <p:grpSpPr>
+        <a:xfrm>
+          <a:off x="0" y="0"/>
+          <a:ext cx="0" cy="0"/>
+          <a:chOff x="0" y="0"/>
+          <a:chExt cx="0" cy="0"/>
+        </a:xfrm>
+      </p:grpSpPr>
+      <p:sp>
+        <p:nvSpPr>
+          <p:cNvPr id="2" name="Slide Image Placeholder 1"/>
+          <p:cNvSpPr>
+            <a:spLocks noGrp="1" noRot="1" noChangeAspect="1"/>
+          </p:cNvSpPr>
+          <p:nvPr>
+            <p:ph type="sldImg"/>
+          </p:nvPr>
+        </p:nvSpPr>
         <p:spPr/>
         <p:txBody>
           <a:bodyPr/>
@@ -3957,7 +4287,7 @@
           <a:p>
             <a:fld id="{07937F07-1250-4CCE-B198-1B2887014F41}" type="slidenum">
               <a:rPr lang="en-US" smtClean="0"/>
-              <a:t>40</a:t>
+              <a:t>42</a:t>
             </a:fld>
             <a:endParaRPr lang="en-US"/>
           </a:p>
@@ -3976,7 +4306,7 @@
 </p:notes>
 </file>
 
-<file path=ppt/notesSlides/notesSlide33.xml><?xml version="1.0" encoding="utf-8"?>
+<file path=ppt/notesSlides/notesSlide34.xml><?xml version="1.0" encoding="utf-8"?>
 <p:notes xmlns:a="http://schemas.openxmlformats.org/drawingml/2006/main" xmlns:r="http://schemas.openxmlformats.org/officeDocument/2006/relationships" xmlns:p="http://schemas.openxmlformats.org/presentationml/2006/main">
   <p:cSld>
     <p:spTree>
@@ -4075,7 +4405,7 @@
           <a:p>
             <a:fld id="{07937F07-1250-4CCE-B198-1B2887014F41}" type="slidenum">
               <a:rPr lang="en-US" smtClean="0"/>
-              <a:t>41</a:t>
+              <a:t>43</a:t>
             </a:fld>
             <a:endParaRPr lang="en-US"/>
           </a:p>
@@ -4094,7 +4424,7 @@
 </p:notes>
 </file>
 
-<file path=ppt/notesSlides/notesSlide34.xml><?xml version="1.0" encoding="utf-8"?>
+<file path=ppt/notesSlides/notesSlide35.xml><?xml version="1.0" encoding="utf-8"?>
 <p:notes xmlns:a="http://schemas.openxmlformats.org/drawingml/2006/main" xmlns:r="http://schemas.openxmlformats.org/officeDocument/2006/relationships" xmlns:p="http://schemas.openxmlformats.org/presentationml/2006/main">
   <p:cSld>
     <p:spTree>
@@ -4178,124 +4508,6 @@
     <p:extLst>
       <p:ext uri="{BB962C8B-B14F-4D97-AF65-F5344CB8AC3E}">
         <p14:creationId xmlns:p14="http://schemas.microsoft.com/office/powerpoint/2010/main" val="4036773944"/>
-      </p:ext>
-    </p:extLst>
-  </p:cSld>
-  <p:clrMapOvr>
-    <a:masterClrMapping/>
-  </p:clrMapOvr>
-</p:notes>
-</file>
-
-<file path=ppt/notesSlides/notesSlide35.xml><?xml version="1.0" encoding="utf-8"?>
-<p:notes xmlns:a="http://schemas.openxmlformats.org/drawingml/2006/main" xmlns:r="http://schemas.openxmlformats.org/officeDocument/2006/relationships" xmlns:p="http://schemas.openxmlformats.org/presentationml/2006/main">
-  <p:cSld>
-    <p:spTree>
-      <p:nvGrpSpPr>
-        <p:cNvPr id="1" name="">
-          <a:extLst>
-            <a:ext uri="{FF2B5EF4-FFF2-40B4-BE49-F238E27FC236}">
-              <a16:creationId xmlns:a16="http://schemas.microsoft.com/office/drawing/2014/main" id="{F7B2264C-DFEB-53E4-5B35-4BC6D2449264}"/>
-            </a:ext>
-          </a:extLst>
-        </p:cNvPr>
-        <p:cNvGrpSpPr/>
-        <p:nvPr/>
-      </p:nvGrpSpPr>
-      <p:grpSpPr>
-        <a:xfrm>
-          <a:off x="0" y="0"/>
-          <a:ext cx="0" cy="0"/>
-          <a:chOff x="0" y="0"/>
-          <a:chExt cx="0" cy="0"/>
-        </a:xfrm>
-      </p:grpSpPr>
-      <p:sp>
-        <p:nvSpPr>
-          <p:cNvPr id="2" name="Slide Image Placeholder 1">
-            <a:extLst>
-              <a:ext uri="{FF2B5EF4-FFF2-40B4-BE49-F238E27FC236}">
-                <a16:creationId xmlns:a16="http://schemas.microsoft.com/office/drawing/2014/main" id="{50D9F692-70A1-39A9-0EC0-C3C08A93BF2A}"/>
-              </a:ext>
-            </a:extLst>
-          </p:cNvPr>
-          <p:cNvSpPr>
-            <a:spLocks noGrp="1" noRot="1" noChangeAspect="1"/>
-          </p:cNvSpPr>
-          <p:nvPr>
-            <p:ph type="sldImg"/>
-          </p:nvPr>
-        </p:nvSpPr>
-        <p:spPr/>
-        <p:txBody>
-          <a:bodyPr/>
-          <a:lstStyle/>
-          <a:p>
-            <a:endParaRPr lang="en-US"/>
-          </a:p>
-        </p:txBody>
-      </p:sp>
-      <p:sp>
-        <p:nvSpPr>
-          <p:cNvPr id="3" name="Notes Placeholder 2">
-            <a:extLst>
-              <a:ext uri="{FF2B5EF4-FFF2-40B4-BE49-F238E27FC236}">
-                <a16:creationId xmlns:a16="http://schemas.microsoft.com/office/drawing/2014/main" id="{AB0DF6A1-3525-9D88-A1F3-DB794DC15C53}"/>
-              </a:ext>
-            </a:extLst>
-          </p:cNvPr>
-          <p:cNvSpPr>
-            <a:spLocks noGrp="1"/>
-          </p:cNvSpPr>
-          <p:nvPr>
-            <p:ph type="body" idx="1"/>
-          </p:nvPr>
-        </p:nvSpPr>
-        <p:spPr/>
-        <p:txBody>
-          <a:bodyPr/>
-          <a:lstStyle/>
-          <a:p>
-            <a:r>
-              <a:rPr lang="en-US" dirty="0"/>
-              <a:t>&lt;read slide&gt;</a:t>
-            </a:r>
-          </a:p>
-        </p:txBody>
-      </p:sp>
-      <p:sp>
-        <p:nvSpPr>
-          <p:cNvPr id="4" name="Slide Number Placeholder 3">
-            <a:extLst>
-              <a:ext uri="{FF2B5EF4-FFF2-40B4-BE49-F238E27FC236}">
-                <a16:creationId xmlns:a16="http://schemas.microsoft.com/office/drawing/2014/main" id="{8EC0CF62-788E-81B9-E348-BCCB3517B8C5}"/>
-              </a:ext>
-            </a:extLst>
-          </p:cNvPr>
-          <p:cNvSpPr>
-            <a:spLocks noGrp="1"/>
-          </p:cNvSpPr>
-          <p:nvPr>
-            <p:ph type="sldNum" sz="quarter" idx="5"/>
-          </p:nvPr>
-        </p:nvSpPr>
-        <p:spPr/>
-        <p:txBody>
-          <a:bodyPr/>
-          <a:lstStyle/>
-          <a:p>
-            <a:fld id="{07937F07-1250-4CCE-B198-1B2887014F41}" type="slidenum">
-              <a:rPr lang="en-US" smtClean="0"/>
-              <a:t>44</a:t>
-            </a:fld>
-            <a:endParaRPr lang="en-US"/>
-          </a:p>
-        </p:txBody>
-      </p:sp>
-    </p:spTree>
-    <p:extLst>
-      <p:ext uri="{BB962C8B-B14F-4D97-AF65-F5344CB8AC3E}">
-        <p14:creationId xmlns:p14="http://schemas.microsoft.com/office/powerpoint/2010/main" val="500095670"/>
       </p:ext>
     </p:extLst>
   </p:cSld>
@@ -4345,38 +4557,49 @@
           </p:nvPr>
         </p:nvSpPr>
         <p:spPr/>
+      </p:sp>
+      <p:sp>
+        <p:nvSpPr>
+          <p:cNvPr id="3" name="Notes Placeholder 2">
+            <a:extLst>
+              <a:ext uri="{FF2B5EF4-FFF2-40B4-BE49-F238E27FC236}">
+                <a16:creationId xmlns:a16="http://schemas.microsoft.com/office/drawing/2014/main" id="{AB0DF6A1-3525-9D88-A1F3-DB794DC15C53}"/>
+              </a:ext>
+            </a:extLst>
+          </p:cNvPr>
+          <p:cNvSpPr>
+            <a:spLocks noGrp="1"/>
+          </p:cNvSpPr>
+          <p:nvPr>
+            <p:ph type="body" idx="1"/>
+          </p:nvPr>
+        </p:nvSpPr>
+        <p:spPr/>
         <p:txBody>
           <a:bodyPr/>
           <a:lstStyle/>
           <a:p>
-            <a:endParaRPr lang="en-US"/>
-          </a:p>
-        </p:txBody>
-      </p:sp>
-      <p:sp>
-        <p:nvSpPr>
-          <p:cNvPr id="3" name="Notes Placeholder 2">
-            <a:extLst>
-              <a:ext uri="{FF2B5EF4-FFF2-40B4-BE49-F238E27FC236}">
-                <a16:creationId xmlns:a16="http://schemas.microsoft.com/office/drawing/2014/main" id="{AB0DF6A1-3525-9D88-A1F3-DB794DC15C53}"/>
-              </a:ext>
-            </a:extLst>
-          </p:cNvPr>
-          <p:cNvSpPr>
-            <a:spLocks noGrp="1"/>
-          </p:cNvSpPr>
-          <p:nvPr>
-            <p:ph type="body" idx="1"/>
-          </p:nvPr>
-        </p:nvSpPr>
-        <p:spPr/>
-        <p:txBody>
-          <a:bodyPr/>
-          <a:lstStyle/>
-          <a:p>
             <a:r>
               <a:rPr lang="en-US" dirty="0"/>
               <a:t>&lt;read slide&gt;</a:t>
+            </a:r>
+          </a:p>
+          <a:p>
+            <a:endParaRPr lang="en-US" dirty="0"/>
+          </a:p>
+          <a:p>
+            <a:r>
+              <a:rPr lang="en-US" dirty="0"/>
+              <a:t>Moral: every data flow is an attack surface!</a:t>
+            </a:r>
+          </a:p>
+          <a:p>
+            <a:endParaRPr lang="en-US" dirty="0"/>
+          </a:p>
+          <a:p>
+            <a:r>
+              <a:rPr lang="en-US" dirty="0"/>
+              <a:t>(Discuss: are the notations on the flows  vulnerabilities, threats, or something else?  My answer: the slide doesn't really make a distinction}</a:t>
             </a:r>
           </a:p>
         </p:txBody>
@@ -4405,6 +4628,124 @@
             <a:fld id="{07937F07-1250-4CCE-B198-1B2887014F41}" type="slidenum">
               <a:rPr lang="en-US" smtClean="0"/>
               <a:t>45</a:t>
+            </a:fld>
+            <a:endParaRPr lang="en-US"/>
+          </a:p>
+        </p:txBody>
+      </p:sp>
+    </p:spTree>
+    <p:extLst>
+      <p:ext uri="{BB962C8B-B14F-4D97-AF65-F5344CB8AC3E}">
+        <p14:creationId xmlns:p14="http://schemas.microsoft.com/office/powerpoint/2010/main" val="1129449499"/>
+      </p:ext>
+    </p:extLst>
+  </p:cSld>
+  <p:clrMapOvr>
+    <a:masterClrMapping/>
+  </p:clrMapOvr>
+</p:notes>
+</file>
+
+<file path=ppt/notesSlides/notesSlide37.xml><?xml version="1.0" encoding="utf-8"?>
+<p:notes xmlns:a="http://schemas.openxmlformats.org/drawingml/2006/main" xmlns:r="http://schemas.openxmlformats.org/officeDocument/2006/relationships" xmlns:p="http://schemas.openxmlformats.org/presentationml/2006/main">
+  <p:cSld>
+    <p:spTree>
+      <p:nvGrpSpPr>
+        <p:cNvPr id="1" name="">
+          <a:extLst>
+            <a:ext uri="{FF2B5EF4-FFF2-40B4-BE49-F238E27FC236}">
+              <a16:creationId xmlns:a16="http://schemas.microsoft.com/office/drawing/2014/main" id="{F7B2264C-DFEB-53E4-5B35-4BC6D2449264}"/>
+            </a:ext>
+          </a:extLst>
+        </p:cNvPr>
+        <p:cNvGrpSpPr/>
+        <p:nvPr/>
+      </p:nvGrpSpPr>
+      <p:grpSpPr>
+        <a:xfrm>
+          <a:off x="0" y="0"/>
+          <a:ext cx="0" cy="0"/>
+          <a:chOff x="0" y="0"/>
+          <a:chExt cx="0" cy="0"/>
+        </a:xfrm>
+      </p:grpSpPr>
+      <p:sp>
+        <p:nvSpPr>
+          <p:cNvPr id="2" name="Slide Image Placeholder 1">
+            <a:extLst>
+              <a:ext uri="{FF2B5EF4-FFF2-40B4-BE49-F238E27FC236}">
+                <a16:creationId xmlns:a16="http://schemas.microsoft.com/office/drawing/2014/main" id="{50D9F692-70A1-39A9-0EC0-C3C08A93BF2A}"/>
+              </a:ext>
+            </a:extLst>
+          </p:cNvPr>
+          <p:cNvSpPr>
+            <a:spLocks noGrp="1" noRot="1" noChangeAspect="1"/>
+          </p:cNvSpPr>
+          <p:nvPr>
+            <p:ph type="sldImg"/>
+          </p:nvPr>
+        </p:nvSpPr>
+        <p:spPr/>
+        <p:txBody>
+          <a:bodyPr/>
+          <a:lstStyle/>
+          <a:p>
+            <a:endParaRPr lang="en-US"/>
+          </a:p>
+        </p:txBody>
+      </p:sp>
+      <p:sp>
+        <p:nvSpPr>
+          <p:cNvPr id="3" name="Notes Placeholder 2">
+            <a:extLst>
+              <a:ext uri="{FF2B5EF4-FFF2-40B4-BE49-F238E27FC236}">
+                <a16:creationId xmlns:a16="http://schemas.microsoft.com/office/drawing/2014/main" id="{AB0DF6A1-3525-9D88-A1F3-DB794DC15C53}"/>
+              </a:ext>
+            </a:extLst>
+          </p:cNvPr>
+          <p:cNvSpPr>
+            <a:spLocks noGrp="1"/>
+          </p:cNvSpPr>
+          <p:nvPr>
+            <p:ph type="body" idx="1"/>
+          </p:nvPr>
+        </p:nvSpPr>
+        <p:spPr/>
+        <p:txBody>
+          <a:bodyPr/>
+          <a:lstStyle/>
+          <a:p>
+            <a:r>
+              <a:rPr lang="en-US" dirty="0"/>
+              <a:t>&lt;read slide&gt;</a:t>
+            </a:r>
+          </a:p>
+        </p:txBody>
+      </p:sp>
+      <p:sp>
+        <p:nvSpPr>
+          <p:cNvPr id="4" name="Slide Number Placeholder 3">
+            <a:extLst>
+              <a:ext uri="{FF2B5EF4-FFF2-40B4-BE49-F238E27FC236}">
+                <a16:creationId xmlns:a16="http://schemas.microsoft.com/office/drawing/2014/main" id="{8EC0CF62-788E-81B9-E348-BCCB3517B8C5}"/>
+              </a:ext>
+            </a:extLst>
+          </p:cNvPr>
+          <p:cNvSpPr>
+            <a:spLocks noGrp="1"/>
+          </p:cNvSpPr>
+          <p:nvPr>
+            <p:ph type="sldNum" sz="quarter" idx="5"/>
+          </p:nvPr>
+        </p:nvSpPr>
+        <p:spPr/>
+        <p:txBody>
+          <a:bodyPr/>
+          <a:lstStyle/>
+          <a:p>
+            <a:fld id="{07937F07-1250-4CCE-B198-1B2887014F41}" type="slidenum">
+              <a:rPr lang="en-US" smtClean="0"/>
+              <a:t>47</a:t>
             </a:fld>
             <a:endParaRPr lang="en-US"/>
           </a:p>
@@ -4423,7 +4764,7 @@
 </p:notes>
 </file>
 
-<file path=ppt/notesSlides/notesSlide37.xml><?xml version="1.0" encoding="utf-8"?>
+<file path=ppt/notesSlides/notesSlide38.xml><?xml version="1.0" encoding="utf-8"?>
 <p:notes xmlns:a="http://schemas.openxmlformats.org/drawingml/2006/main" xmlns:r="http://schemas.openxmlformats.org/officeDocument/2006/relationships" xmlns:p="http://schemas.openxmlformats.org/presentationml/2006/main">
   <p:cSld>
     <p:spTree>
@@ -5326,7 +5667,7 @@
           <a:p>
             <a:fld id="{5D2A64DE-480B-420F-9649-4F8E696E08E0}" type="datetime1">
               <a:rPr lang="en-US" smtClean="0"/>
-              <a:t>10/26/2026</a:t>
+              <a:t>10/29/2026</a:t>
             </a:fld>
             <a:endParaRPr lang="en-US" dirty="0"/>
           </a:p>
@@ -5448,7 +5789,7 @@
           </a:prstGeom>
           <a:extLst>
             <a:ext uri="{C572A759-6A51-4108-AA02-DFA0A04FC94B}">
-              <ma14:wrappingTextBoxFlag xmlns="" xmlns:m="http://schemas.openxmlformats.org/officeDocument/2006/math" xmlns:a14="http://schemas.microsoft.com/office/drawing/2010/main" xmlns:ma14="http://schemas.microsoft.com/office/mac/drawingml/2011/main" val="1"/>
+              <ma14:wrappingTextBoxFlag xmlns:ma14="http://schemas.microsoft.com/office/mac/drawingml/2011/main" xmlns:a14="http://schemas.microsoft.com/office/drawing/2010/main" xmlns:m="http://schemas.openxmlformats.org/officeDocument/2006/math" xmlns="" val="1"/>
             </a:ext>
           </a:extLst>
         </p:spPr>
@@ -5739,7 +6080,7 @@
           <a:p>
             <a:fld id="{EA476A42-A091-4468-A075-64A31BE59948}" type="datetime1">
               <a:rPr lang="en-US" smtClean="0"/>
-              <a:t>10/26/2026</a:t>
+              <a:t>10/29/2026</a:t>
             </a:fld>
             <a:endParaRPr lang="en-US" dirty="0"/>
           </a:p>
@@ -5937,7 +6278,7 @@
           <a:p>
             <a:fld id="{0D3616D0-8311-4107-9726-6B805E7D05BA}" type="datetime1">
               <a:rPr lang="en-US" smtClean="0"/>
-              <a:t>10/26/2026</a:t>
+              <a:t>10/29/2026</a:t>
             </a:fld>
             <a:endParaRPr lang="en-US" dirty="0"/>
           </a:p>
@@ -6145,7 +6486,7 @@
           <a:p>
             <a:fld id="{3BC2557A-5C88-417A-A763-5AC779462A5F}" type="datetime1">
               <a:rPr lang="en-US" smtClean="0"/>
-              <a:t>10/26/2026</a:t>
+              <a:t>10/29/2026</a:t>
             </a:fld>
             <a:endParaRPr lang="en-US" dirty="0"/>
           </a:p>
@@ -7104,7 +7445,7 @@
           <a:p>
             <a:fld id="{5D2A64DE-480B-420F-9649-4F8E696E08E0}" type="datetime1">
               <a:rPr lang="en-US" smtClean="0"/>
-              <a:t>10/26/2026</a:t>
+              <a:t>10/29/2026</a:t>
             </a:fld>
             <a:endParaRPr lang="en-US" dirty="0"/>
           </a:p>
@@ -7524,7 +7865,7 @@
           <a:p>
             <a:fld id="{07C7BFD4-467E-4EDE-93EA-052F5B39A4E5}" type="datetime1">
               <a:rPr lang="en-US" smtClean="0"/>
-              <a:t>10/26/2026</a:t>
+              <a:t>10/29/2026</a:t>
             </a:fld>
             <a:endParaRPr lang="en-US" dirty="0"/>
           </a:p>
@@ -7774,7 +8115,7 @@
           <a:p>
             <a:fld id="{07C7BFD4-467E-4EDE-93EA-052F5B39A4E5}" type="datetime1">
               <a:rPr lang="en-US" smtClean="0"/>
-              <a:t>10/26/2026</a:t>
+              <a:t>10/29/2026</a:t>
             </a:fld>
             <a:endParaRPr lang="en-US" dirty="0"/>
           </a:p>
@@ -7923,7 +8264,7 @@
           <a:p>
             <a:fld id="{109E55A0-C911-4F03-82FC-7E5926047D46}" type="datetime1">
               <a:rPr lang="en-US" smtClean="0"/>
-              <a:t>10/26/2026</a:t>
+              <a:t>10/29/2026</a:t>
             </a:fld>
             <a:endParaRPr lang="en-US" dirty="0"/>
           </a:p>
@@ -8111,7 +8452,7 @@
           <a:p>
             <a:fld id="{2B7B7EE0-7771-4CD5-9B2B-3550753A54A1}" type="datetime1">
               <a:rPr lang="en-US" smtClean="0"/>
-              <a:t>10/26/2026</a:t>
+              <a:t>10/29/2026</a:t>
             </a:fld>
             <a:endParaRPr lang="en-US" dirty="0"/>
           </a:p>
@@ -8325,7 +8666,7 @@
           <a:p>
             <a:fld id="{07C7BFD4-467E-4EDE-93EA-052F5B39A4E5}" type="datetime1">
               <a:rPr lang="en-US" smtClean="0"/>
-              <a:t>10/26/2026</a:t>
+              <a:t>10/29/2026</a:t>
             </a:fld>
             <a:endParaRPr lang="en-US" dirty="0"/>
           </a:p>
@@ -8513,7 +8854,7 @@
           <a:p>
             <a:fld id="{109E55A0-C911-4F03-82FC-7E5926047D46}" type="datetime1">
               <a:rPr lang="en-US" smtClean="0"/>
-              <a:t>10/26/2026</a:t>
+              <a:t>10/29/2026</a:t>
             </a:fld>
             <a:endParaRPr lang="en-US" dirty="0"/>
           </a:p>
@@ -8826,7 +9167,7 @@
           <a:p>
             <a:fld id="{A533CBE2-D5BE-47AC-ADC2-9CDFC1D0CF90}" type="datetime1">
               <a:rPr lang="en-US" smtClean="0"/>
-              <a:t>10/26/2026</a:t>
+              <a:t>10/29/2026</a:t>
             </a:fld>
             <a:endParaRPr lang="en-US" dirty="0"/>
           </a:p>
@@ -9127,7 +9468,7 @@
           <a:p>
             <a:fld id="{39B7EDB1-CE74-4951-85A2-0B01C2128E28}" type="datetime1">
               <a:rPr lang="en-US" smtClean="0"/>
-              <a:t>10/26/2026</a:t>
+              <a:t>10/29/2026</a:t>
             </a:fld>
             <a:endParaRPr lang="en-US" dirty="0"/>
           </a:p>
@@ -9575,7 +9916,7 @@
           <a:p>
             <a:fld id="{2BC7EB92-A5C2-4807-A9DC-9EDE6CBFB241}" type="datetime1">
               <a:rPr lang="en-US" smtClean="0"/>
-              <a:t>10/26/2026</a:t>
+              <a:t>10/29/2026</a:t>
             </a:fld>
             <a:endParaRPr lang="en-US" dirty="0"/>
           </a:p>
@@ -9688,7 +10029,7 @@
           <a:p>
             <a:fld id="{2B7B7EE0-7771-4CD5-9B2B-3550753A54A1}" type="datetime1">
               <a:rPr lang="en-US" smtClean="0"/>
-              <a:t>10/26/2026</a:t>
+              <a:t>10/29/2026</a:t>
             </a:fld>
             <a:endParaRPr lang="en-US" dirty="0"/>
           </a:p>
@@ -9999,7 +10340,7 @@
           <a:p>
             <a:fld id="{F8B318B3-0E87-4416-A9B8-D891968C2727}" type="datetime1">
               <a:rPr lang="en-US" smtClean="0"/>
-              <a:t>10/26/2026</a:t>
+              <a:t>10/29/2026</a:t>
             </a:fld>
             <a:endParaRPr lang="en-US" dirty="0"/>
           </a:p>
@@ -10240,7 +10581,7 @@
           <a:p>
             <a:fld id="{54D997E8-DDEE-43F1-8D9B-F8A1E11DE488}" type="datetime1">
               <a:rPr lang="en-US" smtClean="0"/>
-              <a:t>10/26/2026</a:t>
+              <a:t>10/29/2026</a:t>
             </a:fld>
             <a:endParaRPr lang="en-US" dirty="0"/>
           </a:p>
@@ -10815,7 +11156,7 @@
           <a:p>
             <a:fld id="{54D997E8-DDEE-43F1-8D9B-F8A1E11DE488}" type="datetime1">
               <a:rPr lang="en-US" smtClean="0"/>
-              <a:t>10/26/2026</a:t>
+              <a:t>10/29/2026</a:t>
             </a:fld>
             <a:endParaRPr lang="en-US" dirty="0"/>
           </a:p>
@@ -11382,7 +11723,7 @@
           </a:prstGeom>
           <a:extLst>
             <a:ext uri="{C572A759-6A51-4108-AA02-DFA0A04FC94B}">
-              <ma14:wrappingTextBoxFlag xmlns:ma14="http://schemas.microsoft.com/office/mac/drawingml/2011/main" xmlns:a14="http://schemas.microsoft.com/office/drawing/2010/main" xmlns:m="http://schemas.openxmlformats.org/officeDocument/2006/math" xmlns="" val="1"/>
+              <ma14:wrappingTextBoxFlag xmlns="" xmlns:m="http://schemas.openxmlformats.org/officeDocument/2006/math" xmlns:a14="http://schemas.microsoft.com/office/drawing/2010/main" xmlns:ma14="http://schemas.microsoft.com/office/mac/drawingml/2011/main" val="1"/>
             </a:ext>
           </a:extLst>
         </p:spPr>
@@ -12767,7 +13108,7 @@
           </a:ln>
           <a:extLst>
             <a:ext uri="{C572A759-6A51-4108-AA02-DFA0A04FC94B}">
-              <ma14:wrappingTextBoxFlag xmlns="" xmlns:m="http://schemas.openxmlformats.org/officeDocument/2006/math" xmlns:a14="http://schemas.microsoft.com/office/drawing/2010/main" xmlns:ma14="http://schemas.microsoft.com/office/mac/drawingml/2011/main" val="1"/>
+              <ma14:wrappingTextBoxFlag xmlns:ma14="http://schemas.microsoft.com/office/mac/drawingml/2011/main" xmlns:a14="http://schemas.microsoft.com/office/drawing/2010/main" xmlns:m="http://schemas.openxmlformats.org/officeDocument/2006/math" xmlns="" val="1"/>
             </a:ext>
           </a:extLst>
         </p:spPr>
@@ -13004,7 +13345,7 @@
           </a:ln>
           <a:extLst>
             <a:ext uri="{C572A759-6A51-4108-AA02-DFA0A04FC94B}">
-              <ma14:wrappingTextBoxFlag xmlns="" xmlns:m="http://schemas.openxmlformats.org/officeDocument/2006/math" xmlns:a14="http://schemas.microsoft.com/office/drawing/2010/main" xmlns:ma14="http://schemas.microsoft.com/office/mac/drawingml/2011/main" val="1"/>
+              <ma14:wrappingTextBoxFlag xmlns:ma14="http://schemas.microsoft.com/office/mac/drawingml/2011/main" xmlns:a14="http://schemas.microsoft.com/office/drawing/2010/main" xmlns:m="http://schemas.openxmlformats.org/officeDocument/2006/math" xmlns="" val="1"/>
             </a:ext>
           </a:extLst>
         </p:spPr>
@@ -13100,7 +13441,7 @@
           </a:ln>
           <a:extLst>
             <a:ext uri="{C572A759-6A51-4108-AA02-DFA0A04FC94B}">
-              <ma14:wrappingTextBoxFlag xmlns="" xmlns:m="http://schemas.openxmlformats.org/officeDocument/2006/math" xmlns:a14="http://schemas.microsoft.com/office/drawing/2010/main" xmlns:ma14="http://schemas.microsoft.com/office/mac/drawingml/2011/main" val="1"/>
+              <ma14:wrappingTextBoxFlag xmlns:ma14="http://schemas.microsoft.com/office/mac/drawingml/2011/main" xmlns:a14="http://schemas.microsoft.com/office/drawing/2010/main" xmlns:m="http://schemas.openxmlformats.org/officeDocument/2006/math" xmlns="" val="1"/>
             </a:ext>
           </a:extLst>
         </p:spPr>
@@ -13330,7 +13671,7 @@
           </a:ln>
           <a:extLst>
             <a:ext uri="{C572A759-6A51-4108-AA02-DFA0A04FC94B}">
-              <ma14:wrappingTextBoxFlag xmlns="" xmlns:m="http://schemas.openxmlformats.org/officeDocument/2006/math" xmlns:a14="http://schemas.microsoft.com/office/drawing/2010/main" xmlns:ma14="http://schemas.microsoft.com/office/mac/drawingml/2011/main" val="1"/>
+              <ma14:wrappingTextBoxFlag xmlns:ma14="http://schemas.microsoft.com/office/mac/drawingml/2011/main" xmlns:a14="http://schemas.microsoft.com/office/drawing/2010/main" xmlns:m="http://schemas.openxmlformats.org/officeDocument/2006/math" xmlns="" val="1"/>
             </a:ext>
           </a:extLst>
         </p:spPr>
@@ -13994,7 +14335,7 @@
           </a:prstGeom>
           <a:extLst>
             <a:ext uri="{C572A759-6A51-4108-AA02-DFA0A04FC94B}">
-              <ma14:wrappingTextBoxFlag xmlns="" xmlns:m="http://schemas.openxmlformats.org/officeDocument/2006/math" xmlns:a14="http://schemas.microsoft.com/office/drawing/2010/main" xmlns:ma14="http://schemas.microsoft.com/office/mac/drawingml/2011/main" val="1"/>
+              <ma14:wrappingTextBoxFlag xmlns:ma14="http://schemas.microsoft.com/office/mac/drawingml/2011/main" xmlns:a14="http://schemas.microsoft.com/office/drawing/2010/main" xmlns:m="http://schemas.openxmlformats.org/officeDocument/2006/math" xmlns="" val="1"/>
             </a:ext>
           </a:extLst>
         </p:spPr>
@@ -14050,7 +14391,7 @@
           </a:ln>
           <a:extLst>
             <a:ext uri="{C572A759-6A51-4108-AA02-DFA0A04FC94B}">
-              <ma14:wrappingTextBoxFlag xmlns="" xmlns:m="http://schemas.openxmlformats.org/officeDocument/2006/math" xmlns:a14="http://schemas.microsoft.com/office/drawing/2010/main" xmlns:ma14="http://schemas.microsoft.com/office/mac/drawingml/2011/main" val="1"/>
+              <ma14:wrappingTextBoxFlag xmlns:ma14="http://schemas.microsoft.com/office/mac/drawingml/2011/main" xmlns:a14="http://schemas.microsoft.com/office/drawing/2010/main" xmlns:m="http://schemas.openxmlformats.org/officeDocument/2006/math" xmlns="" val="1"/>
             </a:ext>
           </a:extLst>
         </p:spPr>
@@ -14912,7 +15253,7 @@
             <a:effectLst/>
             <a:extLst>
               <a:ext uri="{C572A759-6A51-4108-AA02-DFA0A04FC94B}">
-                <ma14:wrappingTextBoxFlag xmlns="" xmlns:m="http://schemas.openxmlformats.org/officeDocument/2006/math" xmlns:a14="http://schemas.microsoft.com/office/drawing/2010/main" xmlns:ma14="http://schemas.microsoft.com/office/mac/drawingml/2011/main" val="1"/>
+                <ma14:wrappingTextBoxFlag xmlns:ma14="http://schemas.microsoft.com/office/mac/drawingml/2011/main" xmlns:a14="http://schemas.microsoft.com/office/drawing/2010/main" xmlns:m="http://schemas.openxmlformats.org/officeDocument/2006/math" xmlns="" val="1"/>
               </a:ext>
             </a:extLst>
           </p:spPr>
@@ -15214,7 +15555,7 @@
           </a:ln>
           <a:extLst>
             <a:ext uri="{C572A759-6A51-4108-AA02-DFA0A04FC94B}">
-              <ma14:wrappingTextBoxFlag xmlns="" xmlns:m="http://schemas.openxmlformats.org/officeDocument/2006/math" xmlns:a14="http://schemas.microsoft.com/office/drawing/2010/main" xmlns:ma14="http://schemas.microsoft.com/office/mac/drawingml/2011/main" val="1"/>
+              <ma14:wrappingTextBoxFlag xmlns:ma14="http://schemas.microsoft.com/office/mac/drawingml/2011/main" xmlns:a14="http://schemas.microsoft.com/office/drawing/2010/main" xmlns:m="http://schemas.openxmlformats.org/officeDocument/2006/math" xmlns="" val="1"/>
             </a:ext>
           </a:extLst>
         </p:spPr>
@@ -15655,7 +15996,7 @@
           <a:effectLst/>
           <a:extLst>
             <a:ext uri="{C572A759-6A51-4108-AA02-DFA0A04FC94B}">
-              <ma14:wrappingTextBoxFlag xmlns="" xmlns:m="http://schemas.openxmlformats.org/officeDocument/2006/math" xmlns:a14="http://schemas.microsoft.com/office/drawing/2010/main" xmlns:ma14="http://schemas.microsoft.com/office/mac/drawingml/2011/main" val="1"/>
+              <ma14:wrappingTextBoxFlag xmlns:ma14="http://schemas.microsoft.com/office/mac/drawingml/2011/main" xmlns:a14="http://schemas.microsoft.com/office/drawing/2010/main" xmlns:m="http://schemas.openxmlformats.org/officeDocument/2006/math" xmlns="" val="1"/>
             </a:ext>
           </a:extLst>
         </p:spPr>
@@ -16973,7 +17314,7 @@
           <a:effectLst/>
           <a:extLst>
             <a:ext uri="{C572A759-6A51-4108-AA02-DFA0A04FC94B}">
-              <ma14:wrappingTextBoxFlag xmlns="" xmlns:m="http://schemas.openxmlformats.org/officeDocument/2006/math" xmlns:a14="http://schemas.microsoft.com/office/drawing/2010/main" xmlns:ma14="http://schemas.microsoft.com/office/mac/drawingml/2011/main" val="1"/>
+              <ma14:wrappingTextBoxFlag xmlns:ma14="http://schemas.microsoft.com/office/mac/drawingml/2011/main" xmlns:a14="http://schemas.microsoft.com/office/drawing/2010/main" xmlns:m="http://schemas.openxmlformats.org/officeDocument/2006/math" xmlns="" val="1"/>
             </a:ext>
           </a:extLst>
         </p:spPr>
@@ -17895,15 +18236,7 @@
           <a:p>
             <a:r>
               <a:rPr lang="en-US" dirty="0"/>
-              <a:t>Every third-party dependency is a </a:t>
-            </a:r>
-            <a:r>
-              <a:rPr lang="en-US" dirty="0" err="1"/>
-              <a:t>potetial</a:t>
-            </a:r>
-            <a:r>
-              <a:rPr lang="en-US" dirty="0"/>
-              <a:t> attack surface.</a:t>
+              <a:t>Every third-party dependency is a potential attack surface.</a:t>
             </a:r>
           </a:p>
         </p:txBody>
@@ -17996,7 +18329,7 @@
           </a:ln>
           <a:extLst>
             <a:ext uri="{C572A759-6A51-4108-AA02-DFA0A04FC94B}">
-              <ma14:wrappingTextBoxFlag xmlns="" xmlns:m="http://schemas.openxmlformats.org/officeDocument/2006/math" xmlns:a14="http://schemas.microsoft.com/office/drawing/2010/main" xmlns:ma14="http://schemas.microsoft.com/office/mac/drawingml/2011/main" val="1"/>
+              <ma14:wrappingTextBoxFlag xmlns:ma14="http://schemas.microsoft.com/office/mac/drawingml/2011/main" xmlns:a14="http://schemas.microsoft.com/office/drawing/2010/main" xmlns:m="http://schemas.openxmlformats.org/officeDocument/2006/math" xmlns="" val="1"/>
             </a:ext>
           </a:extLst>
         </p:spPr>
@@ -18091,7 +18424,7 @@
           </a:ln>
           <a:extLst>
             <a:ext uri="{C572A759-6A51-4108-AA02-DFA0A04FC94B}">
-              <ma14:wrappingTextBoxFlag xmlns="" xmlns:m="http://schemas.openxmlformats.org/officeDocument/2006/math" xmlns:a14="http://schemas.microsoft.com/office/drawing/2010/main" xmlns:ma14="http://schemas.microsoft.com/office/mac/drawingml/2011/main" val="1"/>
+              <ma14:wrappingTextBoxFlag xmlns:ma14="http://schemas.microsoft.com/office/mac/drawingml/2011/main" xmlns:a14="http://schemas.microsoft.com/office/drawing/2010/main" xmlns:m="http://schemas.openxmlformats.org/officeDocument/2006/math" xmlns="" val="1"/>
             </a:ext>
           </a:extLst>
         </p:spPr>
@@ -18150,7 +18483,7 @@
           </a:ln>
           <a:extLst>
             <a:ext uri="{C572A759-6A51-4108-AA02-DFA0A04FC94B}">
-              <ma14:wrappingTextBoxFlag xmlns="" xmlns:m="http://schemas.openxmlformats.org/officeDocument/2006/math" xmlns:a14="http://schemas.microsoft.com/office/drawing/2010/main" xmlns:ma14="http://schemas.microsoft.com/office/mac/drawingml/2011/main" val="1"/>
+              <ma14:wrappingTextBoxFlag xmlns:ma14="http://schemas.microsoft.com/office/mac/drawingml/2011/main" xmlns:a14="http://schemas.microsoft.com/office/drawing/2010/main" xmlns:m="http://schemas.openxmlformats.org/officeDocument/2006/math" xmlns="" val="1"/>
             </a:ext>
           </a:extLst>
         </p:spPr>
@@ -18209,7 +18542,7 @@
           </a:ln>
           <a:extLst>
             <a:ext uri="{C572A759-6A51-4108-AA02-DFA0A04FC94B}">
-              <ma14:wrappingTextBoxFlag xmlns="" xmlns:m="http://schemas.openxmlformats.org/officeDocument/2006/math" xmlns:a14="http://schemas.microsoft.com/office/drawing/2010/main" xmlns:ma14="http://schemas.microsoft.com/office/mac/drawingml/2011/main" val="1"/>
+              <ma14:wrappingTextBoxFlag xmlns:ma14="http://schemas.microsoft.com/office/mac/drawingml/2011/main" xmlns:a14="http://schemas.microsoft.com/office/drawing/2010/main" xmlns:m="http://schemas.openxmlformats.org/officeDocument/2006/math" xmlns="" val="1"/>
             </a:ext>
           </a:extLst>
         </p:spPr>
@@ -18340,7 +18673,7 @@
           </a:ln>
           <a:extLst>
             <a:ext uri="{C572A759-6A51-4108-AA02-DFA0A04FC94B}">
-              <ma14:wrappingTextBoxFlag xmlns="" xmlns:m="http://schemas.openxmlformats.org/officeDocument/2006/math" xmlns:a14="http://schemas.microsoft.com/office/drawing/2010/main" xmlns:ma14="http://schemas.microsoft.com/office/mac/drawingml/2011/main" val="1"/>
+              <ma14:wrappingTextBoxFlag xmlns:ma14="http://schemas.microsoft.com/office/mac/drawingml/2011/main" xmlns:a14="http://schemas.microsoft.com/office/drawing/2010/main" xmlns:m="http://schemas.openxmlformats.org/officeDocument/2006/math" xmlns="" val="1"/>
             </a:ext>
           </a:extLst>
         </p:spPr>
@@ -20361,7 +20694,7 @@
           <a:effectLst/>
           <a:extLst>
             <a:ext uri="{C572A759-6A51-4108-AA02-DFA0A04FC94B}">
-              <ma14:wrappingTextBoxFlag xmlns="" xmlns:m="http://schemas.openxmlformats.org/officeDocument/2006/math" xmlns:a14="http://schemas.microsoft.com/office/drawing/2010/main" xmlns:ma14="http://schemas.microsoft.com/office/mac/drawingml/2011/main" val="1"/>
+              <ma14:wrappingTextBoxFlag xmlns:ma14="http://schemas.microsoft.com/office/mac/drawingml/2011/main" xmlns:a14="http://schemas.microsoft.com/office/drawing/2010/main" xmlns:m="http://schemas.openxmlformats.org/officeDocument/2006/math" xmlns="" val="1"/>
             </a:ext>
           </a:extLst>
         </p:spPr>
@@ -21293,6 +21626,598 @@
           <p:cNvPr id="2" name="Title 1">
             <a:extLst>
               <a:ext uri="{FF2B5EF4-FFF2-40B4-BE49-F238E27FC236}">
+                <a16:creationId xmlns:a16="http://schemas.microsoft.com/office/drawing/2014/main" id="{2C24B87C-26A1-1CB5-82AE-B9E3E252728F}"/>
+              </a:ext>
+            </a:extLst>
+          </p:cNvPr>
+          <p:cNvSpPr>
+            <a:spLocks noGrp="1"/>
+          </p:cNvSpPr>
+          <p:nvPr>
+            <p:ph type="title"/>
+          </p:nvPr>
+        </p:nvSpPr>
+        <p:spPr/>
+        <p:txBody>
+          <a:bodyPr/>
+          <a:lstStyle/>
+          <a:p>
+            <a:r>
+              <a:rPr lang="en-US" dirty="0"/>
+              <a:t>Example mechanism: secret detection</a:t>
+            </a:r>
+          </a:p>
+        </p:txBody>
+      </p:sp>
+      <p:sp>
+        <p:nvSpPr>
+          <p:cNvPr id="3" name="Content Placeholder 2">
+            <a:extLst>
+              <a:ext uri="{FF2B5EF4-FFF2-40B4-BE49-F238E27FC236}">
+                <a16:creationId xmlns:a16="http://schemas.microsoft.com/office/drawing/2014/main" id="{09DA1F5F-2E1A-D75F-DAB6-2AA06C2A7D50}"/>
+              </a:ext>
+            </a:extLst>
+          </p:cNvPr>
+          <p:cNvSpPr>
+            <a:spLocks noGrp="1"/>
+          </p:cNvSpPr>
+          <p:nvPr>
+            <p:ph idx="1"/>
+          </p:nvPr>
+        </p:nvSpPr>
+        <p:spPr>
+          <a:xfrm>
+            <a:off x="838200" y="1500160"/>
+            <a:ext cx="5416826" cy="4351338"/>
+          </a:xfrm>
+        </p:spPr>
+        <p:txBody>
+          <a:bodyPr/>
+          <a:lstStyle/>
+          <a:p>
+            <a:r>
+              <a:rPr lang="en-US" dirty="0"/>
+              <a:t>Recall: SSL only talks about public/private keys.</a:t>
+            </a:r>
+          </a:p>
+          <a:p>
+            <a:r>
+              <a:rPr lang="en-US" dirty="0"/>
+              <a:t>Applications may have many other </a:t>
+            </a:r>
+            <a:r>
+              <a:rPr lang="en-US" i="1" dirty="0"/>
+              <a:t>secret</a:t>
+            </a:r>
+            <a:r>
+              <a:rPr lang="en-US" dirty="0"/>
+              <a:t> values (e.g. access tokens for other services)</a:t>
+            </a:r>
+          </a:p>
+          <a:p>
+            <a:r>
+              <a:rPr lang="en-US" dirty="0"/>
+              <a:t>Tools like </a:t>
+            </a:r>
+            <a:r>
+              <a:rPr lang="en-US" i="1" dirty="0" err="1"/>
+              <a:t>GitGuardian</a:t>
+            </a:r>
+            <a:r>
+              <a:rPr lang="en-US" dirty="0"/>
+              <a:t> automatically detect secrets in repositories</a:t>
+            </a:r>
+          </a:p>
+          <a:p>
+            <a:r>
+              <a:rPr lang="en-US" dirty="0"/>
+              <a:t>What happens when we put that in the toolchain?</a:t>
+            </a:r>
+          </a:p>
+        </p:txBody>
+      </p:sp>
+      <p:sp>
+        <p:nvSpPr>
+          <p:cNvPr id="4" name="Slide Number Placeholder 3">
+            <a:extLst>
+              <a:ext uri="{FF2B5EF4-FFF2-40B4-BE49-F238E27FC236}">
+                <a16:creationId xmlns:a16="http://schemas.microsoft.com/office/drawing/2014/main" id="{F56D9A2A-26EE-B44C-BCBE-697378D734C7}"/>
+              </a:ext>
+            </a:extLst>
+          </p:cNvPr>
+          <p:cNvSpPr>
+            <a:spLocks noGrp="1"/>
+          </p:cNvSpPr>
+          <p:nvPr>
+            <p:ph type="sldNum" sz="quarter" idx="12"/>
+          </p:nvPr>
+        </p:nvSpPr>
+        <p:spPr/>
+        <p:txBody>
+          <a:bodyPr/>
+          <a:lstStyle/>
+          <a:p>
+            <a:fld id="{20F37917-FD3A-4669-9018-DA04BCDD3D75}" type="slidenum">
+              <a:rPr lang="en-US" smtClean="0"/>
+              <a:t>40</a:t>
+            </a:fld>
+            <a:endParaRPr lang="en-US"/>
+          </a:p>
+        </p:txBody>
+      </p:sp>
+      <p:pic>
+        <p:nvPicPr>
+          <p:cNvPr id="5" name="Picture 4">
+            <a:extLst>
+              <a:ext uri="{FF2B5EF4-FFF2-40B4-BE49-F238E27FC236}">
+                <a16:creationId xmlns:a16="http://schemas.microsoft.com/office/drawing/2014/main" id="{DD80FCE0-7476-157D-B2E2-16F3C5D21B29}"/>
+              </a:ext>
+            </a:extLst>
+          </p:cNvPr>
+          <p:cNvPicPr>
+            <a:picLocks noChangeAspect="1"/>
+          </p:cNvPicPr>
+          <p:nvPr/>
+        </p:nvPicPr>
+        <p:blipFill>
+          <a:blip r:embed="rId2"/>
+          <a:stretch>
+            <a:fillRect/>
+          </a:stretch>
+        </p:blipFill>
+        <p:spPr>
+          <a:xfrm>
+            <a:off x="6546573" y="1760657"/>
+            <a:ext cx="5416826" cy="3830344"/>
+          </a:xfrm>
+          <a:prstGeom prst="rect">
+            <a:avLst/>
+          </a:prstGeom>
+        </p:spPr>
+      </p:pic>
+    </p:spTree>
+    <p:extLst>
+      <p:ext uri="{BB962C8B-B14F-4D97-AF65-F5344CB8AC3E}">
+        <p14:creationId xmlns:p14="http://schemas.microsoft.com/office/powerpoint/2010/main" val="2921844832"/>
+      </p:ext>
+    </p:extLst>
+  </p:cSld>
+  <p:clrMapOvr>
+    <a:masterClrMapping/>
+  </p:clrMapOvr>
+</p:sld>
+</file>
+
+<file path=ppt/slides/slide41.xml><?xml version="1.0" encoding="utf-8"?>
+<p:sld xmlns:a="http://schemas.openxmlformats.org/drawingml/2006/main" xmlns:r="http://schemas.openxmlformats.org/officeDocument/2006/relationships" xmlns:p="http://schemas.openxmlformats.org/presentationml/2006/main">
+  <p:cSld>
+    <p:spTree>
+      <p:nvGrpSpPr>
+        <p:cNvPr id="1" name=""/>
+        <p:cNvGrpSpPr/>
+        <p:nvPr/>
+      </p:nvGrpSpPr>
+      <p:grpSpPr>
+        <a:xfrm>
+          <a:off x="0" y="0"/>
+          <a:ext cx="0" cy="0"/>
+          <a:chOff x="0" y="0"/>
+          <a:chExt cx="0" cy="0"/>
+        </a:xfrm>
+      </p:grpSpPr>
+      <p:sp>
+        <p:nvSpPr>
+          <p:cNvPr id="2" name="Title 1">
+            <a:extLst>
+              <a:ext uri="{FF2B5EF4-FFF2-40B4-BE49-F238E27FC236}">
+                <a16:creationId xmlns:a16="http://schemas.microsoft.com/office/drawing/2014/main" id="{44E51F3B-F355-EB4F-926D-C0E1CB396309}"/>
+              </a:ext>
+            </a:extLst>
+          </p:cNvPr>
+          <p:cNvSpPr>
+            <a:spLocks noGrp="1"/>
+          </p:cNvSpPr>
+          <p:nvPr>
+            <p:ph type="title"/>
+          </p:nvPr>
+        </p:nvSpPr>
+        <p:spPr/>
+        <p:txBody>
+          <a:bodyPr>
+            <a:normAutofit/>
+          </a:bodyPr>
+          <a:lstStyle/>
+          <a:p>
+            <a:r>
+              <a:rPr lang="en-US" sz="3600" dirty="0"/>
+              <a:t>Do developers keep secret keys secret, even when they are warned?</a:t>
+            </a:r>
+          </a:p>
+        </p:txBody>
+      </p:sp>
+      <p:sp>
+        <p:nvSpPr>
+          <p:cNvPr id="4" name="Text Placeholder 3">
+            <a:extLst>
+              <a:ext uri="{FF2B5EF4-FFF2-40B4-BE49-F238E27FC236}">
+                <a16:creationId xmlns:a16="http://schemas.microsoft.com/office/drawing/2014/main" id="{32124C87-8E0C-814E-BF12-4F5B4055540E}"/>
+              </a:ext>
+            </a:extLst>
+          </p:cNvPr>
+          <p:cNvSpPr>
+            <a:spLocks noGrp="1"/>
+          </p:cNvSpPr>
+          <p:nvPr>
+            <p:ph idx="1"/>
+          </p:nvPr>
+        </p:nvSpPr>
+        <p:spPr>
+          <a:xfrm>
+            <a:off x="838199" y="1500160"/>
+            <a:ext cx="10288971" cy="4351338"/>
+          </a:xfrm>
+        </p:spPr>
+        <p:txBody>
+          <a:bodyPr>
+            <a:normAutofit/>
+          </a:bodyPr>
+          <a:lstStyle/>
+          <a:p>
+            <a:r>
+              <a:rPr lang="en-US" dirty="0"/>
+              <a:t>Industrial study of secret detection tool in a large software services company with over 1,000 developers, operating for over 10 years</a:t>
+            </a:r>
+          </a:p>
+          <a:p>
+            <a:r>
+              <a:rPr lang="en-US" dirty="0"/>
+              <a:t>What do developers do when they get warnings of secrets in repository?</a:t>
+            </a:r>
+          </a:p>
+          <a:p>
+            <a:pPr lvl="1"/>
+            <a:r>
+              <a:rPr lang="en-US" dirty="0"/>
+              <a:t>49% remove the secrets; 51% bypass the warning</a:t>
+            </a:r>
+          </a:p>
+          <a:p>
+            <a:r>
+              <a:rPr lang="en-US" dirty="0"/>
+              <a:t>Why do developers bypass warnings?</a:t>
+            </a:r>
+          </a:p>
+          <a:p>
+            <a:pPr lvl="1"/>
+            <a:r>
+              <a:rPr lang="en-US" dirty="0"/>
+              <a:t>44% report false positives, 6% are already exposed secrets, remaining are “development-related” reasons, e.g. “not a production credential” or “no significant security value”</a:t>
+            </a:r>
+          </a:p>
+          <a:p>
+            <a:endParaRPr lang="en-US" dirty="0"/>
+          </a:p>
+        </p:txBody>
+      </p:sp>
+      <p:sp>
+        <p:nvSpPr>
+          <p:cNvPr id="6" name="TextBox 5">
+            <a:extLst>
+              <a:ext uri="{FF2B5EF4-FFF2-40B4-BE49-F238E27FC236}">
+                <a16:creationId xmlns:a16="http://schemas.microsoft.com/office/drawing/2014/main" id="{738664A1-DA08-294D-847B-632B1C3EFD29}"/>
+              </a:ext>
+            </a:extLst>
+          </p:cNvPr>
+          <p:cNvSpPr txBox="1"/>
+          <p:nvPr/>
+        </p:nvSpPr>
+        <p:spPr>
+          <a:xfrm>
+            <a:off x="2108200" y="6257836"/>
+            <a:ext cx="7708900" cy="369332"/>
+          </a:xfrm>
+          <a:prstGeom prst="rect">
+            <a:avLst/>
+          </a:prstGeom>
+          <a:noFill/>
+          <a:ln w="12700" cap="flat">
+            <a:noFill/>
+            <a:miter lim="400000"/>
+          </a:ln>
+          <a:effectLst/>
+          <a:sp3d/>
+        </p:spPr>
+        <p:style>
+          <a:lnRef idx="0">
+            <a:scrgbClr r="0" g="0" b="0"/>
+          </a:lnRef>
+          <a:fillRef idx="0">
+            <a:scrgbClr r="0" g="0" b="0"/>
+          </a:fillRef>
+          <a:effectRef idx="0">
+            <a:scrgbClr r="0" g="0" b="0"/>
+          </a:effectRef>
+          <a:fontRef idx="none"/>
+        </p:style>
+        <p:txBody>
+          <a:bodyPr wrap="square">
+            <a:spAutoFit/>
+          </a:bodyPr>
+          <a:lstStyle/>
+          <a:p>
+            <a:r>
+              <a:rPr lang="en-US" sz="900" dirty="0">
+                <a:solidFill>
+                  <a:srgbClr val="333333"/>
+                </a:solidFill>
+                <a:latin typeface="Georgia" panose="02040502050405020303" pitchFamily="18" charset="0"/>
+              </a:rPr>
+              <a:t>“Why secret detection tools are not enough: It’s not just about false positives - An industrial case study”</a:t>
+            </a:r>
+          </a:p>
+          <a:p>
+            <a:r>
+              <a:rPr lang="en-US" sz="900" dirty="0">
+                <a:solidFill>
+                  <a:srgbClr val="333333"/>
+                </a:solidFill>
+                <a:latin typeface="Georgia" panose="02040502050405020303" pitchFamily="18" charset="0"/>
+              </a:rPr>
+              <a:t>Md </a:t>
+            </a:r>
+            <a:r>
+              <a:rPr lang="en-US" sz="900" dirty="0" err="1">
+                <a:solidFill>
+                  <a:srgbClr val="333333"/>
+                </a:solidFill>
+                <a:latin typeface="Georgia" panose="02040502050405020303" pitchFamily="18" charset="0"/>
+              </a:rPr>
+              <a:t>Rayhanur</a:t>
+            </a:r>
+            <a:r>
+              <a:rPr lang="en-US" sz="900" dirty="0">
+                <a:solidFill>
+                  <a:srgbClr val="333333"/>
+                </a:solidFill>
+                <a:latin typeface="Georgia" panose="02040502050405020303" pitchFamily="18" charset="0"/>
+              </a:rPr>
+              <a:t> Rahman, </a:t>
+            </a:r>
+            <a:r>
+              <a:rPr lang="en-US" sz="900" dirty="0" err="1">
+                <a:solidFill>
+                  <a:srgbClr val="333333"/>
+                </a:solidFill>
+                <a:latin typeface="Georgia" panose="02040502050405020303" pitchFamily="18" charset="0"/>
+              </a:rPr>
+              <a:t>Nasif</a:t>
+            </a:r>
+            <a:r>
+              <a:rPr lang="en-US" sz="900" dirty="0">
+                <a:solidFill>
+                  <a:srgbClr val="333333"/>
+                </a:solidFill>
+                <a:latin typeface="Georgia" panose="02040502050405020303" pitchFamily="18" charset="0"/>
+              </a:rPr>
+              <a:t> Imtiaz, Margaret-Anne </a:t>
+            </a:r>
+            <a:r>
+              <a:rPr lang="en-US" sz="900" dirty="0" err="1">
+                <a:solidFill>
+                  <a:srgbClr val="333333"/>
+                </a:solidFill>
+                <a:latin typeface="Georgia" panose="02040502050405020303" pitchFamily="18" charset="0"/>
+              </a:rPr>
+              <a:t>Storey</a:t>
+            </a:r>
+            <a:r>
+              <a:rPr lang="en-US" sz="900" dirty="0">
+                <a:solidFill>
+                  <a:srgbClr val="333333"/>
+                </a:solidFill>
+                <a:latin typeface="Georgia" panose="02040502050405020303" pitchFamily="18" charset="0"/>
+              </a:rPr>
+              <a:t> &amp; Laurie Williams  </a:t>
+            </a:r>
+            <a:r>
+              <a:rPr lang="en-US" sz="900" dirty="0">
+                <a:solidFill>
+                  <a:srgbClr val="333333"/>
+                </a:solidFill>
+                <a:latin typeface="Georgia" panose="02040502050405020303" pitchFamily="18" charset="0"/>
+                <a:hlinkClick r:id="rId3"/>
+              </a:rPr>
+              <a:t>https://link.springer.com/article/10.1007/s10664-021-10109-y</a:t>
+            </a:r>
+            <a:r>
+              <a:rPr lang="en-US" sz="900" dirty="0">
+                <a:solidFill>
+                  <a:srgbClr val="333333"/>
+                </a:solidFill>
+                <a:latin typeface="Georgia" panose="02040502050405020303" pitchFamily="18" charset="0"/>
+              </a:rPr>
+              <a:t> </a:t>
+            </a:r>
+            <a:endParaRPr lang="en-US" sz="900" dirty="0"/>
+          </a:p>
+        </p:txBody>
+      </p:sp>
+      <p:sp>
+        <p:nvSpPr>
+          <p:cNvPr id="5" name="TextBox 4">
+            <a:extLst>
+              <a:ext uri="{FF2B5EF4-FFF2-40B4-BE49-F238E27FC236}">
+                <a16:creationId xmlns:a16="http://schemas.microsoft.com/office/drawing/2014/main" id="{1E08015D-93BC-D0B6-A73A-D67F74461F2F}"/>
+              </a:ext>
+            </a:extLst>
+          </p:cNvPr>
+          <p:cNvSpPr txBox="1"/>
+          <p:nvPr/>
+        </p:nvSpPr>
+        <p:spPr>
+          <a:xfrm>
+            <a:off x="7560013" y="5126845"/>
+            <a:ext cx="3793787" cy="974626"/>
+          </a:xfrm>
+          <a:prstGeom prst="rect">
+            <a:avLst/>
+          </a:prstGeom>
+          <a:solidFill>
+            <a:schemeClr val="accent3">
+              <a:lumMod val="60000"/>
+              <a:lumOff val="40000"/>
+            </a:schemeClr>
+          </a:solidFill>
+          <a:ln/>
+        </p:spPr>
+        <p:style>
+          <a:lnRef idx="2">
+            <a:schemeClr val="accent1">
+              <a:shade val="50000"/>
+            </a:schemeClr>
+          </a:lnRef>
+          <a:fillRef idx="1">
+            <a:schemeClr val="accent1"/>
+          </a:fillRef>
+          <a:effectRef idx="0">
+            <a:schemeClr val="accent1"/>
+          </a:effectRef>
+          <a:fontRef idx="minor">
+            <a:schemeClr val="lt1"/>
+          </a:fontRef>
+        </p:style>
+        <p:txBody>
+          <a:bodyPr rot="0" spcFirstLastPara="1" vertOverflow="overflow" horzOverflow="overflow" vert="horz" wrap="square" lIns="25400" tIns="25400" rIns="25400" bIns="25400" numCol="1" spcCol="38100" rtlCol="0" anchor="ctr">
+            <a:spAutoFit/>
+          </a:bodyPr>
+          <a:lstStyle/>
+          <a:p>
+            <a:pPr algn="ctr" defTabSz="1219169" hangingPunct="0"/>
+            <a:r>
+              <a:rPr lang="en-US" sz="3000" dirty="0">
+                <a:solidFill>
+                  <a:schemeClr val="tx1"/>
+                </a:solidFill>
+                <a:sym typeface="Helvetica Neue"/>
+              </a:rPr>
+              <a:t>Is it a tool problem or a management problem?</a:t>
+            </a:r>
+          </a:p>
+        </p:txBody>
+      </p:sp>
+    </p:spTree>
+    <p:extLst>
+      <p:ext uri="{BB962C8B-B14F-4D97-AF65-F5344CB8AC3E}">
+        <p14:creationId xmlns:p14="http://schemas.microsoft.com/office/powerpoint/2010/main" val="126056709"/>
+      </p:ext>
+    </p:extLst>
+  </p:cSld>
+  <p:clrMapOvr>
+    <a:masterClrMapping/>
+  </p:clrMapOvr>
+  <p:timing>
+    <p:tnLst>
+      <p:par>
+        <p:cTn id="1" dur="indefinite" restart="never" nodeType="tmRoot">
+          <p:childTnLst>
+            <p:seq concurrent="1" nextAc="seek">
+              <p:cTn id="2" dur="indefinite" nodeType="mainSeq">
+                <p:childTnLst>
+                  <p:par>
+                    <p:cTn id="3" fill="hold">
+                      <p:stCondLst>
+                        <p:cond delay="indefinite"/>
+                      </p:stCondLst>
+                      <p:childTnLst>
+                        <p:par>
+                          <p:cTn id="4" fill="hold">
+                            <p:stCondLst>
+                              <p:cond delay="0"/>
+                            </p:stCondLst>
+                            <p:childTnLst>
+                              <p:par>
+                                <p:cTn id="5" presetID="1" presetClass="entr" presetSubtype="0" fill="hold" grpId="0" nodeType="clickEffect">
+                                  <p:stCondLst>
+                                    <p:cond delay="0"/>
+                                  </p:stCondLst>
+                                  <p:childTnLst>
+                                    <p:set>
+                                      <p:cBhvr>
+                                        <p:cTn id="6" dur="1" fill="hold">
+                                          <p:stCondLst>
+                                            <p:cond delay="0"/>
+                                          </p:stCondLst>
+                                        </p:cTn>
+                                        <p:tgtEl>
+                                          <p:spTgt spid="5"/>
+                                        </p:tgtEl>
+                                        <p:attrNameLst>
+                                          <p:attrName>style.visibility</p:attrName>
+                                        </p:attrNameLst>
+                                      </p:cBhvr>
+                                      <p:to>
+                                        <p:strVal val="visible"/>
+                                      </p:to>
+                                    </p:set>
+                                  </p:childTnLst>
+                                </p:cTn>
+                              </p:par>
+                            </p:childTnLst>
+                          </p:cTn>
+                        </p:par>
+                      </p:childTnLst>
+                    </p:cTn>
+                  </p:par>
+                </p:childTnLst>
+              </p:cTn>
+              <p:prevCondLst>
+                <p:cond evt="onPrev" delay="0">
+                  <p:tgtEl>
+                    <p:sldTgt/>
+                  </p:tgtEl>
+                </p:cond>
+              </p:prevCondLst>
+              <p:nextCondLst>
+                <p:cond evt="onNext" delay="0">
+                  <p:tgtEl>
+                    <p:sldTgt/>
+                  </p:tgtEl>
+                </p:cond>
+              </p:nextCondLst>
+            </p:seq>
+          </p:childTnLst>
+        </p:cTn>
+      </p:par>
+    </p:tnLst>
+    <p:bldLst>
+      <p:bldP spid="5" grpId="0" animBg="1"/>
+    </p:bldLst>
+  </p:timing>
+</p:sld>
+</file>
+
+<file path=ppt/slides/slide42.xml><?xml version="1.0" encoding="utf-8"?>
+<p:sld xmlns:a="http://schemas.openxmlformats.org/drawingml/2006/main" xmlns:r="http://schemas.openxmlformats.org/officeDocument/2006/relationships" xmlns:p="http://schemas.openxmlformats.org/presentationml/2006/main">
+  <p:cSld>
+    <p:spTree>
+      <p:nvGrpSpPr>
+        <p:cNvPr id="1" name=""/>
+        <p:cNvGrpSpPr/>
+        <p:nvPr/>
+      </p:nvGrpSpPr>
+      <p:grpSpPr>
+        <a:xfrm>
+          <a:off x="0" y="0"/>
+          <a:ext cx="0" cy="0"/>
+          <a:chOff x="0" y="0"/>
+          <a:chExt cx="0" cy="0"/>
+        </a:xfrm>
+      </p:grpSpPr>
+      <p:sp>
+        <p:nvSpPr>
+          <p:cNvPr id="2" name="Title 1">
+            <a:extLst>
+              <a:ext uri="{FF2B5EF4-FFF2-40B4-BE49-F238E27FC236}">
                 <a16:creationId xmlns:a16="http://schemas.microsoft.com/office/drawing/2014/main" id="{ED7460F2-402D-B9AA-A614-91E800A3128D}"/>
               </a:ext>
             </a:extLst>
@@ -21377,7 +22302,7 @@
           <a:p>
             <a:fld id="{20F37917-FD3A-4669-9018-DA04BCDD3D75}" type="slidenum">
               <a:rPr lang="en-US" smtClean="0"/>
-              <a:t>40</a:t>
+              <a:t>42</a:t>
             </a:fld>
             <a:endParaRPr lang="en-US"/>
           </a:p>
@@ -21443,7 +22368,7 @@
 </p:sld>
 </file>
 
-<file path=ppt/slides/slide41.xml><?xml version="1.0" encoding="utf-8"?>
+<file path=ppt/slides/slide43.xml><?xml version="1.0" encoding="utf-8"?>
 <p:sld xmlns:a="http://schemas.openxmlformats.org/drawingml/2006/main" xmlns:r="http://schemas.openxmlformats.org/officeDocument/2006/relationships" xmlns:p="http://schemas.openxmlformats.org/presentationml/2006/main">
   <p:cSld>
     <p:spTree>
@@ -21578,7 +22503,7 @@
           <a:p>
             <a:fld id="{20F37917-FD3A-4669-9018-DA04BCDD3D75}" type="slidenum">
               <a:rPr lang="en-US" smtClean="0"/>
-              <a:t>41</a:t>
+              <a:t>43</a:t>
             </a:fld>
             <a:endParaRPr lang="en-US" dirty="0"/>
           </a:p>
@@ -21643,7 +22568,7 @@
 </p:sld>
 </file>
 
-<file path=ppt/slides/slide42.xml><?xml version="1.0" encoding="utf-8"?>
+<file path=ppt/slides/slide44.xml><?xml version="1.0" encoding="utf-8"?>
 <p:sld xmlns:a="http://schemas.openxmlformats.org/drawingml/2006/main" xmlns:r="http://schemas.openxmlformats.org/officeDocument/2006/relationships" xmlns:p="http://schemas.openxmlformats.org/presentationml/2006/main">
   <p:cSld>
     <p:spTree>
@@ -21774,465 +22699,6 @@
     <p:extLst>
       <p:ext uri="{BB962C8B-B14F-4D97-AF65-F5344CB8AC3E}">
         <p14:creationId xmlns:p14="http://schemas.microsoft.com/office/powerpoint/2010/main" val="3870596137"/>
-      </p:ext>
-    </p:extLst>
-  </p:cSld>
-  <p:clrMapOvr>
-    <a:masterClrMapping/>
-  </p:clrMapOvr>
-</p:sld>
-</file>
-
-<file path=ppt/slides/slide43.xml><?xml version="1.0" encoding="utf-8"?>
-<p:sld xmlns:a="http://schemas.openxmlformats.org/drawingml/2006/main" xmlns:r="http://schemas.openxmlformats.org/officeDocument/2006/relationships" xmlns:p="http://schemas.openxmlformats.org/presentationml/2006/main">
-  <p:cSld>
-    <p:spTree>
-      <p:nvGrpSpPr>
-        <p:cNvPr id="1" name=""/>
-        <p:cNvGrpSpPr/>
-        <p:nvPr/>
-      </p:nvGrpSpPr>
-      <p:grpSpPr>
-        <a:xfrm>
-          <a:off x="0" y="0"/>
-          <a:ext cx="0" cy="0"/>
-          <a:chOff x="0" y="0"/>
-          <a:chExt cx="0" cy="0"/>
-        </a:xfrm>
-      </p:grpSpPr>
-      <p:sp>
-        <p:nvSpPr>
-          <p:cNvPr id="2" name="Title 1">
-            <a:extLst>
-              <a:ext uri="{FF2B5EF4-FFF2-40B4-BE49-F238E27FC236}">
-                <a16:creationId xmlns:a16="http://schemas.microsoft.com/office/drawing/2014/main" id="{745AB5F6-8402-21D1-FE7E-9E95F8EAEE7E}"/>
-              </a:ext>
-            </a:extLst>
-          </p:cNvPr>
-          <p:cNvSpPr>
-            <a:spLocks noGrp="1"/>
-          </p:cNvSpPr>
-          <p:nvPr>
-            <p:ph type="title"/>
-          </p:nvPr>
-        </p:nvSpPr>
-        <p:spPr/>
-        <p:txBody>
-          <a:bodyPr/>
-          <a:lstStyle/>
-          <a:p>
-            <a:r>
-              <a:rPr lang="en-US" dirty="0"/>
-              <a:t>For every data flow, ask “what could go wrong?”</a:t>
-            </a:r>
-          </a:p>
-        </p:txBody>
-      </p:sp>
-      <p:sp>
-        <p:nvSpPr>
-          <p:cNvPr id="3" name="Content Placeholder 2">
-            <a:extLst>
-              <a:ext uri="{FF2B5EF4-FFF2-40B4-BE49-F238E27FC236}">
-                <a16:creationId xmlns:a16="http://schemas.microsoft.com/office/drawing/2014/main" id="{6C92FEA4-7715-91F2-3909-2E533E189B16}"/>
-              </a:ext>
-            </a:extLst>
-          </p:cNvPr>
-          <p:cNvSpPr>
-            <a:spLocks noGrp="1"/>
-          </p:cNvSpPr>
-          <p:nvPr>
-            <p:ph idx="1"/>
-          </p:nvPr>
-        </p:nvSpPr>
-        <p:spPr>
-          <a:xfrm>
-            <a:off x="838200" y="1500159"/>
-            <a:ext cx="9623323" cy="4856191"/>
-          </a:xfrm>
-        </p:spPr>
-        <p:txBody>
-          <a:bodyPr>
-            <a:normAutofit fontScale="77500" lnSpcReduction="20000"/>
-          </a:bodyPr>
-          <a:lstStyle/>
-          <a:p>
-            <a:pPr lvl="0" fontAlgn="base"/>
-            <a:r>
-              <a:rPr lang="en-US" b="1" dirty="0"/>
-              <a:t>S</a:t>
-            </a:r>
-            <a:r>
-              <a:rPr lang="en-US" dirty="0"/>
-              <a:t>poofed identity: </a:t>
-            </a:r>
-            <a:r>
-              <a:rPr lang="en-US" i="1" dirty="0"/>
-              <a:t>Is there Authentication? Should there be?</a:t>
-            </a:r>
-            <a:r>
-              <a:rPr lang="en-US" dirty="0"/>
-              <a:t> - Attackers pretending to be legitimate users through stolen credentials, phishing, or social engineering.</a:t>
-            </a:r>
-          </a:p>
-          <a:p>
-            <a:pPr lvl="0" fontAlgn="base"/>
-            <a:r>
-              <a:rPr lang="en-US" b="1" dirty="0"/>
-              <a:t>T</a:t>
-            </a:r>
-            <a:r>
-              <a:rPr lang="en-US" dirty="0"/>
-              <a:t>ampering with input: </a:t>
-            </a:r>
-            <a:r>
-              <a:rPr lang="en-US" i="1" dirty="0"/>
-              <a:t>What about nasty input?</a:t>
-            </a:r>
-            <a:r>
-              <a:rPr lang="en-US" dirty="0"/>
-              <a:t> - Attackers modifying data, code, or memory maliciously to break your system's trust boundaries.</a:t>
-            </a:r>
-          </a:p>
-          <a:p>
-            <a:pPr lvl="0" fontAlgn="base"/>
-            <a:r>
-              <a:rPr lang="en-US" b="1" dirty="0"/>
-              <a:t>R</a:t>
-            </a:r>
-            <a:r>
-              <a:rPr lang="en-US" dirty="0"/>
-              <a:t>epudiation: </a:t>
-            </a:r>
-            <a:r>
-              <a:rPr lang="en-US" i="1" dirty="0"/>
-              <a:t>Does the system show who is accountable?</a:t>
-            </a:r>
-            <a:r>
-              <a:rPr lang="en-US" dirty="0"/>
-              <a:t> - When something goes wrong, can you prove which user performed an action, or could they plausibly deny responsibility due to insufficient audit trails?</a:t>
-            </a:r>
-          </a:p>
-          <a:p>
-            <a:pPr lvl="0" fontAlgn="base"/>
-            <a:r>
-              <a:rPr lang="en-US" b="1" dirty="0"/>
-              <a:t>I</a:t>
-            </a:r>
-            <a:r>
-              <a:rPr lang="en-US" dirty="0"/>
-              <a:t>nformation disclosure: </a:t>
-            </a:r>
-            <a:r>
-              <a:rPr lang="en-US" i="1" dirty="0"/>
-              <a:t>Is sensitive data inappropriately exposed or unencrypted?</a:t>
-            </a:r>
-            <a:r>
-              <a:rPr lang="en-US" dirty="0"/>
-              <a:t> - Unauthorized access to sensitive data through poor access controls, cleartext transmission, or insufficient data protection.</a:t>
-            </a:r>
-          </a:p>
-          <a:p>
-            <a:pPr lvl="0" fontAlgn="base"/>
-            <a:r>
-              <a:rPr lang="en-US" b="1" dirty="0"/>
-              <a:t>D</a:t>
-            </a:r>
-            <a:r>
-              <a:rPr lang="en-US" dirty="0"/>
-              <a:t>enial of service: </a:t>
-            </a:r>
-            <a:r>
-              <a:rPr lang="en-US" i="1" dirty="0"/>
-              <a:t>What if we smash it?</a:t>
-            </a:r>
-            <a:r>
-              <a:rPr lang="en-US" dirty="0"/>
-              <a:t> - Attacks aiming at making the system unavailable to legitimate users by flooding or breaking critical components.</a:t>
-            </a:r>
-          </a:p>
-          <a:p>
-            <a:pPr lvl="0" fontAlgn="base"/>
-            <a:r>
-              <a:rPr lang="en-US" b="1" dirty="0"/>
-              <a:t>E</a:t>
-            </a:r>
-            <a:r>
-              <a:rPr lang="en-US" dirty="0"/>
-              <a:t>levation of privilege: </a:t>
-            </a:r>
-            <a:r>
-              <a:rPr lang="en-US" i="1" dirty="0"/>
-              <a:t>Can I bypass Authorization? Move deeper into the system?</a:t>
-            </a:r>
-            <a:r>
-              <a:rPr lang="en-US" dirty="0"/>
-              <a:t> - Attackers gaining unauthorized access levels, obtaining higher permissions than intended, or moving laterally through your system.</a:t>
-            </a:r>
-          </a:p>
-        </p:txBody>
-      </p:sp>
-      <p:sp>
-        <p:nvSpPr>
-          <p:cNvPr id="4" name="Slide Number Placeholder 3">
-            <a:extLst>
-              <a:ext uri="{FF2B5EF4-FFF2-40B4-BE49-F238E27FC236}">
-                <a16:creationId xmlns:a16="http://schemas.microsoft.com/office/drawing/2014/main" id="{87AE9534-859F-71D2-5797-D58C842B6700}"/>
-              </a:ext>
-            </a:extLst>
-          </p:cNvPr>
-          <p:cNvSpPr>
-            <a:spLocks noGrp="1"/>
-          </p:cNvSpPr>
-          <p:nvPr>
-            <p:ph type="sldNum" sz="quarter" idx="12"/>
-          </p:nvPr>
-        </p:nvSpPr>
-        <p:spPr/>
-        <p:txBody>
-          <a:bodyPr/>
-          <a:lstStyle/>
-          <a:p>
-            <a:fld id="{20F37917-FD3A-4669-9018-DA04BCDD3D75}" type="slidenum">
-              <a:rPr lang="en-US" smtClean="0"/>
-              <a:t>43</a:t>
-            </a:fld>
-            <a:endParaRPr lang="en-US"/>
-          </a:p>
-        </p:txBody>
-      </p:sp>
-    </p:spTree>
-    <p:extLst>
-      <p:ext uri="{BB962C8B-B14F-4D97-AF65-F5344CB8AC3E}">
-        <p14:creationId xmlns:p14="http://schemas.microsoft.com/office/powerpoint/2010/main" val="2163532588"/>
-      </p:ext>
-    </p:extLst>
-  </p:cSld>
-  <p:clrMapOvr>
-    <a:masterClrMapping/>
-  </p:clrMapOvr>
-</p:sld>
-</file>
-
-<file path=ppt/slides/slide44.xml><?xml version="1.0" encoding="utf-8"?>
-<p:sld xmlns:a="http://schemas.openxmlformats.org/drawingml/2006/main" xmlns:r="http://schemas.openxmlformats.org/officeDocument/2006/relationships" xmlns:p="http://schemas.openxmlformats.org/presentationml/2006/main">
-  <p:cSld>
-    <p:spTree>
-      <p:nvGrpSpPr>
-        <p:cNvPr id="1" name="">
-          <a:extLst>
-            <a:ext uri="{FF2B5EF4-FFF2-40B4-BE49-F238E27FC236}">
-              <a16:creationId xmlns:a16="http://schemas.microsoft.com/office/drawing/2014/main" id="{513C269D-332D-7519-6CED-6E8C182E257D}"/>
-            </a:ext>
-          </a:extLst>
-        </p:cNvPr>
-        <p:cNvGrpSpPr/>
-        <p:nvPr/>
-      </p:nvGrpSpPr>
-      <p:grpSpPr>
-        <a:xfrm>
-          <a:off x="0" y="0"/>
-          <a:ext cx="0" cy="0"/>
-          <a:chOff x="0" y="0"/>
-          <a:chExt cx="0" cy="0"/>
-        </a:xfrm>
-      </p:grpSpPr>
-      <p:sp>
-        <p:nvSpPr>
-          <p:cNvPr id="2" name="Title 1">
-            <a:extLst>
-              <a:ext uri="{FF2B5EF4-FFF2-40B4-BE49-F238E27FC236}">
-                <a16:creationId xmlns:a16="http://schemas.microsoft.com/office/drawing/2014/main" id="{B974C6E5-8FE2-DF16-609E-9B7A086EBBD8}"/>
-              </a:ext>
-            </a:extLst>
-          </p:cNvPr>
-          <p:cNvSpPr>
-            <a:spLocks noGrp="1"/>
-          </p:cNvSpPr>
-          <p:nvPr>
-            <p:ph type="title"/>
-          </p:nvPr>
-        </p:nvSpPr>
-        <p:spPr/>
-        <p:txBody>
-          <a:bodyPr/>
-          <a:lstStyle/>
-          <a:p>
-            <a:r>
-              <a:rPr lang="en-US" dirty="0"/>
-              <a:t>Choose highest priority vulnerabilities</a:t>
-            </a:r>
-          </a:p>
-        </p:txBody>
-      </p:sp>
-      <p:sp>
-        <p:nvSpPr>
-          <p:cNvPr id="3" name="Content Placeholder 2">
-            <a:extLst>
-              <a:ext uri="{FF2B5EF4-FFF2-40B4-BE49-F238E27FC236}">
-                <a16:creationId xmlns:a16="http://schemas.microsoft.com/office/drawing/2014/main" id="{64D9733F-E10E-307D-2EA6-7F4520ABB642}"/>
-              </a:ext>
-            </a:extLst>
-          </p:cNvPr>
-          <p:cNvSpPr>
-            <a:spLocks noGrp="1"/>
-          </p:cNvSpPr>
-          <p:nvPr>
-            <p:ph idx="1"/>
-          </p:nvPr>
-        </p:nvSpPr>
-        <p:spPr>
-          <a:xfrm>
-            <a:off x="838200" y="1500160"/>
-            <a:ext cx="8818756" cy="4351338"/>
-          </a:xfrm>
-        </p:spPr>
-        <p:txBody>
-          <a:bodyPr>
-            <a:normAutofit/>
-          </a:bodyPr>
-          <a:lstStyle/>
-          <a:p>
-            <a:r>
-              <a:rPr lang="en-US" dirty="0"/>
-              <a:t>Add Highest Priority threats to backlog (as user stories or conditions of satisfaction)</a:t>
-            </a:r>
-          </a:p>
-          <a:p>
-            <a:pPr lvl="1"/>
-            <a:endParaRPr lang="en-US" dirty="0">
-              <a:solidFill>
-                <a:srgbClr val="7030A0"/>
-              </a:solidFill>
-            </a:endParaRPr>
-          </a:p>
-        </p:txBody>
-      </p:sp>
-      <p:sp>
-        <p:nvSpPr>
-          <p:cNvPr id="4" name="Slide Number Placeholder 3">
-            <a:extLst>
-              <a:ext uri="{FF2B5EF4-FFF2-40B4-BE49-F238E27FC236}">
-                <a16:creationId xmlns:a16="http://schemas.microsoft.com/office/drawing/2014/main" id="{1435EAD8-89C7-41F3-196B-5DA7219C7D61}"/>
-              </a:ext>
-            </a:extLst>
-          </p:cNvPr>
-          <p:cNvSpPr>
-            <a:spLocks noGrp="1"/>
-          </p:cNvSpPr>
-          <p:nvPr>
-            <p:ph type="sldNum" sz="quarter" idx="12"/>
-          </p:nvPr>
-        </p:nvSpPr>
-        <p:spPr/>
-        <p:txBody>
-          <a:bodyPr/>
-          <a:lstStyle/>
-          <a:p>
-            <a:fld id="{20F37917-FD3A-4669-9018-DA04BCDD3D75}" type="slidenum">
-              <a:rPr lang="en-US" smtClean="0"/>
-              <a:t>44</a:t>
-            </a:fld>
-            <a:endParaRPr lang="en-US" dirty="0"/>
-          </a:p>
-        </p:txBody>
-      </p:sp>
-      <p:sp>
-        <p:nvSpPr>
-          <p:cNvPr id="6" name="TextBox 5">
-            <a:extLst>
-              <a:ext uri="{FF2B5EF4-FFF2-40B4-BE49-F238E27FC236}">
-                <a16:creationId xmlns:a16="http://schemas.microsoft.com/office/drawing/2014/main" id="{B6CB42CC-E0A3-F486-D1D1-FF4A2A45276B}"/>
-              </a:ext>
-            </a:extLst>
-          </p:cNvPr>
-          <p:cNvSpPr txBox="1"/>
-          <p:nvPr/>
-        </p:nvSpPr>
-        <p:spPr>
-          <a:xfrm>
-            <a:off x="1183887" y="2468935"/>
-            <a:ext cx="10515600" cy="3046988"/>
-          </a:xfrm>
-          <a:prstGeom prst="rect">
-            <a:avLst/>
-          </a:prstGeom>
-          <a:noFill/>
-        </p:spPr>
-        <p:txBody>
-          <a:bodyPr wrap="square" rtlCol="0">
-            <a:spAutoFit/>
-          </a:bodyPr>
-          <a:lstStyle/>
-          <a:p>
-            <a:r>
-              <a:rPr lang="en-US" sz="2400" b="1" dirty="0">
-                <a:latin typeface="Bradley Hand ITC" panose="03070402050302030203" pitchFamily="66" charset="77"/>
-              </a:rPr>
-              <a:t>Given the user is logged in </a:t>
-            </a:r>
-            <a:br>
-              <a:rPr lang="en-US" sz="2400" b="1" dirty="0">
-                <a:latin typeface="Bradley Hand ITC" panose="03070402050302030203" pitchFamily="66" charset="77"/>
-              </a:rPr>
-            </a:br>
-            <a:r>
-              <a:rPr lang="en-US" sz="2400" b="1" dirty="0">
-                <a:latin typeface="Bradley Hand ITC" panose="03070402050302030203" pitchFamily="66" charset="77"/>
-              </a:rPr>
-              <a:t>When they request to view their profile page And they have a valid token</a:t>
-            </a:r>
-          </a:p>
-          <a:p>
-            <a:r>
-              <a:rPr lang="en-US" sz="2400" b="1" dirty="0">
-                <a:latin typeface="Bradley Hand ITC" panose="03070402050302030203" pitchFamily="66" charset="77"/>
-              </a:rPr>
-              <a:t>Then their profile page is displayed  </a:t>
-            </a:r>
-          </a:p>
-          <a:p>
-            <a:endParaRPr lang="en-US" sz="2400" b="1" dirty="0">
-              <a:latin typeface="Bradley Hand ITC" panose="03070402050302030203" pitchFamily="66" charset="77"/>
-            </a:endParaRPr>
-          </a:p>
-          <a:p>
-            <a:r>
-              <a:rPr lang="en-US" sz="2400" b="1" dirty="0">
-                <a:latin typeface="Bradley Hand ITC" panose="03070402050302030203" pitchFamily="66" charset="77"/>
-              </a:rPr>
-              <a:t>Given the user is logged in</a:t>
-            </a:r>
-          </a:p>
-          <a:p>
-            <a:r>
-              <a:rPr lang="en-US" sz="2400" b="1" dirty="0">
-                <a:latin typeface="Bradley Hand ITC" panose="03070402050302030203" pitchFamily="66" charset="77"/>
-              </a:rPr>
-              <a:t>When they request to view their profile page</a:t>
-            </a:r>
-          </a:p>
-          <a:p>
-            <a:r>
-              <a:rPr lang="en-US" sz="2400" b="1" dirty="0">
-                <a:latin typeface="Bradley Hand ITC" panose="03070402050302030203" pitchFamily="66" charset="77"/>
-              </a:rPr>
-              <a:t>But they do not have a valid token</a:t>
-            </a:r>
-          </a:p>
-          <a:p>
-            <a:r>
-              <a:rPr lang="en-US" sz="2400" b="1" dirty="0">
-                <a:latin typeface="Bradley Hand ITC" panose="03070402050302030203" pitchFamily="66" charset="77"/>
-              </a:rPr>
-              <a:t>Then they are asked to login or signup  </a:t>
-            </a:r>
-          </a:p>
-        </p:txBody>
-      </p:sp>
-    </p:spTree>
-    <p:extLst>
-      <p:ext uri="{BB962C8B-B14F-4D97-AF65-F5344CB8AC3E}">
-        <p14:creationId xmlns:p14="http://schemas.microsoft.com/office/powerpoint/2010/main" val="4223131274"/>
       </p:ext>
     </p:extLst>
   </p:cSld>
@@ -22288,7 +22754,7 @@
           <a:p>
             <a:r>
               <a:rPr lang="en-US" dirty="0"/>
-              <a:t>What are you going to do?</a:t>
+              <a:t>Identify the vulnerabilities and threats on each flow</a:t>
             </a:r>
           </a:p>
         </p:txBody>
@@ -22312,7 +22778,734 @@
         <p:spPr>
           <a:xfrm>
             <a:off x="838200" y="1500160"/>
-            <a:ext cx="9197898" cy="4351338"/>
+            <a:ext cx="4767470" cy="4351338"/>
+          </a:xfrm>
+        </p:spPr>
+        <p:txBody>
+          <a:bodyPr/>
+          <a:lstStyle/>
+          <a:p>
+            <a:r>
+              <a:rPr lang="en-US" dirty="0"/>
+              <a:t>Identify the possible vulnerabilities and threats on each flow.</a:t>
+            </a:r>
+          </a:p>
+          <a:p>
+            <a:pPr lvl="1"/>
+            <a:r>
+              <a:rPr lang="en-US" dirty="0">
+                <a:solidFill>
+                  <a:srgbClr val="C00000"/>
+                </a:solidFill>
+              </a:rPr>
+              <a:t>Customer -&gt; UI</a:t>
+            </a:r>
+          </a:p>
+          <a:p>
+            <a:pPr lvl="1"/>
+            <a:r>
+              <a:rPr lang="en-US" dirty="0">
+                <a:solidFill>
+                  <a:srgbClr val="0070C0"/>
+                </a:solidFill>
+              </a:rPr>
+              <a:t>Customer -&gt; Identity Service</a:t>
+            </a:r>
+          </a:p>
+          <a:p>
+            <a:pPr lvl="1"/>
+            <a:r>
+              <a:rPr lang="en-US" dirty="0">
+                <a:solidFill>
+                  <a:schemeClr val="accent6">
+                    <a:lumMod val="75000"/>
+                  </a:schemeClr>
+                </a:solidFill>
+              </a:rPr>
+              <a:t>UI -&gt; BFF</a:t>
+            </a:r>
+          </a:p>
+          <a:p>
+            <a:pPr lvl="1"/>
+            <a:r>
+              <a:rPr lang="en-US" dirty="0">
+                <a:solidFill>
+                  <a:srgbClr val="7030A0"/>
+                </a:solidFill>
+              </a:rPr>
+              <a:t>BFF -&gt; Customer Service </a:t>
+            </a:r>
+          </a:p>
+        </p:txBody>
+      </p:sp>
+      <p:sp>
+        <p:nvSpPr>
+          <p:cNvPr id="4" name="Slide Number Placeholder 3">
+            <a:extLst>
+              <a:ext uri="{FF2B5EF4-FFF2-40B4-BE49-F238E27FC236}">
+                <a16:creationId xmlns:a16="http://schemas.microsoft.com/office/drawing/2014/main" id="{1435EAD8-89C7-41F3-196B-5DA7219C7D61}"/>
+              </a:ext>
+            </a:extLst>
+          </p:cNvPr>
+          <p:cNvSpPr>
+            <a:spLocks noGrp="1"/>
+          </p:cNvSpPr>
+          <p:nvPr>
+            <p:ph type="sldNum" sz="quarter" idx="12"/>
+          </p:nvPr>
+        </p:nvSpPr>
+        <p:spPr/>
+        <p:txBody>
+          <a:bodyPr/>
+          <a:lstStyle/>
+          <a:p>
+            <a:fld id="{20F37917-FD3A-4669-9018-DA04BCDD3D75}" type="slidenum">
+              <a:rPr lang="en-US" smtClean="0"/>
+              <a:t>45</a:t>
+            </a:fld>
+            <a:endParaRPr lang="en-US" dirty="0"/>
+          </a:p>
+        </p:txBody>
+      </p:sp>
+      <p:pic>
+        <p:nvPicPr>
+          <p:cNvPr id="5" name="Picture 2">
+            <a:extLst>
+              <a:ext uri="{FF2B5EF4-FFF2-40B4-BE49-F238E27FC236}">
+                <a16:creationId xmlns:a16="http://schemas.microsoft.com/office/drawing/2014/main" id="{63B124B3-8924-11B1-430E-1B0CA533155D}"/>
+              </a:ext>
+            </a:extLst>
+          </p:cNvPr>
+          <p:cNvPicPr>
+            <a:picLocks noChangeAspect="1" noChangeArrowheads="1"/>
+          </p:cNvPicPr>
+          <p:nvPr/>
+        </p:nvPicPr>
+        <p:blipFill>
+          <a:blip r:embed="rId3">
+            <a:extLst>
+              <a:ext uri="{28A0092B-C50C-407E-A947-70E740481C1C}">
+                <a14:useLocalDpi xmlns:a14="http://schemas.microsoft.com/office/drawing/2010/main" val="0"/>
+              </a:ext>
+            </a:extLst>
+          </a:blip>
+          <a:srcRect/>
+          <a:stretch>
+            <a:fillRect/>
+          </a:stretch>
+        </p:blipFill>
+        <p:spPr bwMode="auto">
+          <a:xfrm>
+            <a:off x="5896096" y="1895199"/>
+            <a:ext cx="5968272" cy="3142668"/>
+          </a:xfrm>
+          <a:prstGeom prst="rect">
+            <a:avLst/>
+          </a:prstGeom>
+          <a:noFill/>
+          <a:extLst>
+            <a:ext uri="{909E8E84-426E-40DD-AFC4-6F175D3DCCD1}">
+              <a14:hiddenFill xmlns:a14="http://schemas.microsoft.com/office/drawing/2010/main">
+                <a:solidFill>
+                  <a:srgbClr val="FFFFFF"/>
+                </a:solidFill>
+              </a14:hiddenFill>
+            </a:ext>
+          </a:extLst>
+        </p:spPr>
+      </p:pic>
+      <p:sp>
+        <p:nvSpPr>
+          <p:cNvPr id="7" name="TextBox 6">
+            <a:extLst>
+              <a:ext uri="{FF2B5EF4-FFF2-40B4-BE49-F238E27FC236}">
+                <a16:creationId xmlns:a16="http://schemas.microsoft.com/office/drawing/2014/main" id="{7B287D73-3DD1-1949-A242-9A0F4E094AF7}"/>
+              </a:ext>
+            </a:extLst>
+          </p:cNvPr>
+          <p:cNvSpPr txBox="1"/>
+          <p:nvPr/>
+        </p:nvSpPr>
+        <p:spPr>
+          <a:xfrm>
+            <a:off x="6732104" y="2710146"/>
+            <a:ext cx="920445" cy="276999"/>
+          </a:xfrm>
+          <a:prstGeom prst="rect">
+            <a:avLst/>
+          </a:prstGeom>
+          <a:noFill/>
+        </p:spPr>
+        <p:txBody>
+          <a:bodyPr wrap="none" rtlCol="0">
+            <a:spAutoFit/>
+          </a:bodyPr>
+          <a:lstStyle/>
+          <a:p>
+            <a:r>
+              <a:rPr lang="en-US" sz="1200" b="1" dirty="0">
+                <a:solidFill>
+                  <a:srgbClr val="C00000"/>
+                </a:solidFill>
+                <a:latin typeface="APPLE CHANCERY" panose="03020702040506060504" pitchFamily="66" charset="-79"/>
+                <a:cs typeface="APPLE CHANCERY" panose="03020702040506060504" pitchFamily="66" charset="-79"/>
+              </a:rPr>
+              <a:t>XSS attack</a:t>
+            </a:r>
+          </a:p>
+        </p:txBody>
+      </p:sp>
+      <p:sp>
+        <p:nvSpPr>
+          <p:cNvPr id="8" name="TextBox 7">
+            <a:extLst>
+              <a:ext uri="{FF2B5EF4-FFF2-40B4-BE49-F238E27FC236}">
+                <a16:creationId xmlns:a16="http://schemas.microsoft.com/office/drawing/2014/main" id="{1BF7E704-B53E-2FBE-986E-98A70C42EE0D}"/>
+              </a:ext>
+            </a:extLst>
+          </p:cNvPr>
+          <p:cNvSpPr txBox="1"/>
+          <p:nvPr/>
+        </p:nvSpPr>
+        <p:spPr>
+          <a:xfrm>
+            <a:off x="7818736" y="2248481"/>
+            <a:ext cx="1182757" cy="461665"/>
+          </a:xfrm>
+          <a:prstGeom prst="rect">
+            <a:avLst/>
+          </a:prstGeom>
+          <a:noFill/>
+        </p:spPr>
+        <p:txBody>
+          <a:bodyPr wrap="square" rtlCol="0">
+            <a:spAutoFit/>
+          </a:bodyPr>
+          <a:lstStyle/>
+          <a:p>
+            <a:r>
+              <a:rPr lang="en-US" sz="1200" b="1" dirty="0">
+                <a:solidFill>
+                  <a:srgbClr val="0070C0"/>
+                </a:solidFill>
+                <a:latin typeface="APPLE CHANCERY" panose="03020702040506060504" pitchFamily="66" charset="-79"/>
+                <a:cs typeface="APPLE CHANCERY" panose="03020702040506060504" pitchFamily="66" charset="-79"/>
+              </a:rPr>
+              <a:t>No 2-factor authentication</a:t>
+            </a:r>
+          </a:p>
+        </p:txBody>
+      </p:sp>
+      <p:sp>
+        <p:nvSpPr>
+          <p:cNvPr id="9" name="TextBox 8">
+            <a:extLst>
+              <a:ext uri="{FF2B5EF4-FFF2-40B4-BE49-F238E27FC236}">
+                <a16:creationId xmlns:a16="http://schemas.microsoft.com/office/drawing/2014/main" id="{BA2EA816-66D6-0FB1-E241-24C33140293D}"/>
+              </a:ext>
+            </a:extLst>
+          </p:cNvPr>
+          <p:cNvSpPr txBox="1"/>
+          <p:nvPr/>
+        </p:nvSpPr>
+        <p:spPr>
+          <a:xfrm>
+            <a:off x="7192327" y="4114085"/>
+            <a:ext cx="1922146" cy="1754326"/>
+          </a:xfrm>
+          <a:prstGeom prst="rect">
+            <a:avLst/>
+          </a:prstGeom>
+          <a:noFill/>
+        </p:spPr>
+        <p:txBody>
+          <a:bodyPr wrap="square" rtlCol="0">
+            <a:spAutoFit/>
+          </a:bodyPr>
+          <a:lstStyle/>
+          <a:p>
+            <a:pPr marL="171450" indent="-171450">
+              <a:buFont typeface="Arial" panose="020B0604020202020204" pitchFamily="34" charset="0"/>
+              <a:buChar char="•"/>
+            </a:pPr>
+            <a:r>
+              <a:rPr lang="en-US" sz="1200" b="1" dirty="0">
+                <a:solidFill>
+                  <a:schemeClr val="accent6">
+                    <a:lumMod val="75000"/>
+                  </a:schemeClr>
+                </a:solidFill>
+                <a:latin typeface="APPLE CHANCERY" panose="03020702040506060504" pitchFamily="66" charset="-79"/>
+                <a:cs typeface="APPLE CHANCERY" panose="03020702040506060504" pitchFamily="66" charset="-79"/>
+              </a:rPr>
+              <a:t>Absent/weak identity token validation</a:t>
+            </a:r>
+          </a:p>
+          <a:p>
+            <a:pPr marL="171450" indent="-171450">
+              <a:buFont typeface="Arial" panose="020B0604020202020204" pitchFamily="34" charset="0"/>
+              <a:buChar char="•"/>
+            </a:pPr>
+            <a:r>
+              <a:rPr lang="en-US" sz="1200" b="1" dirty="0">
+                <a:solidFill>
+                  <a:schemeClr val="accent6">
+                    <a:lumMod val="75000"/>
+                  </a:schemeClr>
+                </a:solidFill>
+                <a:latin typeface="APPLE CHANCERY" panose="03020702040506060504" pitchFamily="66" charset="-79"/>
+                <a:cs typeface="APPLE CHANCERY" panose="03020702040506060504" pitchFamily="66" charset="-79"/>
+              </a:rPr>
+              <a:t>injection attacks</a:t>
+            </a:r>
+          </a:p>
+          <a:p>
+            <a:pPr marL="171450" indent="-171450">
+              <a:buFont typeface="Arial" panose="020B0604020202020204" pitchFamily="34" charset="0"/>
+              <a:buChar char="•"/>
+            </a:pPr>
+            <a:r>
+              <a:rPr lang="en-US" sz="1200" b="1" dirty="0">
+                <a:solidFill>
+                  <a:schemeClr val="accent6">
+                    <a:lumMod val="75000"/>
+                  </a:schemeClr>
+                </a:solidFill>
+                <a:latin typeface="APPLE CHANCERY" panose="03020702040506060504" pitchFamily="66" charset="-79"/>
+                <a:cs typeface="APPLE CHANCERY" panose="03020702040506060504" pitchFamily="66" charset="-79"/>
+              </a:rPr>
+              <a:t>Misconfigured TLS configuration</a:t>
+            </a:r>
+          </a:p>
+          <a:p>
+            <a:pPr marL="171450" indent="-171450">
+              <a:buFont typeface="Arial" panose="020B0604020202020204" pitchFamily="34" charset="0"/>
+              <a:buChar char="•"/>
+            </a:pPr>
+            <a:r>
+              <a:rPr lang="en-US" sz="1200" b="1" dirty="0">
+                <a:solidFill>
+                  <a:schemeClr val="accent6">
+                    <a:lumMod val="75000"/>
+                  </a:schemeClr>
+                </a:solidFill>
+                <a:latin typeface="APPLE CHANCERY" panose="03020702040506060504" pitchFamily="66" charset="-79"/>
+                <a:cs typeface="APPLE CHANCERY" panose="03020702040506060504" pitchFamily="66" charset="-79"/>
+              </a:rPr>
+              <a:t>Privilege of escalation by authenticated user</a:t>
+            </a:r>
+          </a:p>
+          <a:p>
+            <a:pPr marL="171450" indent="-171450">
+              <a:buFont typeface="Arial" panose="020B0604020202020204" pitchFamily="34" charset="0"/>
+              <a:buChar char="•"/>
+            </a:pPr>
+            <a:r>
+              <a:rPr lang="en-US" sz="1200" b="1" dirty="0">
+                <a:solidFill>
+                  <a:schemeClr val="accent6">
+                    <a:lumMod val="75000"/>
+                  </a:schemeClr>
+                </a:solidFill>
+                <a:latin typeface="APPLE CHANCERY" panose="03020702040506060504" pitchFamily="66" charset="-79"/>
+                <a:cs typeface="APPLE CHANCERY" panose="03020702040506060504" pitchFamily="66" charset="-79"/>
+              </a:rPr>
+              <a:t>Flood of traffic from bots</a:t>
+            </a:r>
+          </a:p>
+        </p:txBody>
+      </p:sp>
+      <p:sp>
+        <p:nvSpPr>
+          <p:cNvPr id="10" name="TextBox 9">
+            <a:extLst>
+              <a:ext uri="{FF2B5EF4-FFF2-40B4-BE49-F238E27FC236}">
+                <a16:creationId xmlns:a16="http://schemas.microsoft.com/office/drawing/2014/main" id="{8717C172-B390-7530-4D9A-0C3BACF0B8BA}"/>
+              </a:ext>
+            </a:extLst>
+          </p:cNvPr>
+          <p:cNvSpPr txBox="1"/>
+          <p:nvPr/>
+        </p:nvSpPr>
+        <p:spPr>
+          <a:xfrm>
+            <a:off x="10073315" y="3804539"/>
+            <a:ext cx="1916665" cy="1384995"/>
+          </a:xfrm>
+          <a:prstGeom prst="rect">
+            <a:avLst/>
+          </a:prstGeom>
+          <a:noFill/>
+        </p:spPr>
+        <p:txBody>
+          <a:bodyPr wrap="square" rtlCol="0">
+            <a:spAutoFit/>
+          </a:bodyPr>
+          <a:lstStyle/>
+          <a:p>
+            <a:pPr marL="171450" indent="-171450">
+              <a:buFont typeface="Arial" panose="020B0604020202020204" pitchFamily="34" charset="0"/>
+              <a:buChar char="•"/>
+            </a:pPr>
+            <a:r>
+              <a:rPr lang="en-US" sz="1200" b="1" dirty="0">
+                <a:solidFill>
+                  <a:srgbClr val="7030A0"/>
+                </a:solidFill>
+                <a:latin typeface="APPLE CHANCERY" panose="03020702040506060504" pitchFamily="66" charset="-79"/>
+                <a:cs typeface="APPLE CHANCERY" panose="03020702040506060504" pitchFamily="66" charset="-79"/>
+              </a:rPr>
+              <a:t>Absent/weak authentication (server-to-server)</a:t>
+            </a:r>
+          </a:p>
+          <a:p>
+            <a:pPr marL="171450" indent="-171450">
+              <a:buFont typeface="Arial" panose="020B0604020202020204" pitchFamily="34" charset="0"/>
+              <a:buChar char="•"/>
+            </a:pPr>
+            <a:r>
+              <a:rPr lang="en-US" sz="1200" b="1" dirty="0">
+                <a:solidFill>
+                  <a:srgbClr val="7030A0"/>
+                </a:solidFill>
+                <a:latin typeface="APPLE CHANCERY" panose="03020702040506060504" pitchFamily="66" charset="-79"/>
+                <a:cs typeface="APPLE CHANCERY" panose="03020702040506060504" pitchFamily="66" charset="-79"/>
+              </a:rPr>
+              <a:t>No logging of caller identity</a:t>
+            </a:r>
+          </a:p>
+          <a:p>
+            <a:pPr marL="171450" indent="-171450">
+              <a:buFont typeface="Arial" panose="020B0604020202020204" pitchFamily="34" charset="0"/>
+              <a:buChar char="•"/>
+            </a:pPr>
+            <a:r>
+              <a:rPr lang="en-US" sz="1200" b="1" dirty="0">
+                <a:solidFill>
+                  <a:srgbClr val="7030A0"/>
+                </a:solidFill>
+                <a:latin typeface="APPLE CHANCERY" panose="03020702040506060504" pitchFamily="66" charset="-79"/>
+                <a:cs typeface="APPLE CHANCERY" panose="03020702040506060504" pitchFamily="66" charset="-79"/>
+              </a:rPr>
+              <a:t>Privilege escalation by authenticated user</a:t>
+            </a:r>
+          </a:p>
+        </p:txBody>
+      </p:sp>
+    </p:spTree>
+    <p:extLst>
+      <p:ext uri="{BB962C8B-B14F-4D97-AF65-F5344CB8AC3E}">
+        <p14:creationId xmlns:p14="http://schemas.microsoft.com/office/powerpoint/2010/main" val="918350328"/>
+      </p:ext>
+    </p:extLst>
+  </p:cSld>
+  <p:clrMapOvr>
+    <a:masterClrMapping/>
+  </p:clrMapOvr>
+</p:sld>
+</file>
+
+<file path=ppt/slides/slide46.xml><?xml version="1.0" encoding="utf-8"?>
+<p:sld xmlns:a="http://schemas.openxmlformats.org/drawingml/2006/main" xmlns:r="http://schemas.openxmlformats.org/officeDocument/2006/relationships" xmlns:p="http://schemas.openxmlformats.org/presentationml/2006/main">
+  <p:cSld>
+    <p:spTree>
+      <p:nvGrpSpPr>
+        <p:cNvPr id="1" name=""/>
+        <p:cNvGrpSpPr/>
+        <p:nvPr/>
+      </p:nvGrpSpPr>
+      <p:grpSpPr>
+        <a:xfrm>
+          <a:off x="0" y="0"/>
+          <a:ext cx="0" cy="0"/>
+          <a:chOff x="0" y="0"/>
+          <a:chExt cx="0" cy="0"/>
+        </a:xfrm>
+      </p:grpSpPr>
+      <p:sp>
+        <p:nvSpPr>
+          <p:cNvPr id="2" name="Title 1">
+            <a:extLst>
+              <a:ext uri="{FF2B5EF4-FFF2-40B4-BE49-F238E27FC236}">
+                <a16:creationId xmlns:a16="http://schemas.microsoft.com/office/drawing/2014/main" id="{745AB5F6-8402-21D1-FE7E-9E95F8EAEE7E}"/>
+              </a:ext>
+            </a:extLst>
+          </p:cNvPr>
+          <p:cNvSpPr>
+            <a:spLocks noGrp="1"/>
+          </p:cNvSpPr>
+          <p:nvPr>
+            <p:ph type="title"/>
+          </p:nvPr>
+        </p:nvSpPr>
+        <p:spPr/>
+        <p:txBody>
+          <a:bodyPr/>
+          <a:lstStyle/>
+          <a:p>
+            <a:r>
+              <a:rPr lang="en-US" dirty="0"/>
+              <a:t>For every data flow, ask “what could go wrong?”</a:t>
+            </a:r>
+          </a:p>
+        </p:txBody>
+      </p:sp>
+      <p:sp>
+        <p:nvSpPr>
+          <p:cNvPr id="3" name="Content Placeholder 2">
+            <a:extLst>
+              <a:ext uri="{FF2B5EF4-FFF2-40B4-BE49-F238E27FC236}">
+                <a16:creationId xmlns:a16="http://schemas.microsoft.com/office/drawing/2014/main" id="{6C92FEA4-7715-91F2-3909-2E533E189B16}"/>
+              </a:ext>
+            </a:extLst>
+          </p:cNvPr>
+          <p:cNvSpPr>
+            <a:spLocks noGrp="1"/>
+          </p:cNvSpPr>
+          <p:nvPr>
+            <p:ph idx="1"/>
+          </p:nvPr>
+        </p:nvSpPr>
+        <p:spPr>
+          <a:xfrm>
+            <a:off x="838200" y="1500159"/>
+            <a:ext cx="9623323" cy="4856191"/>
+          </a:xfrm>
+        </p:spPr>
+        <p:txBody>
+          <a:bodyPr>
+            <a:normAutofit fontScale="77500" lnSpcReduction="20000"/>
+          </a:bodyPr>
+          <a:lstStyle/>
+          <a:p>
+            <a:pPr lvl="0" fontAlgn="base"/>
+            <a:r>
+              <a:rPr lang="en-US" b="1" dirty="0"/>
+              <a:t>S</a:t>
+            </a:r>
+            <a:r>
+              <a:rPr lang="en-US" dirty="0"/>
+              <a:t>poofed identity: </a:t>
+            </a:r>
+            <a:r>
+              <a:rPr lang="en-US" i="1" dirty="0"/>
+              <a:t>Is there Authentication? Should there be?</a:t>
+            </a:r>
+            <a:r>
+              <a:rPr lang="en-US" dirty="0"/>
+              <a:t> - Attackers pretending to be legitimate users through stolen credentials, phishing, or social engineering.</a:t>
+            </a:r>
+          </a:p>
+          <a:p>
+            <a:pPr lvl="0" fontAlgn="base"/>
+            <a:r>
+              <a:rPr lang="en-US" b="1" dirty="0"/>
+              <a:t>T</a:t>
+            </a:r>
+            <a:r>
+              <a:rPr lang="en-US" dirty="0"/>
+              <a:t>ampering with input: </a:t>
+            </a:r>
+            <a:r>
+              <a:rPr lang="en-US" i="1" dirty="0"/>
+              <a:t>What about nasty input?</a:t>
+            </a:r>
+            <a:r>
+              <a:rPr lang="en-US" dirty="0"/>
+              <a:t> - Attackers modifying data, code, or memory maliciously to break your system's trust boundaries.</a:t>
+            </a:r>
+          </a:p>
+          <a:p>
+            <a:pPr lvl="0" fontAlgn="base"/>
+            <a:r>
+              <a:rPr lang="en-US" b="1" dirty="0"/>
+              <a:t>R</a:t>
+            </a:r>
+            <a:r>
+              <a:rPr lang="en-US" dirty="0"/>
+              <a:t>epudiation: </a:t>
+            </a:r>
+            <a:r>
+              <a:rPr lang="en-US" i="1" dirty="0"/>
+              <a:t>Does the system show who is accountable?</a:t>
+            </a:r>
+            <a:r>
+              <a:rPr lang="en-US" dirty="0"/>
+              <a:t> - When something goes wrong, can you prove which user performed an action, or could they plausibly deny responsibility due to insufficient audit trails?</a:t>
+            </a:r>
+          </a:p>
+          <a:p>
+            <a:pPr lvl="0" fontAlgn="base"/>
+            <a:r>
+              <a:rPr lang="en-US" b="1" dirty="0"/>
+              <a:t>I</a:t>
+            </a:r>
+            <a:r>
+              <a:rPr lang="en-US" dirty="0"/>
+              <a:t>nformation disclosure: </a:t>
+            </a:r>
+            <a:r>
+              <a:rPr lang="en-US" i="1" dirty="0"/>
+              <a:t>Is sensitive data inappropriately exposed or unencrypted?</a:t>
+            </a:r>
+            <a:r>
+              <a:rPr lang="en-US" dirty="0"/>
+              <a:t> - Unauthorized access to sensitive data through poor access controls, cleartext transmission, or insufficient data protection.</a:t>
+            </a:r>
+          </a:p>
+          <a:p>
+            <a:pPr lvl="0" fontAlgn="base"/>
+            <a:r>
+              <a:rPr lang="en-US" b="1" dirty="0"/>
+              <a:t>D</a:t>
+            </a:r>
+            <a:r>
+              <a:rPr lang="en-US" dirty="0"/>
+              <a:t>enial of service: </a:t>
+            </a:r>
+            <a:r>
+              <a:rPr lang="en-US" i="1" dirty="0"/>
+              <a:t>What if we smash it?</a:t>
+            </a:r>
+            <a:r>
+              <a:rPr lang="en-US" dirty="0"/>
+              <a:t> - Attacks aiming at making the system unavailable to legitimate users by flooding or breaking critical components.</a:t>
+            </a:r>
+          </a:p>
+          <a:p>
+            <a:pPr lvl="0" fontAlgn="base"/>
+            <a:r>
+              <a:rPr lang="en-US" b="1" dirty="0"/>
+              <a:t>E</a:t>
+            </a:r>
+            <a:r>
+              <a:rPr lang="en-US" dirty="0"/>
+              <a:t>levation of privilege: </a:t>
+            </a:r>
+            <a:r>
+              <a:rPr lang="en-US" i="1" dirty="0"/>
+              <a:t>Can I bypass Authorization? Move deeper into the system?</a:t>
+            </a:r>
+            <a:r>
+              <a:rPr lang="en-US" dirty="0"/>
+              <a:t> - Attackers gaining unauthorized access levels, obtaining higher permissions than intended, or moving laterally through your system.</a:t>
+            </a:r>
+          </a:p>
+        </p:txBody>
+      </p:sp>
+      <p:sp>
+        <p:nvSpPr>
+          <p:cNvPr id="4" name="Slide Number Placeholder 3">
+            <a:extLst>
+              <a:ext uri="{FF2B5EF4-FFF2-40B4-BE49-F238E27FC236}">
+                <a16:creationId xmlns:a16="http://schemas.microsoft.com/office/drawing/2014/main" id="{87AE9534-859F-71D2-5797-D58C842B6700}"/>
+              </a:ext>
+            </a:extLst>
+          </p:cNvPr>
+          <p:cNvSpPr>
+            <a:spLocks noGrp="1"/>
+          </p:cNvSpPr>
+          <p:nvPr>
+            <p:ph type="sldNum" sz="quarter" idx="12"/>
+          </p:nvPr>
+        </p:nvSpPr>
+        <p:spPr/>
+        <p:txBody>
+          <a:bodyPr/>
+          <a:lstStyle/>
+          <a:p>
+            <a:fld id="{20F37917-FD3A-4669-9018-DA04BCDD3D75}" type="slidenum">
+              <a:rPr lang="en-US" smtClean="0"/>
+              <a:t>46</a:t>
+            </a:fld>
+            <a:endParaRPr lang="en-US"/>
+          </a:p>
+        </p:txBody>
+      </p:sp>
+    </p:spTree>
+    <p:extLst>
+      <p:ext uri="{BB962C8B-B14F-4D97-AF65-F5344CB8AC3E}">
+        <p14:creationId xmlns:p14="http://schemas.microsoft.com/office/powerpoint/2010/main" val="2163532588"/>
+      </p:ext>
+    </p:extLst>
+  </p:cSld>
+  <p:clrMapOvr>
+    <a:masterClrMapping/>
+  </p:clrMapOvr>
+</p:sld>
+</file>
+
+<file path=ppt/slides/slide47.xml><?xml version="1.0" encoding="utf-8"?>
+<p:sld xmlns:a="http://schemas.openxmlformats.org/drawingml/2006/main" xmlns:r="http://schemas.openxmlformats.org/officeDocument/2006/relationships" xmlns:p="http://schemas.openxmlformats.org/presentationml/2006/main">
+  <p:cSld>
+    <p:spTree>
+      <p:nvGrpSpPr>
+        <p:cNvPr id="1" name="">
+          <a:extLst>
+            <a:ext uri="{FF2B5EF4-FFF2-40B4-BE49-F238E27FC236}">
+              <a16:creationId xmlns:a16="http://schemas.microsoft.com/office/drawing/2014/main" id="{513C269D-332D-7519-6CED-6E8C182E257D}"/>
+            </a:ext>
+          </a:extLst>
+        </p:cNvPr>
+        <p:cNvGrpSpPr/>
+        <p:nvPr/>
+      </p:nvGrpSpPr>
+      <p:grpSpPr>
+        <a:xfrm>
+          <a:off x="0" y="0"/>
+          <a:ext cx="0" cy="0"/>
+          <a:chOff x="0" y="0"/>
+          <a:chExt cx="0" cy="0"/>
+        </a:xfrm>
+      </p:grpSpPr>
+      <p:sp>
+        <p:nvSpPr>
+          <p:cNvPr id="2" name="Title 1">
+            <a:extLst>
+              <a:ext uri="{FF2B5EF4-FFF2-40B4-BE49-F238E27FC236}">
+                <a16:creationId xmlns:a16="http://schemas.microsoft.com/office/drawing/2014/main" id="{B974C6E5-8FE2-DF16-609E-9B7A086EBBD8}"/>
+              </a:ext>
+            </a:extLst>
+          </p:cNvPr>
+          <p:cNvSpPr>
+            <a:spLocks noGrp="1"/>
+          </p:cNvSpPr>
+          <p:nvPr>
+            <p:ph type="title"/>
+          </p:nvPr>
+        </p:nvSpPr>
+        <p:spPr/>
+        <p:txBody>
+          <a:bodyPr/>
+          <a:lstStyle/>
+          <a:p>
+            <a:r>
+              <a:rPr lang="en-US" dirty="0"/>
+              <a:t>What are you going to do?</a:t>
+            </a:r>
+          </a:p>
+        </p:txBody>
+      </p:sp>
+      <p:sp>
+        <p:nvSpPr>
+          <p:cNvPr id="3" name="Content Placeholder 2">
+            <a:extLst>
+              <a:ext uri="{FF2B5EF4-FFF2-40B4-BE49-F238E27FC236}">
+                <a16:creationId xmlns:a16="http://schemas.microsoft.com/office/drawing/2014/main" id="{64D9733F-E10E-307D-2EA6-7F4520ABB642}"/>
+              </a:ext>
+            </a:extLst>
+          </p:cNvPr>
+          <p:cNvSpPr>
+            <a:spLocks noGrp="1"/>
+          </p:cNvSpPr>
+          <p:nvPr>
+            <p:ph idx="1"/>
+          </p:nvPr>
+        </p:nvSpPr>
+        <p:spPr>
+          <a:xfrm>
+            <a:off x="838200" y="1740310"/>
+            <a:ext cx="9197898" cy="4111188"/>
           </a:xfrm>
         </p:spPr>
         <p:txBody>
@@ -22324,6 +23517,13 @@
             <a:r>
               <a:rPr lang="en-US" dirty="0"/>
               <a:t>Prioritize and Fix</a:t>
+            </a:r>
+          </a:p>
+          <a:p>
+            <a:pPr lvl="1"/>
+            <a:r>
+              <a:rPr lang="en-US" dirty="0"/>
+              <a:t>Choose highest priority vulnerabilities</a:t>
             </a:r>
           </a:p>
           <a:p>
@@ -22416,7 +23616,7 @@
           <a:p>
             <a:fld id="{20F37917-FD3A-4669-9018-DA04BCDD3D75}" type="slidenum">
               <a:rPr lang="en-US" smtClean="0"/>
-              <a:t>45</a:t>
+              <a:t>47</a:t>
             </a:fld>
             <a:endParaRPr lang="en-US" dirty="0"/>
           </a:p>
@@ -22436,7 +23636,7 @@
         </p:nvSpPr>
         <p:spPr>
           <a:xfrm>
-            <a:off x="1159727" y="5734592"/>
+            <a:off x="1149895" y="5919258"/>
             <a:ext cx="10370634" cy="369332"/>
           </a:xfrm>
           <a:prstGeom prst="rect">
@@ -22531,6 +23731,99 @@
           </a:p>
         </p:txBody>
       </p:sp>
+      <p:sp>
+        <p:nvSpPr>
+          <p:cNvPr id="6" name="TextBox 5">
+            <a:extLst>
+              <a:ext uri="{FF2B5EF4-FFF2-40B4-BE49-F238E27FC236}">
+                <a16:creationId xmlns:a16="http://schemas.microsoft.com/office/drawing/2014/main" id="{3B6FD6EC-3679-57B4-0277-D2955983F48A}"/>
+              </a:ext>
+            </a:extLst>
+          </p:cNvPr>
+          <p:cNvSpPr txBox="1"/>
+          <p:nvPr/>
+        </p:nvSpPr>
+        <p:spPr>
+          <a:xfrm>
+            <a:off x="7975236" y="189656"/>
+            <a:ext cx="4121724" cy="2308324"/>
+          </a:xfrm>
+          <a:prstGeom prst="rect">
+            <a:avLst/>
+          </a:prstGeom>
+          <a:noFill/>
+        </p:spPr>
+        <p:txBody>
+          <a:bodyPr wrap="square" rtlCol="0">
+            <a:spAutoFit/>
+          </a:bodyPr>
+          <a:lstStyle/>
+          <a:p>
+            <a:r>
+              <a:rPr lang="en-US" sz="1600" b="1" dirty="0">
+                <a:latin typeface="Bradley Hand ITC" panose="03070402050302030203" pitchFamily="66" charset="77"/>
+              </a:rPr>
+              <a:t>Given the user is logged in </a:t>
+            </a:r>
+            <a:br>
+              <a:rPr lang="en-US" sz="1600" b="1" dirty="0">
+                <a:latin typeface="Bradley Hand ITC" panose="03070402050302030203" pitchFamily="66" charset="77"/>
+              </a:rPr>
+            </a:br>
+            <a:r>
+              <a:rPr lang="en-US" sz="1600" b="1" dirty="0">
+                <a:latin typeface="Bradley Hand ITC" panose="03070402050302030203" pitchFamily="66" charset="77"/>
+              </a:rPr>
+              <a:t>When they request to view their profile page And they have a valid token</a:t>
+            </a:r>
+          </a:p>
+          <a:p>
+            <a:r>
+              <a:rPr lang="en-US" sz="1600" b="1" dirty="0">
+                <a:latin typeface="Bradley Hand ITC" panose="03070402050302030203" pitchFamily="66" charset="77"/>
+              </a:rPr>
+              <a:t>Then their profile page is displayed  </a:t>
+            </a:r>
+          </a:p>
+          <a:p>
+            <a:endParaRPr lang="en-US" sz="1600" b="1" dirty="0">
+              <a:latin typeface="Bradley Hand ITC" panose="03070402050302030203" pitchFamily="66" charset="77"/>
+            </a:endParaRPr>
+          </a:p>
+          <a:p>
+            <a:r>
+              <a:rPr lang="en-US" sz="1600" b="1" dirty="0">
+                <a:latin typeface="Bradley Hand ITC" panose="03070402050302030203" pitchFamily="66" charset="77"/>
+              </a:rPr>
+              <a:t>Given the user is logged in</a:t>
+            </a:r>
+          </a:p>
+          <a:p>
+            <a:r>
+              <a:rPr lang="en-US" sz="1600" b="1" dirty="0">
+                <a:latin typeface="Bradley Hand ITC" panose="03070402050302030203" pitchFamily="66" charset="77"/>
+              </a:rPr>
+              <a:t>When they request to view their profile page</a:t>
+            </a:r>
+          </a:p>
+          <a:p>
+            <a:r>
+              <a:rPr lang="en-US" sz="1600" b="1" dirty="0">
+                <a:latin typeface="Bradley Hand ITC" panose="03070402050302030203" pitchFamily="66" charset="77"/>
+              </a:rPr>
+              <a:t>But they do not have a valid token</a:t>
+            </a:r>
+          </a:p>
+          <a:p>
+            <a:r>
+              <a:rPr lang="en-US" sz="1600" b="1" dirty="0">
+                <a:latin typeface="Bradley Hand ITC" panose="03070402050302030203" pitchFamily="66" charset="77"/>
+              </a:rPr>
+              <a:t>Then they are asked to login or signup  </a:t>
+            </a:r>
+          </a:p>
+        </p:txBody>
+      </p:sp>
     </p:spTree>
     <p:extLst>
       <p:ext uri="{BB962C8B-B14F-4D97-AF65-F5344CB8AC3E}">
@@ -22544,7 +23837,7 @@
 </p:sld>
 </file>
 
-<file path=ppt/slides/slide46.xml><?xml version="1.0" encoding="utf-8"?>
+<file path=ppt/slides/slide48.xml><?xml version="1.0" encoding="utf-8"?>
 <p:sld xmlns:a="http://schemas.openxmlformats.org/drawingml/2006/main" xmlns:r="http://schemas.openxmlformats.org/officeDocument/2006/relationships" xmlns:p="http://schemas.openxmlformats.org/presentationml/2006/main">
   <p:cSld>
     <p:spTree>

</xml_diff>